<commit_message>
Complete verified step visuals and guides for Lab 08
</commit_message>
<xml_diff>
--- a/slides/LAB08_Cloud_Notes_Nextjs_Bukti_Live.pptx
+++ b/slides/LAB08_Cloud_Notes_Nextjs_Bukti_Live.pptx
@@ -11,15 +11,22 @@
     <p:sldId id="288" r:id="rId2"/>
     <p:sldId id="289" r:id="rId3"/>
     <p:sldId id="290" r:id="rId4"/>
+    <p:sldId id="300" r:id="rId19"/>
     <p:sldId id="291" r:id="rId5"/>
+    <p:sldId id="301" r:id="rId20"/>
     <p:sldId id="292" r:id="rId6"/>
     <p:sldId id="293" r:id="rId7"/>
     <p:sldId id="294" r:id="rId8"/>
+    <p:sldId id="302" r:id="rId21"/>
     <p:sldId id="295" r:id="rId9"/>
     <p:sldId id="296" r:id="rId10"/>
+    <p:sldId id="303" r:id="rId22"/>
     <p:sldId id="297" r:id="rId11"/>
+    <p:sldId id="304" r:id="rId23"/>
+    <p:sldId id="305" r:id="rId24"/>
     <p:sldId id="298" r:id="rId12"/>
     <p:sldId id="299" r:id="rId13"/>
+    <p:sldId id="306" r:id="rId25"/>
   </p:sldIdLst>
   <p:sldSz cx="12192000" cy="6858000"/>
   <p:notesSz cx="6858000" cy="9144000"/>
@@ -491,7 +498,9 @@
           <a:bodyPr/>
           <a:lstStyle/>
           <a:p>
-            <a:endParaRPr/>
+            <a:r>
+              <a:t>Perintah: npm run typecheck; npm run build. Fungsi: verifikasi tipe dan bundel produksi. Cara kerja: tsc memeriksa TypeScript, Next menyusun App Router. Hasil: keduanya exit 0; /api/ready tercantum. Screenshot ringkas berasal dari output aktual screenshots/21_build_aktual.txt.</a:t>
+            </a:r>
           </a:p>
         </p:txBody>
       </p:sp>
@@ -588,6 +597,496 @@
             <a:endParaRPr/>
           </a:p>
         </p:txBody>
+      </p:sp>
+    </p:spTree>
+  </p:cSld>
+  <p:clrMapOvr>
+    <a:masterClrMapping/>
+  </p:clrMapOvr>
+</p:notes>
+</file>
+
+<file path=ppt/notesSlides/notesSlide13.xml><?xml version="1.0" encoding="utf-8"?>
+<p:notes xmlns:a="http://schemas.openxmlformats.org/drawingml/2006/main" xmlns:p="http://schemas.openxmlformats.org/presentationml/2006/main" xmlns:r="http://schemas.openxmlformats.org/officeDocument/2006/relationships">
+  <p:cSld>
+    <p:spTree>
+      <p:nvGrpSpPr>
+        <p:cNvPr id="1" name=""/>
+        <p:cNvGrpSpPr/>
+        <p:nvPr/>
+      </p:nvGrpSpPr>
+      <p:grpSpPr>
+        <a:xfrm>
+          <a:off x="0" y="0"/>
+          <a:ext cx="0" cy="0"/>
+          <a:chOff x="0" y="0"/>
+          <a:chExt cx="0" cy="0"/>
+        </a:xfrm>
+      </p:grpSpPr>
+      <p:sp>
+        <p:nvSpPr>
+          <p:cNvPr id="2" name="Slide Image Placeholder 1"/>
+          <p:cNvSpPr>
+            <a:spLocks noGrp="1"/>
+          </p:cNvSpPr>
+          <p:nvPr>
+            <p:ph type="sldImg" idx="2"/>
+          </p:nvPr>
+        </p:nvSpPr>
+        <p:spPr/>
+      </p:sp>
+      <p:sp>
+        <p:nvSpPr>
+          <p:cNvPr id="3" name="Notes Placeholder 2"/>
+          <p:cNvSpPr>
+            <a:spLocks noGrp="1"/>
+          </p:cNvSpPr>
+          <p:nvPr>
+            <p:ph type="body" idx="3" sz="quarter"/>
+          </p:nvPr>
+        </p:nvSpPr>
+        <p:spPr/>
+        <p:txBody>
+          <a:bodyPr/>
+          <a:lstStyle/>
+          <a:p>
+            <a:r>
+              <a:t>Command: npm ci. Fungsi: memasang paket dari package-lock.json. Cara kerja: npm membangun ulang node_modules. Hasil: 37 paket, 0 vulnerability, exit 0. Output lengkap screenshots/13_npm_ci.txt.</a:t>
+            </a:r>
+          </a:p>
+        </p:txBody>
+      </p:sp>
+      <p:sp>
+        <p:nvSpPr>
+          <p:cNvPr id="4" name="Slide Number Placeholder 3"/>
+          <p:cNvSpPr>
+            <a:spLocks noGrp="1"/>
+          </p:cNvSpPr>
+          <p:nvPr>
+            <p:ph type="sldNum" idx="5" sz="quarter"/>
+          </p:nvPr>
+        </p:nvSpPr>
+        <p:spPr/>
+      </p:sp>
+    </p:spTree>
+  </p:cSld>
+  <p:clrMapOvr>
+    <a:masterClrMapping/>
+  </p:clrMapOvr>
+</p:notes>
+</file>
+
+<file path=ppt/notesSlides/notesSlide14.xml><?xml version="1.0" encoding="utf-8"?>
+<p:notes xmlns:a="http://schemas.openxmlformats.org/drawingml/2006/main" xmlns:p="http://schemas.openxmlformats.org/presentationml/2006/main" xmlns:r="http://schemas.openxmlformats.org/officeDocument/2006/relationships">
+  <p:cSld>
+    <p:spTree>
+      <p:nvGrpSpPr>
+        <p:cNvPr id="1" name=""/>
+        <p:cNvGrpSpPr/>
+        <p:nvPr/>
+      </p:nvGrpSpPr>
+      <p:grpSpPr>
+        <a:xfrm>
+          <a:off x="0" y="0"/>
+          <a:ext cx="0" cy="0"/>
+          <a:chOff x="0" y="0"/>
+          <a:chExt cx="0" cy="0"/>
+        </a:xfrm>
+      </p:grpSpPr>
+      <p:sp>
+        <p:nvSpPr>
+          <p:cNvPr id="2" name="Slide Image Placeholder 1"/>
+          <p:cNvSpPr>
+            <a:spLocks noGrp="1"/>
+          </p:cNvSpPr>
+          <p:nvPr>
+            <p:ph type="sldImg" idx="2"/>
+          </p:nvPr>
+        </p:nvSpPr>
+        <p:spPr/>
+      </p:sp>
+      <p:sp>
+        <p:nvSpPr>
+          <p:cNvPr id="3" name="Notes Placeholder 2"/>
+          <p:cNvSpPr>
+            <a:spLocks noGrp="1"/>
+          </p:cNvSpPr>
+          <p:nvPr>
+            <p:ph type="body" idx="3" sz="quarter"/>
+          </p:nvPr>
+        </p:nvSpPr>
+        <p:spPr/>
+        <p:txBody>
+          <a:bodyPr/>
+          <a:lstStyle/>
+          <a:p>
+            <a:r>
+              <a:t>Command: rg -n 'use client|fetch|LOCAL_API_URL|export async function' src/app/page.tsx src/app/api/notes/route.ts. Fungsi: menelusuri kode. Cara kerja: rg membaca source. Hasil: halaman adalah Client Component, Route Handler memegang URL API privat. Output lengkap screenshots/15_source_tour.txt.</a:t>
+            </a:r>
+          </a:p>
+        </p:txBody>
+      </p:sp>
+      <p:sp>
+        <p:nvSpPr>
+          <p:cNvPr id="4" name="Slide Number Placeholder 3"/>
+          <p:cNvSpPr>
+            <a:spLocks noGrp="1"/>
+          </p:cNvSpPr>
+          <p:nvPr>
+            <p:ph type="sldNum" idx="5" sz="quarter"/>
+          </p:nvPr>
+        </p:nvSpPr>
+        <p:spPr/>
+      </p:sp>
+    </p:spTree>
+  </p:cSld>
+  <p:clrMapOvr>
+    <a:masterClrMapping/>
+  </p:clrMapOvr>
+</p:notes>
+</file>
+
+<file path=ppt/notesSlides/notesSlide15.xml><?xml version="1.0" encoding="utf-8"?>
+<p:notes xmlns:a="http://schemas.openxmlformats.org/drawingml/2006/main" xmlns:p="http://schemas.openxmlformats.org/presentationml/2006/main" xmlns:r="http://schemas.openxmlformats.org/officeDocument/2006/relationships">
+  <p:cSld>
+    <p:spTree>
+      <p:nvGrpSpPr>
+        <p:cNvPr id="1" name=""/>
+        <p:cNvGrpSpPr/>
+        <p:nvPr/>
+      </p:nvGrpSpPr>
+      <p:grpSpPr>
+        <a:xfrm>
+          <a:off x="0" y="0"/>
+          <a:ext cx="0" cy="0"/>
+          <a:chOff x="0" y="0"/>
+          <a:chExt cx="0" cy="0"/>
+        </a:xfrm>
+      </p:grpSpPr>
+      <p:sp>
+        <p:nvSpPr>
+          <p:cNvPr id="2" name="Slide Image Placeholder 1"/>
+          <p:cNvSpPr>
+            <a:spLocks noGrp="1"/>
+          </p:cNvSpPr>
+          <p:nvPr>
+            <p:ph type="sldImg" idx="2"/>
+          </p:nvPr>
+        </p:nvSpPr>
+        <p:spPr/>
+      </p:sp>
+      <p:sp>
+        <p:nvSpPr>
+          <p:cNvPr id="3" name="Notes Placeholder 2"/>
+          <p:cNvSpPr>
+            <a:spLocks noGrp="1"/>
+          </p:cNvSpPr>
+          <p:nvPr>
+            <p:ph type="body" idx="3" sz="quarter"/>
+          </p:nvPr>
+        </p:nvSpPr>
+        <p:spPr/>
+        <p:txBody>
+          <a:bodyPr/>
+          <a:lstStyle/>
+          <a:p>
+            <a:r>
+              <a:t>Command: docker compose stop api; probe /api/health, /api/ready, /api/notes; docker compose start api; probe lagi. Fungsi: membedakan liveness dan readiness serta memastikan data pulih. Cara kerja: Next tetap hidup ketika API mati; PostgreSQL tidak dihentikan. Hasil: outage 200/503/503, pulih 200/200 dan catatan lama ditemukan. Output lengkap screenshots/18_outage_probe.txt dan 19_pemulihan.txt.</a:t>
+            </a:r>
+          </a:p>
+        </p:txBody>
+      </p:sp>
+      <p:sp>
+        <p:nvSpPr>
+          <p:cNvPr id="4" name="Slide Number Placeholder 3"/>
+          <p:cNvSpPr>
+            <a:spLocks noGrp="1"/>
+          </p:cNvSpPr>
+          <p:nvPr>
+            <p:ph type="sldNum" idx="5" sz="quarter"/>
+          </p:nvPr>
+        </p:nvSpPr>
+        <p:spPr/>
+      </p:sp>
+    </p:spTree>
+  </p:cSld>
+  <p:clrMapOvr>
+    <a:masterClrMapping/>
+  </p:clrMapOvr>
+</p:notes>
+</file>
+
+<file path=ppt/notesSlides/notesSlide16.xml><?xml version="1.0" encoding="utf-8"?>
+<p:notes xmlns:a="http://schemas.openxmlformats.org/drawingml/2006/main" xmlns:p="http://schemas.openxmlformats.org/presentationml/2006/main" xmlns:r="http://schemas.openxmlformats.org/officeDocument/2006/relationships">
+  <p:cSld>
+    <p:spTree>
+      <p:nvGrpSpPr>
+        <p:cNvPr id="1" name=""/>
+        <p:cNvGrpSpPr/>
+        <p:nvPr/>
+      </p:nvGrpSpPr>
+      <p:grpSpPr>
+        <a:xfrm>
+          <a:off x="0" y="0"/>
+          <a:ext cx="0" cy="0"/>
+          <a:chOff x="0" y="0"/>
+          <a:chExt cx="0" cy="0"/>
+        </a:xfrm>
+      </p:grpSpPr>
+      <p:sp>
+        <p:nvSpPr>
+          <p:cNvPr id="2" name="Slide Image Placeholder 1"/>
+          <p:cNvSpPr>
+            <a:spLocks noGrp="1"/>
+          </p:cNvSpPr>
+          <p:nvPr>
+            <p:ph type="sldImg" idx="2"/>
+          </p:nvPr>
+        </p:nvSpPr>
+        <p:spPr/>
+      </p:sp>
+      <p:sp>
+        <p:nvSpPr>
+          <p:cNvPr id="3" name="Notes Placeholder 2"/>
+          <p:cNvSpPr>
+            <a:spLocks noGrp="1"/>
+          </p:cNvSpPr>
+          <p:nvPr>
+            <p:ph type="body" idx="3" sz="quarter"/>
+          </p:nvPr>
+        </p:nvSpPr>
+        <p:spPr/>
+        <p:txBody>
+          <a:bodyPr/>
+          <a:lstStyle/>
+          <a:p>
+            <a:r>
+              <a:t>Command: Invoke-WebRequest POST /api/notes dengan title/content, lalu GET /api/notes. Fungsi: membuktikan tulis/baca dan korelasi log. Cara kerja: Next meneruskan ke API Lab 06; PostgreSQL menyimpan. Hasil: HTTP 201, header X-Request-ID, GET 200. ID cocok dengan event notes_proxy di terminal Next. Output lengkap screenshots/16_post_request_id.txt.</a:t>
+            </a:r>
+          </a:p>
+        </p:txBody>
+      </p:sp>
+      <p:sp>
+        <p:nvSpPr>
+          <p:cNvPr id="4" name="Slide Number Placeholder 3"/>
+          <p:cNvSpPr>
+            <a:spLocks noGrp="1"/>
+          </p:cNvSpPr>
+          <p:nvPr>
+            <p:ph type="sldNum" idx="5" sz="quarter"/>
+          </p:nvPr>
+        </p:nvSpPr>
+        <p:spPr/>
+      </p:sp>
+    </p:spTree>
+  </p:cSld>
+  <p:clrMapOvr>
+    <a:masterClrMapping/>
+  </p:clrMapOvr>
+</p:notes>
+</file>
+
+<file path=ppt/notesSlides/notesSlide17.xml><?xml version="1.0" encoding="utf-8"?>
+<p:notes xmlns:a="http://schemas.openxmlformats.org/drawingml/2006/main" xmlns:p="http://schemas.openxmlformats.org/presentationml/2006/main" xmlns:r="http://schemas.openxmlformats.org/officeDocument/2006/relationships">
+  <p:cSld>
+    <p:spTree>
+      <p:nvGrpSpPr>
+        <p:cNvPr id="1" name=""/>
+        <p:cNvGrpSpPr/>
+        <p:nvPr/>
+      </p:nvGrpSpPr>
+      <p:grpSpPr>
+        <a:xfrm>
+          <a:off x="0" y="0"/>
+          <a:ext cx="0" cy="0"/>
+          <a:chOff x="0" y="0"/>
+          <a:chExt cx="0" cy="0"/>
+        </a:xfrm>
+      </p:grpSpPr>
+      <p:sp>
+        <p:nvSpPr>
+          <p:cNvPr id="2" name="Slide Image Placeholder 1"/>
+          <p:cNvSpPr>
+            <a:spLocks noGrp="1"/>
+          </p:cNvSpPr>
+          <p:nvPr>
+            <p:ph type="sldImg" idx="2"/>
+          </p:nvPr>
+        </p:nvSpPr>
+        <p:spPr/>
+      </p:sp>
+      <p:sp>
+        <p:nvSpPr>
+          <p:cNvPr id="3" name="Notes Placeholder 2"/>
+          <p:cNvSpPr>
+            <a:spLocks noGrp="1"/>
+          </p:cNvSpPr>
+          <p:nvPr>
+            <p:ph type="body" idx="3" sz="quarter"/>
+          </p:nvPr>
+        </p:nvSpPr>
+        <p:spPr/>
+        <p:txBody>
+          <a:bodyPr/>
+          <a:lstStyle/>
+          <a:p>
+            <a:r>
+              <a:t>Command: dua POST /api/notes dengan payload tidak valid. Fungsi: memisahkan kesalahan pengguna dari outage. Cara kerja: Route Handler memvalidasi sebelum proxy. Hasil: HTTP 400 dengan pesan judul wajib dan JSON tidak valid. Output lengkap screenshots/17_validasi_aktual.txt.</a:t>
+            </a:r>
+          </a:p>
+        </p:txBody>
+      </p:sp>
+      <p:sp>
+        <p:nvSpPr>
+          <p:cNvPr id="4" name="Slide Number Placeholder 3"/>
+          <p:cNvSpPr>
+            <a:spLocks noGrp="1"/>
+          </p:cNvSpPr>
+          <p:nvPr>
+            <p:ph type="sldNum" idx="5" sz="quarter"/>
+          </p:nvPr>
+        </p:nvSpPr>
+        <p:spPr/>
+      </p:sp>
+    </p:spTree>
+  </p:cSld>
+  <p:clrMapOvr>
+    <a:masterClrMapping/>
+  </p:clrMapOvr>
+</p:notes>
+</file>
+
+<file path=ppt/notesSlides/notesSlide18.xml><?xml version="1.0" encoding="utf-8"?>
+<p:notes xmlns:a="http://schemas.openxmlformats.org/drawingml/2006/main" xmlns:p="http://schemas.openxmlformats.org/presentationml/2006/main" xmlns:r="http://schemas.openxmlformats.org/officeDocument/2006/relationships">
+  <p:cSld>
+    <p:spTree>
+      <p:nvGrpSpPr>
+        <p:cNvPr id="1" name=""/>
+        <p:cNvGrpSpPr/>
+        <p:nvPr/>
+      </p:nvGrpSpPr>
+      <p:grpSpPr>
+        <a:xfrm>
+          <a:off x="0" y="0"/>
+          <a:ext cx="0" cy="0"/>
+          <a:chOff x="0" y="0"/>
+          <a:chExt cx="0" cy="0"/>
+        </a:xfrm>
+      </p:grpSpPr>
+      <p:sp>
+        <p:nvSpPr>
+          <p:cNvPr id="2" name="Slide Image Placeholder 1"/>
+          <p:cNvSpPr>
+            <a:spLocks noGrp="1"/>
+          </p:cNvSpPr>
+          <p:nvPr>
+            <p:ph type="sldImg" idx="2"/>
+          </p:nvPr>
+        </p:nvSpPr>
+        <p:spPr/>
+      </p:sp>
+      <p:sp>
+        <p:nvSpPr>
+          <p:cNvPr id="3" name="Notes Placeholder 2"/>
+          <p:cNvSpPr>
+            <a:spLocks noGrp="1"/>
+          </p:cNvSpPr>
+          <p:nvPr>
+            <p:ph type="body" idx="3" sz="quarter"/>
+          </p:nvPr>
+        </p:nvSpPr>
+        <p:spPr/>
+        <p:txBody>
+          <a:bodyPr/>
+          <a:lstStyle/>
+          <a:p>
+            <a:r>
+              <a:t>Command: npm run check:local. Fungsi: menguji liveness, readiness, validasi, POST, GET, dan header request ID. Cara kerja: tests/challenge.mjs memanggil Next dan menyimpan catatan uji. Hasil: 9 PASS, 0 FAIL. Ini output aktual yang ditata ulang.</a:t>
+            </a:r>
+          </a:p>
+        </p:txBody>
+      </p:sp>
+      <p:sp>
+        <p:nvSpPr>
+          <p:cNvPr id="4" name="Slide Number Placeholder 3"/>
+          <p:cNvSpPr>
+            <a:spLocks noGrp="1"/>
+          </p:cNvSpPr>
+          <p:nvPr>
+            <p:ph type="sldNum" idx="5" sz="quarter"/>
+          </p:nvPr>
+        </p:nvSpPr>
+        <p:spPr/>
+      </p:sp>
+    </p:spTree>
+  </p:cSld>
+  <p:clrMapOvr>
+    <a:masterClrMapping/>
+  </p:clrMapOvr>
+</p:notes>
+</file>
+
+<file path=ppt/notesSlides/notesSlide19.xml><?xml version="1.0" encoding="utf-8"?>
+<p:notes xmlns:a="http://schemas.openxmlformats.org/drawingml/2006/main" xmlns:p="http://schemas.openxmlformats.org/presentationml/2006/main" xmlns:r="http://schemas.openxmlformats.org/officeDocument/2006/relationships">
+  <p:cSld>
+    <p:spTree>
+      <p:nvGrpSpPr>
+        <p:cNvPr id="1" name=""/>
+        <p:cNvGrpSpPr/>
+        <p:nvPr/>
+      </p:nvGrpSpPr>
+      <p:grpSpPr>
+        <a:xfrm>
+          <a:off x="0" y="0"/>
+          <a:ext cx="0" cy="0"/>
+          <a:chOff x="0" y="0"/>
+          <a:chExt cx="0" cy="0"/>
+        </a:xfrm>
+      </p:grpSpPr>
+      <p:sp>
+        <p:nvSpPr>
+          <p:cNvPr id="2" name="Slide Image Placeholder 1"/>
+          <p:cNvSpPr>
+            <a:spLocks noGrp="1"/>
+          </p:cNvSpPr>
+          <p:nvPr>
+            <p:ph type="sldImg" idx="2"/>
+          </p:nvPr>
+        </p:nvSpPr>
+        <p:spPr/>
+      </p:sp>
+      <p:sp>
+        <p:nvSpPr>
+          <p:cNvPr id="3" name="Notes Placeholder 2"/>
+          <p:cNvSpPr>
+            <a:spLocks noGrp="1"/>
+          </p:cNvSpPr>
+          <p:nvPr>
+            <p:ph type="body" idx="3" sz="quarter"/>
+          </p:nvPr>
+        </p:nvSpPr>
+        <p:spPr/>
+        <p:txBody>
+          <a:bodyPr/>
+          <a:lstStyle/>
+          <a:p>
+            <a:r>
+              <a:t>Command: git status --short; git check-ignore -v .env.local node_modules .next; git diff --cached --check. Fungsi: mencegah secret dan hasil build ikut commit. Cara kerja: .gitignore menyaring tiga path. Hasil: ketiganya diabaikan; contoh belum membuktikan push mahasiswa. Output lengkap screenshots/20_git_aman.txt.</a:t>
+            </a:r>
+          </a:p>
+        </p:txBody>
+      </p:sp>
+      <p:sp>
+        <p:nvSpPr>
+          <p:cNvPr id="4" name="Slide Number Placeholder 3"/>
+          <p:cNvSpPr>
+            <a:spLocks noGrp="1"/>
+          </p:cNvSpPr>
+          <p:nvPr>
+            <p:ph type="sldNum" idx="5" sz="quarter"/>
+          </p:nvPr>
+        </p:nvSpPr>
+        <p:spPr/>
       </p:sp>
     </p:spTree>
   </p:cSld>
@@ -2073,7 +2572,7 @@
                 <a:ea typeface="Calibri"/>
                 <a:cs typeface="Calibri"/>
               </a:rPr>
-              <a:t>10</a:t>
+              <a:t>14</a:t>
             </a:r>
             <a:endParaRPr sz="900"/>
           </a:p>
@@ -2949,7 +3448,7 @@
                 <a:ea typeface="Calibri"/>
                 <a:cs typeface="Calibri"/>
               </a:rPr>
-              <a:t>11</a:t>
+              <a:t>17</a:t>
             </a:r>
             <a:endParaRPr sz="900"/>
           </a:p>
@@ -3153,7 +3652,7 @@
                 <a:ea typeface="Calibri"/>
                 <a:cs typeface="Calibri"/>
               </a:rPr>
-              <a:t>Output build lokal; ulangi setelah perubahan route terbaru</a:t>
+              <a:t>Output terbaru: route /api/ready sudah ikut dibangun</a:t>
             </a:r>
             <a:endParaRPr sz="1200"/>
           </a:p>
@@ -3452,7 +3951,7 @@
                 <a:ea typeface="Calibri"/>
                 <a:cs typeface="Calibri"/>
               </a:rPr>
-              <a:t>Screenshot menunjukkan build sebelumnya.</a:t>
+              <a:t>Screenshot berasal dari build terbaru.</a:t>
             </a:r>
             <a:endParaRPr sz="1400">
               <a:solidFill>
@@ -3527,7 +4026,7 @@
                 <a:ea typeface="Calibri"/>
                 <a:cs typeface="Calibri"/>
               </a:rPr>
-              <a:t>Pada kode kini /api/ready juga ada.</a:t>
+              <a:t>Daftar route memuat /api/ready.</a:t>
             </a:r>
             <a:endParaRPr sz="1400">
               <a:solidFill>
@@ -3602,7 +4101,7 @@
                 <a:ea typeface="Calibri"/>
                 <a:cs typeface="Calibri"/>
               </a:rPr>
-              <a:t>Jalankan ulang build setelah perubahan.</a:t>
+              <a:t>Typecheck dan build keluar dengan kode 0.</a:t>
             </a:r>
             <a:endParaRPr sz="1400">
               <a:solidFill>
@@ -3953,7 +4452,7 @@
                 <a:ea typeface="Calibri"/>
                 <a:cs typeface="Calibri"/>
               </a:rPr>
-              <a:t>Screenshot membuktikan typecheck/build pada versi awal.</a:t>
+              <a:t>Typecheck dan build lulus pada source terkini.</a:t>
             </a:r>
             <a:endParaRPr sz="1500">
               <a:solidFill>
@@ -3966,34 +4465,22 @@
       </p:sp>
       <p:pic>
         <p:nvPicPr>
-          <p:cNvPr id="6" name="Picture 5">
-            <a:extLst>
-              <a:ext uri="{FF2B5EF4-FFF2-40B4-BE49-F238E27FC236}">
-                <a16:creationId xmlns:a16="http://schemas.microsoft.com/office/drawing/2014/main" id="{559D640C-8338-6CF3-395D-09752CF7DEBF}"/>
-              </a:ext>
-            </a:extLst>
-          </p:cNvPr>
+          <p:cNvPr id="63" name="Picture 62" descr="21_build_ringkas_ppt.png"/>
           <p:cNvPicPr>
-            <a:picLocks/>
+            <a:picLocks noChangeAspect="1"/>
           </p:cNvPicPr>
           <p:nvPr/>
         </p:nvPicPr>
         <p:blipFill>
-          <a:blip r:embed="rId12">
-            <a:extLst>
-              <a:ext uri="{28A0092B-C50C-407E-A947-70E740481C1C}">
-                <a14:useLocalDpi xmlns:a14="http://schemas.microsoft.com/office/drawing/2010/main" val="0"/>
-              </a:ext>
-            </a:extLst>
-          </a:blip>
+          <a:blip r:embed="rId13"/>
           <a:stretch>
             <a:fillRect/>
           </a:stretch>
         </p:blipFill>
         <p:spPr>
           <a:xfrm>
-            <a:off x="6566134" y="2057400"/>
-            <a:ext cx="4789971" cy="3090672"/>
+            <a:off x="6566134" y="2623248"/>
+            <a:ext cx="4789971" cy="1958975"/>
           </a:xfrm>
           <a:prstGeom prst="rect">
             <a:avLst/>
@@ -4124,7 +4611,7 @@
                 <a:ea typeface="Calibri"/>
                 <a:cs typeface="Calibri"/>
               </a:rPr>
-              <a:t>12</a:t>
+              <a:t>18</a:t>
             </a:r>
             <a:endParaRPr sz="900"/>
           </a:p>
@@ -4881,6 +5368,2652 @@
         <p14:creationId xmlns:p14="http://schemas.microsoft.com/office/powerpoint/2010/main" val="3373960594"/>
       </p:ext>
     </p:extLst>
+  </p:cSld>
+  <p:clrMapOvr>
+    <a:masterClrMapping/>
+  </p:clrMapOvr>
+</p:sld>
+</file>
+
+<file path=ppt/slides/slide13.xml><?xml version="1.0" encoding="utf-8"?>
+<p:sld xmlns:a="http://schemas.openxmlformats.org/drawingml/2006/main" xmlns:p="http://schemas.openxmlformats.org/presentationml/2006/main" xmlns:r="http://schemas.openxmlformats.org/officeDocument/2006/relationships">
+  <p:cSld>
+    <p:spTree>
+      <p:nvGrpSpPr>
+        <p:cNvPr id="1" name=""/>
+        <p:cNvGrpSpPr/>
+        <p:nvPr/>
+      </p:nvGrpSpPr>
+      <p:grpSpPr/>
+      <p:sp>
+        <p:nvSpPr>
+          <p:cNvPr id="2" name="Text 0">
+            <a:extLst>
+              <a:ext uri="{FF2B5EF4-FFF2-40B4-BE49-F238E27FC236}">
+                <a16:creationId xmlns:a16="http://schemas.microsoft.com/office/drawing/2014/main" id="{0B86DC9D-6623-4169-8C9C-3145D037D6C7}"/>
+              </a:ext>
+            </a:extLst>
+          </p:cNvPr>
+          <p:cNvSpPr>
+            <a:spLocks noGrp="1"/>
+          </p:cNvSpPr>
+          <p:nvPr/>
+        </p:nvSpPr>
+        <p:spPr>
+          <a:xfrm>
+            <a:off x="457200" y="6492240"/>
+            <a:ext cx="7315200" cy="274320"/>
+          </a:xfrm>
+          <a:prstGeom prst="rect">
+            <a:avLst/>
+          </a:prstGeom>
+          <a:noFill/>
+        </p:spPr>
+        <p:txBody>
+          <a:bodyPr wrap="square" lIns="0" tIns="0" rIns="0" bIns="0" anchor="ctr"/>
+          <a:lstStyle/>
+          <a:p>
+            <a:pPr marL="0" indent="0" algn="l">
+              <a:buNone/>
+            </a:pPr>
+            <a:r>
+              <a:rPr sz="900">
+                <a:solidFill>
+                  <a:srgbClr val="64748B"/>
+                </a:solidFill>
+                <a:latin typeface="Calibri"/>
+                <a:ea typeface="Calibri"/>
+                <a:cs typeface="Calibri"/>
+              </a:rPr>
+              <a:t>BINUS UNIVERSITY  |  Cloud Services  |  Praktikum 8</a:t>
+            </a:r>
+            <a:endParaRPr sz="900"/>
+          </a:p>
+        </p:txBody>
+      </p:sp>
+      <p:sp>
+        <p:nvSpPr>
+          <p:cNvPr id="3" name="Text 1">
+            <a:extLst>
+              <a:ext uri="{FF2B5EF4-FFF2-40B4-BE49-F238E27FC236}">
+                <a16:creationId xmlns:a16="http://schemas.microsoft.com/office/drawing/2014/main" id="{B7DEE372-5732-46B2-A5A3-CCDCD1213C21}"/>
+              </a:ext>
+            </a:extLst>
+          </p:cNvPr>
+          <p:cNvSpPr>
+            <a:spLocks noGrp="1"/>
+          </p:cNvSpPr>
+          <p:nvPr/>
+        </p:nvSpPr>
+        <p:spPr>
+          <a:xfrm>
+            <a:off x="11247120" y="6492240"/>
+            <a:ext cx="457200" cy="274320"/>
+          </a:xfrm>
+          <a:prstGeom prst="rect">
+            <a:avLst/>
+          </a:prstGeom>
+          <a:noFill/>
+        </p:spPr>
+        <p:txBody>
+          <a:bodyPr wrap="square" lIns="0" tIns="0" rIns="0" bIns="0" anchor="ctr"/>
+          <a:lstStyle/>
+          <a:p>
+            <a:pPr marL="0" indent="0" algn="r">
+              <a:buNone/>
+            </a:pPr>
+            <a:r>
+              <a:rPr lang="en-US" sz="900" b="1">
+                <a:solidFill>
+                  <a:srgbClr val="64748B"/>
+                </a:solidFill>
+                <a:latin typeface="Calibri"/>
+                <a:ea typeface="Calibri"/>
+                <a:cs typeface="Calibri"/>
+              </a:rPr>
+              <a:t>4</a:t>
+            </a:r>
+            <a:endParaRPr sz="900"/>
+          </a:p>
+        </p:txBody>
+      </p:sp>
+      <p:sp>
+        <p:nvSpPr>
+          <p:cNvPr id="4" name="Shape 2">
+            <a:extLst>
+              <a:ext uri="{FF2B5EF4-FFF2-40B4-BE49-F238E27FC236}">
+                <a16:creationId xmlns:a16="http://schemas.microsoft.com/office/drawing/2014/main" id="{6444FE1B-E38D-44B3-AEA5-6826CCE7CA16}"/>
+              </a:ext>
+            </a:extLst>
+          </p:cNvPr>
+          <p:cNvSpPr>
+            <a:spLocks noGrp="1"/>
+          </p:cNvSpPr>
+          <p:nvPr/>
+        </p:nvSpPr>
+        <p:spPr>
+          <a:xfrm>
+            <a:off x="457200" y="6446520"/>
+            <a:ext cx="228600" cy="36576"/>
+          </a:xfrm>
+          <a:prstGeom prst="rect">
+            <a:avLst/>
+          </a:prstGeom>
+          <a:solidFill>
+            <a:srgbClr val="F37021"/>
+          </a:solidFill>
+          <a:ln w="12700">
+            <a:solidFill>
+              <a:srgbClr val="F37021"/>
+            </a:solidFill>
+            <a:prstDash val="solid"/>
+          </a:ln>
+        </p:spPr>
+      </p:sp>
+      <p:pic>
+        <p:nvPicPr>
+          <p:cNvPr id="5" name="Picture 4" descr="image.png"/>
+          <p:cNvPicPr>
+            <a:picLocks noChangeAspect="1"/>
+          </p:cNvPicPr>
+          <p:nvPr/>
+        </p:nvPicPr>
+        <p:blipFill>
+          <a:blip r:embed="rId2"/>
+          <a:stretch>
+            <a:fillRect/>
+          </a:stretch>
+        </p:blipFill>
+        <p:spPr>
+          <a:xfrm>
+            <a:off x="274320" y="164592"/>
+            <a:ext cx="914400" cy="603504"/>
+          </a:xfrm>
+          <a:prstGeom prst="rect">
+            <a:avLst/>
+          </a:prstGeom>
+        </p:spPr>
+      </p:pic>
+      <p:pic>
+        <p:nvPicPr>
+          <p:cNvPr id="6" name="Picture 5" descr="image.png"/>
+          <p:cNvPicPr>
+            <a:picLocks noChangeAspect="1"/>
+          </p:cNvPicPr>
+          <p:nvPr/>
+        </p:nvPicPr>
+        <p:blipFill>
+          <a:blip r:embed="rId3"/>
+          <a:stretch>
+            <a:fillRect/>
+          </a:stretch>
+        </p:blipFill>
+        <p:spPr>
+          <a:xfrm>
+            <a:off x="10881360" y="182880"/>
+            <a:ext cx="1005840" cy="512064"/>
+          </a:xfrm>
+          <a:prstGeom prst="rect">
+            <a:avLst/>
+          </a:prstGeom>
+        </p:spPr>
+      </p:pic>
+      <p:sp>
+        <p:nvSpPr>
+          <p:cNvPr id="7" name="Shape 3">
+            <a:extLst>
+              <a:ext uri="{FF2B5EF4-FFF2-40B4-BE49-F238E27FC236}">
+                <a16:creationId xmlns:a16="http://schemas.microsoft.com/office/drawing/2014/main" id="{36B0E2A9-8B0F-4E12-8FC4-67BFE3E2DE48}"/>
+              </a:ext>
+            </a:extLst>
+          </p:cNvPr>
+          <p:cNvSpPr>
+            <a:spLocks noGrp="1"/>
+          </p:cNvSpPr>
+          <p:nvPr/>
+        </p:nvSpPr>
+        <p:spPr>
+          <a:xfrm>
+            <a:off x="457200" y="868680"/>
+            <a:ext cx="11247120" cy="0"/>
+          </a:xfrm>
+          <a:prstGeom prst="line">
+            <a:avLst/>
+          </a:prstGeom>
+          <a:noFill/>
+          <a:ln w="12700">
+            <a:solidFill>
+              <a:srgbClr val="E2E8F0"/>
+            </a:solidFill>
+            <a:prstDash val="solid"/>
+          </a:ln>
+        </p:spPr>
+      </p:sp>
+      <p:sp>
+        <p:nvSpPr>
+          <p:cNvPr id="8" name="Text 4">
+            <a:extLst>
+              <a:ext uri="{FF2B5EF4-FFF2-40B4-BE49-F238E27FC236}">
+                <a16:creationId xmlns:a16="http://schemas.microsoft.com/office/drawing/2014/main" id="{14FC51D3-657E-4EAF-997E-6D6EBC36EF94}"/>
+              </a:ext>
+            </a:extLst>
+          </p:cNvPr>
+          <p:cNvSpPr>
+            <a:spLocks noGrp="1"/>
+          </p:cNvSpPr>
+          <p:nvPr/>
+        </p:nvSpPr>
+        <p:spPr>
+          <a:xfrm>
+            <a:off x="2011680" y="182880"/>
+            <a:ext cx="8138160" cy="502920"/>
+          </a:xfrm>
+          <a:prstGeom prst="rect">
+            <a:avLst/>
+          </a:prstGeom>
+          <a:noFill/>
+        </p:spPr>
+        <p:txBody>
+          <a:bodyPr wrap="square" lIns="0" tIns="0" rIns="0" bIns="0" anchor="ctr"/>
+          <a:lstStyle/>
+          <a:p>
+            <a:pPr marL="0" indent="0" algn="ctr">
+              <a:buNone/>
+            </a:pPr>
+            <a:r>
+              <a:rPr lang="en-US" sz="2200" b="1">
+                <a:solidFill>
+                  <a:srgbClr val="1976D2"/>
+                </a:solidFill>
+                <a:latin typeface="Calibri"/>
+                <a:ea typeface="Calibri"/>
+                <a:cs typeface="Calibri"/>
+              </a:rPr>
+              <a:t>Bukti 1a | Dependensi dari lockfile</a:t>
+            </a:r>
+            <a:endParaRPr sz="2200"/>
+          </a:p>
+        </p:txBody>
+      </p:sp>
+      <p:sp>
+        <p:nvSpPr>
+          <p:cNvPr id="9" name="Text 5">
+            <a:extLst>
+              <a:ext uri="{FF2B5EF4-FFF2-40B4-BE49-F238E27FC236}">
+                <a16:creationId xmlns:a16="http://schemas.microsoft.com/office/drawing/2014/main" id="{7E594147-411E-4AC6-83CD-7B64DE78AA3C}"/>
+              </a:ext>
+            </a:extLst>
+          </p:cNvPr>
+          <p:cNvSpPr>
+            <a:spLocks noGrp="1"/>
+          </p:cNvSpPr>
+          <p:nvPr/>
+        </p:nvSpPr>
+        <p:spPr>
+          <a:xfrm>
+            <a:off x="457200" y="960120"/>
+            <a:ext cx="11247120" cy="320040"/>
+          </a:xfrm>
+          <a:prstGeom prst="rect">
+            <a:avLst/>
+          </a:prstGeom>
+          <a:noFill/>
+        </p:spPr>
+        <p:txBody>
+          <a:bodyPr wrap="square" lIns="0" tIns="0" rIns="0" bIns="0" anchor="ctr"/>
+          <a:lstStyle/>
+          <a:p>
+            <a:pPr marL="0" indent="0" algn="ctr">
+              <a:buNone/>
+            </a:pPr>
+            <a:r>
+              <a:rPr lang="en-US" sz="1200" i="1">
+                <a:solidFill>
+                  <a:srgbClr val="64748B"/>
+                </a:solidFill>
+                <a:latin typeface="Calibri"/>
+                <a:ea typeface="Calibri"/>
+                <a:cs typeface="Calibri"/>
+              </a:rPr>
+              <a:t>npm ci dijalankan sebelum server Next hidup</a:t>
+            </a:r>
+            <a:endParaRPr sz="1200"/>
+          </a:p>
+        </p:txBody>
+      </p:sp>
+      <p:pic>
+        <p:nvPicPr>
+          <p:cNvPr id="10" name="Picture 9" descr="13_npm_ci.png"/>
+          <p:cNvPicPr>
+            <a:picLocks noChangeAspect="1"/>
+          </p:cNvPicPr>
+          <p:nvPr/>
+        </p:nvPicPr>
+        <p:blipFill>
+          <a:blip r:embed="rId4"/>
+          <a:stretch>
+            <a:fillRect/>
+          </a:stretch>
+        </p:blipFill>
+        <p:spPr>
+          <a:xfrm>
+            <a:off x="640080" y="1995678"/>
+            <a:ext cx="10927080" cy="3278124"/>
+          </a:xfrm>
+          <a:prstGeom prst="rect">
+            <a:avLst/>
+          </a:prstGeom>
+        </p:spPr>
+      </p:pic>
+      <p:sp>
+        <p:nvSpPr>
+          <p:cNvPr id="11" name="TextBox 10"/>
+          <p:cNvSpPr txBox="1"/>
+          <p:nvPr/>
+        </p:nvSpPr>
+        <p:spPr>
+          <a:xfrm>
+            <a:off x="685800" y="5797296"/>
+            <a:ext cx="10881360" cy="566928"/>
+          </a:xfrm>
+          <a:prstGeom prst="rect">
+            <a:avLst/>
+          </a:prstGeom>
+          <a:noFill/>
+        </p:spPr>
+        <p:txBody>
+          <a:bodyPr wrap="square">
+            <a:spAutoFit/>
+          </a:bodyPr>
+          <a:lstStyle/>
+          <a:p>
+            <a:pPr>
+              <a:defRPr sz="1400">
+                <a:solidFill>
+                  <a:srgbClr val="0F336F"/>
+                </a:solidFill>
+                <a:latin typeface="Arial"/>
+              </a:defRPr>
+            </a:pPr>
+            <a:r>
+              <a:t>Perintah: npm ci. Fungsi: pasang dependensi dari lockfile.</a:t>
+            </a:r>
+            <a:br/>
+            <a:r>
+              <a:t>Cara kerja: npm menyusun node_modules; hasil: 37 paket, exit 0.</a:t>
+            </a:r>
+          </a:p>
+        </p:txBody>
+      </p:sp>
+    </p:spTree>
+  </p:cSld>
+  <p:clrMapOvr>
+    <a:masterClrMapping/>
+  </p:clrMapOvr>
+</p:sld>
+</file>
+
+<file path=ppt/slides/slide14.xml><?xml version="1.0" encoding="utf-8"?>
+<p:sld xmlns:a="http://schemas.openxmlformats.org/drawingml/2006/main" xmlns:p="http://schemas.openxmlformats.org/presentationml/2006/main" xmlns:r="http://schemas.openxmlformats.org/officeDocument/2006/relationships">
+  <p:cSld>
+    <p:spTree>
+      <p:nvGrpSpPr>
+        <p:cNvPr id="1" name=""/>
+        <p:cNvGrpSpPr/>
+        <p:nvPr/>
+      </p:nvGrpSpPr>
+      <p:grpSpPr/>
+      <p:sp>
+        <p:nvSpPr>
+          <p:cNvPr id="2" name="Text 0">
+            <a:extLst>
+              <a:ext uri="{FF2B5EF4-FFF2-40B4-BE49-F238E27FC236}">
+                <a16:creationId xmlns:a16="http://schemas.microsoft.com/office/drawing/2014/main" id="{0B86DC9D-6623-4169-8C9C-3145D037D6C7}"/>
+              </a:ext>
+            </a:extLst>
+          </p:cNvPr>
+          <p:cNvSpPr>
+            <a:spLocks noGrp="1"/>
+          </p:cNvSpPr>
+          <p:nvPr/>
+        </p:nvSpPr>
+        <p:spPr>
+          <a:xfrm>
+            <a:off x="457200" y="6492240"/>
+            <a:ext cx="7315200" cy="274320"/>
+          </a:xfrm>
+          <a:prstGeom prst="rect">
+            <a:avLst/>
+          </a:prstGeom>
+          <a:noFill/>
+        </p:spPr>
+        <p:txBody>
+          <a:bodyPr wrap="square" lIns="0" tIns="0" rIns="0" bIns="0" anchor="ctr"/>
+          <a:lstStyle/>
+          <a:p>
+            <a:pPr marL="0" indent="0" algn="l">
+              <a:buNone/>
+            </a:pPr>
+            <a:r>
+              <a:rPr sz="900">
+                <a:solidFill>
+                  <a:srgbClr val="64748B"/>
+                </a:solidFill>
+                <a:latin typeface="Calibri"/>
+                <a:ea typeface="Calibri"/>
+                <a:cs typeface="Calibri"/>
+              </a:rPr>
+              <a:t>BINUS UNIVERSITY  |  Cloud Services  |  Praktikum 8</a:t>
+            </a:r>
+            <a:endParaRPr sz="900"/>
+          </a:p>
+        </p:txBody>
+      </p:sp>
+      <p:sp>
+        <p:nvSpPr>
+          <p:cNvPr id="3" name="Text 1">
+            <a:extLst>
+              <a:ext uri="{FF2B5EF4-FFF2-40B4-BE49-F238E27FC236}">
+                <a16:creationId xmlns:a16="http://schemas.microsoft.com/office/drawing/2014/main" id="{B7DEE372-5732-46B2-A5A3-CCDCD1213C21}"/>
+              </a:ext>
+            </a:extLst>
+          </p:cNvPr>
+          <p:cNvSpPr>
+            <a:spLocks noGrp="1"/>
+          </p:cNvSpPr>
+          <p:nvPr/>
+        </p:nvSpPr>
+        <p:spPr>
+          <a:xfrm>
+            <a:off x="11247120" y="6492240"/>
+            <a:ext cx="457200" cy="274320"/>
+          </a:xfrm>
+          <a:prstGeom prst="rect">
+            <a:avLst/>
+          </a:prstGeom>
+          <a:noFill/>
+        </p:spPr>
+        <p:txBody>
+          <a:bodyPr wrap="square" lIns="0" tIns="0" rIns="0" bIns="0" anchor="ctr"/>
+          <a:lstStyle/>
+          <a:p>
+            <a:pPr marL="0" indent="0" algn="r">
+              <a:buNone/>
+            </a:pPr>
+            <a:r>
+              <a:rPr lang="en-US" sz="900" b="1">
+                <a:solidFill>
+                  <a:srgbClr val="64748B"/>
+                </a:solidFill>
+                <a:latin typeface="Calibri"/>
+                <a:ea typeface="Calibri"/>
+                <a:cs typeface="Calibri"/>
+              </a:rPr>
+              <a:t>6</a:t>
+            </a:r>
+            <a:endParaRPr sz="900"/>
+          </a:p>
+        </p:txBody>
+      </p:sp>
+      <p:sp>
+        <p:nvSpPr>
+          <p:cNvPr id="4" name="Shape 2">
+            <a:extLst>
+              <a:ext uri="{FF2B5EF4-FFF2-40B4-BE49-F238E27FC236}">
+                <a16:creationId xmlns:a16="http://schemas.microsoft.com/office/drawing/2014/main" id="{6444FE1B-E38D-44B3-AEA5-6826CCE7CA16}"/>
+              </a:ext>
+            </a:extLst>
+          </p:cNvPr>
+          <p:cNvSpPr>
+            <a:spLocks noGrp="1"/>
+          </p:cNvSpPr>
+          <p:nvPr/>
+        </p:nvSpPr>
+        <p:spPr>
+          <a:xfrm>
+            <a:off x="457200" y="6446520"/>
+            <a:ext cx="228600" cy="36576"/>
+          </a:xfrm>
+          <a:prstGeom prst="rect">
+            <a:avLst/>
+          </a:prstGeom>
+          <a:solidFill>
+            <a:srgbClr val="F37021"/>
+          </a:solidFill>
+          <a:ln w="12700">
+            <a:solidFill>
+              <a:srgbClr val="F37021"/>
+            </a:solidFill>
+            <a:prstDash val="solid"/>
+          </a:ln>
+        </p:spPr>
+      </p:sp>
+      <p:pic>
+        <p:nvPicPr>
+          <p:cNvPr id="5" name="Picture 4" descr="image.png"/>
+          <p:cNvPicPr>
+            <a:picLocks noChangeAspect="1"/>
+          </p:cNvPicPr>
+          <p:nvPr/>
+        </p:nvPicPr>
+        <p:blipFill>
+          <a:blip r:embed="rId2"/>
+          <a:stretch>
+            <a:fillRect/>
+          </a:stretch>
+        </p:blipFill>
+        <p:spPr>
+          <a:xfrm>
+            <a:off x="274320" y="164592"/>
+            <a:ext cx="914400" cy="603504"/>
+          </a:xfrm>
+          <a:prstGeom prst="rect">
+            <a:avLst/>
+          </a:prstGeom>
+        </p:spPr>
+      </p:pic>
+      <p:pic>
+        <p:nvPicPr>
+          <p:cNvPr id="6" name="Picture 5" descr="image.png"/>
+          <p:cNvPicPr>
+            <a:picLocks noChangeAspect="1"/>
+          </p:cNvPicPr>
+          <p:nvPr/>
+        </p:nvPicPr>
+        <p:blipFill>
+          <a:blip r:embed="rId3"/>
+          <a:stretch>
+            <a:fillRect/>
+          </a:stretch>
+        </p:blipFill>
+        <p:spPr>
+          <a:xfrm>
+            <a:off x="10881360" y="182880"/>
+            <a:ext cx="1005840" cy="512064"/>
+          </a:xfrm>
+          <a:prstGeom prst="rect">
+            <a:avLst/>
+          </a:prstGeom>
+        </p:spPr>
+      </p:pic>
+      <p:sp>
+        <p:nvSpPr>
+          <p:cNvPr id="7" name="Shape 3">
+            <a:extLst>
+              <a:ext uri="{FF2B5EF4-FFF2-40B4-BE49-F238E27FC236}">
+                <a16:creationId xmlns:a16="http://schemas.microsoft.com/office/drawing/2014/main" id="{36B0E2A9-8B0F-4E12-8FC4-67BFE3E2DE48}"/>
+              </a:ext>
+            </a:extLst>
+          </p:cNvPr>
+          <p:cNvSpPr>
+            <a:spLocks noGrp="1"/>
+          </p:cNvSpPr>
+          <p:nvPr/>
+        </p:nvSpPr>
+        <p:spPr>
+          <a:xfrm>
+            <a:off x="457200" y="868680"/>
+            <a:ext cx="11247120" cy="0"/>
+          </a:xfrm>
+          <a:prstGeom prst="line">
+            <a:avLst/>
+          </a:prstGeom>
+          <a:noFill/>
+          <a:ln w="12700">
+            <a:solidFill>
+              <a:srgbClr val="E2E8F0"/>
+            </a:solidFill>
+            <a:prstDash val="solid"/>
+          </a:ln>
+        </p:spPr>
+      </p:sp>
+      <p:sp>
+        <p:nvSpPr>
+          <p:cNvPr id="8" name="Text 4">
+            <a:extLst>
+              <a:ext uri="{FF2B5EF4-FFF2-40B4-BE49-F238E27FC236}">
+                <a16:creationId xmlns:a16="http://schemas.microsoft.com/office/drawing/2014/main" id="{14FC51D3-657E-4EAF-997E-6D6EBC36EF94}"/>
+              </a:ext>
+            </a:extLst>
+          </p:cNvPr>
+          <p:cNvSpPr>
+            <a:spLocks noGrp="1"/>
+          </p:cNvSpPr>
+          <p:nvPr/>
+        </p:nvSpPr>
+        <p:spPr>
+          <a:xfrm>
+            <a:off x="2011680" y="182880"/>
+            <a:ext cx="8138160" cy="502920"/>
+          </a:xfrm>
+          <a:prstGeom prst="rect">
+            <a:avLst/>
+          </a:prstGeom>
+          <a:noFill/>
+        </p:spPr>
+        <p:txBody>
+          <a:bodyPr wrap="square" lIns="0" tIns="0" rIns="0" bIns="0" anchor="ctr"/>
+          <a:lstStyle/>
+          <a:p>
+            <a:pPr marL="0" indent="0" algn="ctr">
+              <a:buNone/>
+            </a:pPr>
+            <a:r>
+              <a:rPr lang="en-US" sz="2200" b="1">
+                <a:solidFill>
+                  <a:srgbClr val="1976D2"/>
+                </a:solidFill>
+                <a:latin typeface="Calibri"/>
+                <a:ea typeface="Calibri"/>
+                <a:cs typeface="Calibri"/>
+              </a:rPr>
+              <a:t>Bukti 1b | Batas browser dan server</a:t>
+            </a:r>
+            <a:endParaRPr sz="2200"/>
+          </a:p>
+        </p:txBody>
+      </p:sp>
+      <p:sp>
+        <p:nvSpPr>
+          <p:cNvPr id="9" name="Text 5">
+            <a:extLst>
+              <a:ext uri="{FF2B5EF4-FFF2-40B4-BE49-F238E27FC236}">
+                <a16:creationId xmlns:a16="http://schemas.microsoft.com/office/drawing/2014/main" id="{7E594147-411E-4AC6-83CD-7B64DE78AA3C}"/>
+              </a:ext>
+            </a:extLst>
+          </p:cNvPr>
+          <p:cNvSpPr>
+            <a:spLocks noGrp="1"/>
+          </p:cNvSpPr>
+          <p:nvPr/>
+        </p:nvSpPr>
+        <p:spPr>
+          <a:xfrm>
+            <a:off x="457200" y="960120"/>
+            <a:ext cx="11247120" cy="320040"/>
+          </a:xfrm>
+          <a:prstGeom prst="rect">
+            <a:avLst/>
+          </a:prstGeom>
+          <a:noFill/>
+        </p:spPr>
+        <p:txBody>
+          <a:bodyPr wrap="square" lIns="0" tIns="0" rIns="0" bIns="0" anchor="ctr"/>
+          <a:lstStyle/>
+          <a:p>
+            <a:pPr marL="0" indent="0" algn="ctr">
+              <a:buNone/>
+            </a:pPr>
+            <a:r>
+              <a:rPr lang="en-US" sz="1200" i="1">
+                <a:solidFill>
+                  <a:srgbClr val="64748B"/>
+                </a:solidFill>
+                <a:latin typeface="Calibri"/>
+                <a:ea typeface="Calibri"/>
+                <a:cs typeface="Calibri"/>
+              </a:rPr>
+              <a:t>Baris source yang menghasilkan jalur Cloud Notes</a:t>
+            </a:r>
+            <a:endParaRPr sz="1200"/>
+          </a:p>
+        </p:txBody>
+      </p:sp>
+      <p:pic>
+        <p:nvPicPr>
+          <p:cNvPr id="10" name="Picture 9" descr="15_source_tour.png"/>
+          <p:cNvPicPr>
+            <a:picLocks noChangeAspect="1"/>
+          </p:cNvPicPr>
+          <p:nvPr/>
+        </p:nvPicPr>
+        <p:blipFill>
+          <a:blip r:embed="rId4"/>
+          <a:stretch>
+            <a:fillRect/>
+          </a:stretch>
+        </p:blipFill>
+        <p:spPr>
+          <a:xfrm>
+            <a:off x="1062174" y="1463040"/>
+            <a:ext cx="10082892" cy="4343400"/>
+          </a:xfrm>
+          <a:prstGeom prst="rect">
+            <a:avLst/>
+          </a:prstGeom>
+        </p:spPr>
+      </p:pic>
+      <p:sp>
+        <p:nvSpPr>
+          <p:cNvPr id="11" name="TextBox 10"/>
+          <p:cNvSpPr txBox="1"/>
+          <p:nvPr/>
+        </p:nvSpPr>
+        <p:spPr>
+          <a:xfrm>
+            <a:off x="685800" y="5797296"/>
+            <a:ext cx="10881360" cy="566928"/>
+          </a:xfrm>
+          <a:prstGeom prst="rect">
+            <a:avLst/>
+          </a:prstGeom>
+          <a:noFill/>
+        </p:spPr>
+        <p:txBody>
+          <a:bodyPr wrap="square">
+            <a:spAutoFit/>
+          </a:bodyPr>
+          <a:lstStyle/>
+          <a:p>
+            <a:pPr>
+              <a:defRPr sz="1400">
+                <a:solidFill>
+                  <a:srgbClr val="0F336F"/>
+                </a:solidFill>
+                <a:latin typeface="Arial"/>
+              </a:defRPr>
+            </a:pPr>
+            <a:r>
+              <a:t>Perintah: rg -n pada page.tsx dan route.ts. Fungsi: temukan batas browser/server.</a:t>
+            </a:r>
+            <a:br/>
+            <a:r>
+              <a:t>Cara kerja: rg membaca source; hasil: page memanggil /api/notes, server membaca LOCAL_API_URL.</a:t>
+            </a:r>
+          </a:p>
+        </p:txBody>
+      </p:sp>
+    </p:spTree>
+  </p:cSld>
+  <p:clrMapOvr>
+    <a:masterClrMapping/>
+  </p:clrMapOvr>
+</p:sld>
+</file>
+
+<file path=ppt/slides/slide15.xml><?xml version="1.0" encoding="utf-8"?>
+<p:sld xmlns:a="http://schemas.openxmlformats.org/drawingml/2006/main" xmlns:p="http://schemas.openxmlformats.org/presentationml/2006/main" xmlns:r="http://schemas.openxmlformats.org/officeDocument/2006/relationships">
+  <p:cSld>
+    <p:spTree>
+      <p:nvGrpSpPr>
+        <p:cNvPr id="1" name=""/>
+        <p:cNvGrpSpPr/>
+        <p:nvPr/>
+      </p:nvGrpSpPr>
+      <p:grpSpPr/>
+      <p:sp>
+        <p:nvSpPr>
+          <p:cNvPr id="2" name="Text 0">
+            <a:extLst>
+              <a:ext uri="{FF2B5EF4-FFF2-40B4-BE49-F238E27FC236}">
+                <a16:creationId xmlns:a16="http://schemas.microsoft.com/office/drawing/2014/main" id="{0B86DC9D-6623-4169-8C9C-3145D037D6C7}"/>
+              </a:ext>
+            </a:extLst>
+          </p:cNvPr>
+          <p:cNvSpPr>
+            <a:spLocks noGrp="1"/>
+          </p:cNvSpPr>
+          <p:nvPr/>
+        </p:nvSpPr>
+        <p:spPr>
+          <a:xfrm>
+            <a:off x="457200" y="6492240"/>
+            <a:ext cx="7315200" cy="274320"/>
+          </a:xfrm>
+          <a:prstGeom prst="rect">
+            <a:avLst/>
+          </a:prstGeom>
+          <a:noFill/>
+        </p:spPr>
+        <p:txBody>
+          <a:bodyPr wrap="square" lIns="0" tIns="0" rIns="0" bIns="0" anchor="ctr"/>
+          <a:lstStyle/>
+          <a:p>
+            <a:pPr marL="0" indent="0" algn="l">
+              <a:buNone/>
+            </a:pPr>
+            <a:r>
+              <a:rPr sz="900">
+                <a:solidFill>
+                  <a:srgbClr val="64748B"/>
+                </a:solidFill>
+                <a:latin typeface="Calibri"/>
+                <a:ea typeface="Calibri"/>
+                <a:cs typeface="Calibri"/>
+              </a:rPr>
+              <a:t>BINUS UNIVERSITY  |  Cloud Services  |  Praktikum 8</a:t>
+            </a:r>
+            <a:endParaRPr sz="900"/>
+          </a:p>
+        </p:txBody>
+      </p:sp>
+      <p:sp>
+        <p:nvSpPr>
+          <p:cNvPr id="3" name="Text 1">
+            <a:extLst>
+              <a:ext uri="{FF2B5EF4-FFF2-40B4-BE49-F238E27FC236}">
+                <a16:creationId xmlns:a16="http://schemas.microsoft.com/office/drawing/2014/main" id="{B7DEE372-5732-46B2-A5A3-CCDCD1213C21}"/>
+              </a:ext>
+            </a:extLst>
+          </p:cNvPr>
+          <p:cNvSpPr>
+            <a:spLocks noGrp="1"/>
+          </p:cNvSpPr>
+          <p:nvPr/>
+        </p:nvSpPr>
+        <p:spPr>
+          <a:xfrm>
+            <a:off x="11247120" y="6492240"/>
+            <a:ext cx="457200" cy="274320"/>
+          </a:xfrm>
+          <a:prstGeom prst="rect">
+            <a:avLst/>
+          </a:prstGeom>
+          <a:noFill/>
+        </p:spPr>
+        <p:txBody>
+          <a:bodyPr wrap="square" lIns="0" tIns="0" rIns="0" bIns="0" anchor="ctr"/>
+          <a:lstStyle/>
+          <a:p>
+            <a:pPr marL="0" indent="0" algn="r">
+              <a:buNone/>
+            </a:pPr>
+            <a:r>
+              <a:rPr lang="en-US" sz="900" b="1">
+                <a:solidFill>
+                  <a:srgbClr val="64748B"/>
+                </a:solidFill>
+                <a:latin typeface="Calibri"/>
+                <a:ea typeface="Calibri"/>
+                <a:cs typeface="Calibri"/>
+              </a:rPr>
+              <a:t>10</a:t>
+            </a:r>
+            <a:endParaRPr sz="900"/>
+          </a:p>
+        </p:txBody>
+      </p:sp>
+      <p:sp>
+        <p:nvSpPr>
+          <p:cNvPr id="4" name="Shape 2">
+            <a:extLst>
+              <a:ext uri="{FF2B5EF4-FFF2-40B4-BE49-F238E27FC236}">
+                <a16:creationId xmlns:a16="http://schemas.microsoft.com/office/drawing/2014/main" id="{6444FE1B-E38D-44B3-AEA5-6826CCE7CA16}"/>
+              </a:ext>
+            </a:extLst>
+          </p:cNvPr>
+          <p:cNvSpPr>
+            <a:spLocks noGrp="1"/>
+          </p:cNvSpPr>
+          <p:nvPr/>
+        </p:nvSpPr>
+        <p:spPr>
+          <a:xfrm>
+            <a:off x="457200" y="6446520"/>
+            <a:ext cx="228600" cy="36576"/>
+          </a:xfrm>
+          <a:prstGeom prst="rect">
+            <a:avLst/>
+          </a:prstGeom>
+          <a:solidFill>
+            <a:srgbClr val="F37021"/>
+          </a:solidFill>
+          <a:ln w="12700">
+            <a:solidFill>
+              <a:srgbClr val="F37021"/>
+            </a:solidFill>
+            <a:prstDash val="solid"/>
+          </a:ln>
+        </p:spPr>
+      </p:sp>
+      <p:pic>
+        <p:nvPicPr>
+          <p:cNvPr id="5" name="Picture 4" descr="image.png"/>
+          <p:cNvPicPr>
+            <a:picLocks noChangeAspect="1"/>
+          </p:cNvPicPr>
+          <p:nvPr/>
+        </p:nvPicPr>
+        <p:blipFill>
+          <a:blip r:embed="rId2"/>
+          <a:stretch>
+            <a:fillRect/>
+          </a:stretch>
+        </p:blipFill>
+        <p:spPr>
+          <a:xfrm>
+            <a:off x="274320" y="164592"/>
+            <a:ext cx="914400" cy="603504"/>
+          </a:xfrm>
+          <a:prstGeom prst="rect">
+            <a:avLst/>
+          </a:prstGeom>
+        </p:spPr>
+      </p:pic>
+      <p:pic>
+        <p:nvPicPr>
+          <p:cNvPr id="6" name="Picture 5" descr="image.png"/>
+          <p:cNvPicPr>
+            <a:picLocks noChangeAspect="1"/>
+          </p:cNvPicPr>
+          <p:nvPr/>
+        </p:nvPicPr>
+        <p:blipFill>
+          <a:blip r:embed="rId3"/>
+          <a:stretch>
+            <a:fillRect/>
+          </a:stretch>
+        </p:blipFill>
+        <p:spPr>
+          <a:xfrm>
+            <a:off x="10881360" y="182880"/>
+            <a:ext cx="1005840" cy="512064"/>
+          </a:xfrm>
+          <a:prstGeom prst="rect">
+            <a:avLst/>
+          </a:prstGeom>
+        </p:spPr>
+      </p:pic>
+      <p:sp>
+        <p:nvSpPr>
+          <p:cNvPr id="7" name="Shape 3">
+            <a:extLst>
+              <a:ext uri="{FF2B5EF4-FFF2-40B4-BE49-F238E27FC236}">
+                <a16:creationId xmlns:a16="http://schemas.microsoft.com/office/drawing/2014/main" id="{36B0E2A9-8B0F-4E12-8FC4-67BFE3E2DE48}"/>
+              </a:ext>
+            </a:extLst>
+          </p:cNvPr>
+          <p:cNvSpPr>
+            <a:spLocks noGrp="1"/>
+          </p:cNvSpPr>
+          <p:nvPr/>
+        </p:nvSpPr>
+        <p:spPr>
+          <a:xfrm>
+            <a:off x="457200" y="868680"/>
+            <a:ext cx="11247120" cy="0"/>
+          </a:xfrm>
+          <a:prstGeom prst="line">
+            <a:avLst/>
+          </a:prstGeom>
+          <a:noFill/>
+          <a:ln w="12700">
+            <a:solidFill>
+              <a:srgbClr val="E2E8F0"/>
+            </a:solidFill>
+            <a:prstDash val="solid"/>
+          </a:ln>
+        </p:spPr>
+      </p:sp>
+      <p:sp>
+        <p:nvSpPr>
+          <p:cNvPr id="8" name="Text 4">
+            <a:extLst>
+              <a:ext uri="{FF2B5EF4-FFF2-40B4-BE49-F238E27FC236}">
+                <a16:creationId xmlns:a16="http://schemas.microsoft.com/office/drawing/2014/main" id="{14FC51D3-657E-4EAF-997E-6D6EBC36EF94}"/>
+              </a:ext>
+            </a:extLst>
+          </p:cNvPr>
+          <p:cNvSpPr>
+            <a:spLocks noGrp="1"/>
+          </p:cNvSpPr>
+          <p:nvPr/>
+        </p:nvSpPr>
+        <p:spPr>
+          <a:xfrm>
+            <a:off x="2011680" y="182880"/>
+            <a:ext cx="8138160" cy="502920"/>
+          </a:xfrm>
+          <a:prstGeom prst="rect">
+            <a:avLst/>
+          </a:prstGeom>
+          <a:noFill/>
+        </p:spPr>
+        <p:txBody>
+          <a:bodyPr wrap="square" lIns="0" tIns="0" rIns="0" bIns="0" anchor="ctr"/>
+          <a:lstStyle/>
+          <a:p>
+            <a:pPr marL="0" indent="0" algn="ctr">
+              <a:buNone/>
+            </a:pPr>
+            <a:r>
+              <a:rPr lang="en-US" sz="2200" b="1">
+                <a:solidFill>
+                  <a:srgbClr val="1976D2"/>
+                </a:solidFill>
+                <a:latin typeface="Calibri"/>
+                <a:ea typeface="Calibri"/>
+                <a:cs typeface="Calibri"/>
+              </a:rPr>
+              <a:t>Bukti 3a | API berhenti lalu pulih</a:t>
+            </a:r>
+            <a:endParaRPr sz="2200"/>
+          </a:p>
+        </p:txBody>
+      </p:sp>
+      <p:sp>
+        <p:nvSpPr>
+          <p:cNvPr id="9" name="Text 5">
+            <a:extLst>
+              <a:ext uri="{FF2B5EF4-FFF2-40B4-BE49-F238E27FC236}">
+                <a16:creationId xmlns:a16="http://schemas.microsoft.com/office/drawing/2014/main" id="{7E594147-411E-4AC6-83CD-7B64DE78AA3C}"/>
+              </a:ext>
+            </a:extLst>
+          </p:cNvPr>
+          <p:cNvSpPr>
+            <a:spLocks noGrp="1"/>
+          </p:cNvSpPr>
+          <p:nvPr/>
+        </p:nvSpPr>
+        <p:spPr>
+          <a:xfrm>
+            <a:off x="457200" y="960120"/>
+            <a:ext cx="11247120" cy="320040"/>
+          </a:xfrm>
+          <a:prstGeom prst="rect">
+            <a:avLst/>
+          </a:prstGeom>
+          <a:noFill/>
+        </p:spPr>
+        <p:txBody>
+          <a:bodyPr wrap="square" lIns="0" tIns="0" rIns="0" bIns="0" anchor="ctr"/>
+          <a:lstStyle/>
+          <a:p>
+            <a:pPr marL="0" indent="0" algn="ctr">
+              <a:buNone/>
+            </a:pPr>
+            <a:r>
+              <a:rPr lang="en-US" sz="1200" i="1">
+                <a:solidFill>
+                  <a:srgbClr val="64748B"/>
+                </a:solidFill>
+                <a:latin typeface="Calibri"/>
+                <a:ea typeface="Calibri"/>
+                <a:cs typeface="Calibri"/>
+              </a:rPr>
+              <a:t>Perbandingan status setelah restart service API Lab 06</a:t>
+            </a:r>
+            <a:endParaRPr sz="1200"/>
+          </a:p>
+        </p:txBody>
+      </p:sp>
+      <p:pic>
+        <p:nvPicPr>
+          <p:cNvPr id="10" name="Picture 9" descr="19_pemulihan.png"/>
+          <p:cNvPicPr>
+            <a:picLocks noChangeAspect="1"/>
+          </p:cNvPicPr>
+          <p:nvPr/>
+        </p:nvPicPr>
+        <p:blipFill>
+          <a:blip r:embed="rId4"/>
+          <a:stretch>
+            <a:fillRect/>
+          </a:stretch>
+        </p:blipFill>
+        <p:spPr>
+          <a:xfrm>
+            <a:off x="793507" y="1463040"/>
+            <a:ext cx="10620225" cy="4343400"/>
+          </a:xfrm>
+          <a:prstGeom prst="rect">
+            <a:avLst/>
+          </a:prstGeom>
+        </p:spPr>
+      </p:pic>
+      <p:sp>
+        <p:nvSpPr>
+          <p:cNvPr id="11" name="TextBox 10"/>
+          <p:cNvSpPr txBox="1"/>
+          <p:nvPr/>
+        </p:nvSpPr>
+        <p:spPr>
+          <a:xfrm>
+            <a:off x="685800" y="5797296"/>
+            <a:ext cx="10881360" cy="566928"/>
+          </a:xfrm>
+          <a:prstGeom prst="rect">
+            <a:avLst/>
+          </a:prstGeom>
+          <a:noFill/>
+        </p:spPr>
+        <p:txBody>
+          <a:bodyPr wrap="square">
+            <a:spAutoFit/>
+          </a:bodyPr>
+          <a:lstStyle/>
+          <a:p>
+            <a:pPr>
+              <a:defRPr sz="1400">
+                <a:solidFill>
+                  <a:srgbClr val="0F336F"/>
+                </a:solidFill>
+                <a:latin typeface="Arial"/>
+              </a:defRPr>
+            </a:pPr>
+            <a:r>
+              <a:t>Perintah: docker compose start api; GET ready dan notes. Fungsi: bukti pemulihan.</a:t>
+            </a:r>
+            <a:br/>
+            <a:r>
+              <a:t>Cara kerja: Next terhubung lagi ke API; hasil: 200/200 dan catatan tetap ada.</a:t>
+            </a:r>
+          </a:p>
+        </p:txBody>
+      </p:sp>
+    </p:spTree>
+  </p:cSld>
+  <p:clrMapOvr>
+    <a:masterClrMapping/>
+  </p:clrMapOvr>
+</p:sld>
+</file>
+
+<file path=ppt/slides/slide16.xml><?xml version="1.0" encoding="utf-8"?>
+<p:sld xmlns:a="http://schemas.openxmlformats.org/drawingml/2006/main" xmlns:p="http://schemas.openxmlformats.org/presentationml/2006/main" xmlns:r="http://schemas.openxmlformats.org/officeDocument/2006/relationships">
+  <p:cSld>
+    <p:spTree>
+      <p:nvGrpSpPr>
+        <p:cNvPr id="1" name=""/>
+        <p:cNvGrpSpPr/>
+        <p:nvPr/>
+      </p:nvGrpSpPr>
+      <p:grpSpPr/>
+      <p:sp>
+        <p:nvSpPr>
+          <p:cNvPr id="2" name="Text 0">
+            <a:extLst>
+              <a:ext uri="{FF2B5EF4-FFF2-40B4-BE49-F238E27FC236}">
+                <a16:creationId xmlns:a16="http://schemas.microsoft.com/office/drawing/2014/main" id="{0B86DC9D-6623-4169-8C9C-3145D037D6C7}"/>
+              </a:ext>
+            </a:extLst>
+          </p:cNvPr>
+          <p:cNvSpPr>
+            <a:spLocks noGrp="1"/>
+          </p:cNvSpPr>
+          <p:nvPr/>
+        </p:nvSpPr>
+        <p:spPr>
+          <a:xfrm>
+            <a:off x="457200" y="6492240"/>
+            <a:ext cx="7315200" cy="274320"/>
+          </a:xfrm>
+          <a:prstGeom prst="rect">
+            <a:avLst/>
+          </a:prstGeom>
+          <a:noFill/>
+        </p:spPr>
+        <p:txBody>
+          <a:bodyPr wrap="square" lIns="0" tIns="0" rIns="0" bIns="0" anchor="ctr"/>
+          <a:lstStyle/>
+          <a:p>
+            <a:pPr marL="0" indent="0" algn="l">
+              <a:buNone/>
+            </a:pPr>
+            <a:r>
+              <a:rPr sz="900">
+                <a:solidFill>
+                  <a:srgbClr val="64748B"/>
+                </a:solidFill>
+                <a:latin typeface="Calibri"/>
+                <a:ea typeface="Calibri"/>
+                <a:cs typeface="Calibri"/>
+              </a:rPr>
+              <a:t>BINUS UNIVERSITY  |  Cloud Services  |  Praktikum 8</a:t>
+            </a:r>
+            <a:endParaRPr sz="900"/>
+          </a:p>
+        </p:txBody>
+      </p:sp>
+      <p:sp>
+        <p:nvSpPr>
+          <p:cNvPr id="3" name="Text 1">
+            <a:extLst>
+              <a:ext uri="{FF2B5EF4-FFF2-40B4-BE49-F238E27FC236}">
+                <a16:creationId xmlns:a16="http://schemas.microsoft.com/office/drawing/2014/main" id="{B7DEE372-5732-46B2-A5A3-CCDCD1213C21}"/>
+              </a:ext>
+            </a:extLst>
+          </p:cNvPr>
+          <p:cNvSpPr>
+            <a:spLocks noGrp="1"/>
+          </p:cNvSpPr>
+          <p:nvPr/>
+        </p:nvSpPr>
+        <p:spPr>
+          <a:xfrm>
+            <a:off x="11247120" y="6492240"/>
+            <a:ext cx="457200" cy="274320"/>
+          </a:xfrm>
+          <a:prstGeom prst="rect">
+            <a:avLst/>
+          </a:prstGeom>
+          <a:noFill/>
+        </p:spPr>
+        <p:txBody>
+          <a:bodyPr wrap="square" lIns="0" tIns="0" rIns="0" bIns="0" anchor="ctr"/>
+          <a:lstStyle/>
+          <a:p>
+            <a:pPr marL="0" indent="0" algn="r">
+              <a:buNone/>
+            </a:pPr>
+            <a:r>
+              <a:rPr lang="en-US" sz="900" b="1">
+                <a:solidFill>
+                  <a:srgbClr val="64748B"/>
+                </a:solidFill>
+                <a:latin typeface="Calibri"/>
+                <a:ea typeface="Calibri"/>
+                <a:cs typeface="Calibri"/>
+              </a:rPr>
+              <a:t>13</a:t>
+            </a:r>
+            <a:endParaRPr sz="900"/>
+          </a:p>
+        </p:txBody>
+      </p:sp>
+      <p:sp>
+        <p:nvSpPr>
+          <p:cNvPr id="4" name="Shape 2">
+            <a:extLst>
+              <a:ext uri="{FF2B5EF4-FFF2-40B4-BE49-F238E27FC236}">
+                <a16:creationId xmlns:a16="http://schemas.microsoft.com/office/drawing/2014/main" id="{6444FE1B-E38D-44B3-AEA5-6826CCE7CA16}"/>
+              </a:ext>
+            </a:extLst>
+          </p:cNvPr>
+          <p:cNvSpPr>
+            <a:spLocks noGrp="1"/>
+          </p:cNvSpPr>
+          <p:nvPr/>
+        </p:nvSpPr>
+        <p:spPr>
+          <a:xfrm>
+            <a:off x="457200" y="6446520"/>
+            <a:ext cx="228600" cy="36576"/>
+          </a:xfrm>
+          <a:prstGeom prst="rect">
+            <a:avLst/>
+          </a:prstGeom>
+          <a:solidFill>
+            <a:srgbClr val="F37021"/>
+          </a:solidFill>
+          <a:ln w="12700">
+            <a:solidFill>
+              <a:srgbClr val="F37021"/>
+            </a:solidFill>
+            <a:prstDash val="solid"/>
+          </a:ln>
+        </p:spPr>
+      </p:sp>
+      <p:pic>
+        <p:nvPicPr>
+          <p:cNvPr id="5" name="Picture 4" descr="image.png"/>
+          <p:cNvPicPr>
+            <a:picLocks noChangeAspect="1"/>
+          </p:cNvPicPr>
+          <p:nvPr/>
+        </p:nvPicPr>
+        <p:blipFill>
+          <a:blip r:embed="rId2"/>
+          <a:stretch>
+            <a:fillRect/>
+          </a:stretch>
+        </p:blipFill>
+        <p:spPr>
+          <a:xfrm>
+            <a:off x="274320" y="164592"/>
+            <a:ext cx="914400" cy="603504"/>
+          </a:xfrm>
+          <a:prstGeom prst="rect">
+            <a:avLst/>
+          </a:prstGeom>
+        </p:spPr>
+      </p:pic>
+      <p:pic>
+        <p:nvPicPr>
+          <p:cNvPr id="6" name="Picture 5" descr="image.png"/>
+          <p:cNvPicPr>
+            <a:picLocks noChangeAspect="1"/>
+          </p:cNvPicPr>
+          <p:nvPr/>
+        </p:nvPicPr>
+        <p:blipFill>
+          <a:blip r:embed="rId3"/>
+          <a:stretch>
+            <a:fillRect/>
+          </a:stretch>
+        </p:blipFill>
+        <p:spPr>
+          <a:xfrm>
+            <a:off x="10881360" y="182880"/>
+            <a:ext cx="1005840" cy="512064"/>
+          </a:xfrm>
+          <a:prstGeom prst="rect">
+            <a:avLst/>
+          </a:prstGeom>
+        </p:spPr>
+      </p:pic>
+      <p:sp>
+        <p:nvSpPr>
+          <p:cNvPr id="7" name="Shape 3">
+            <a:extLst>
+              <a:ext uri="{FF2B5EF4-FFF2-40B4-BE49-F238E27FC236}">
+                <a16:creationId xmlns:a16="http://schemas.microsoft.com/office/drawing/2014/main" id="{36B0E2A9-8B0F-4E12-8FC4-67BFE3E2DE48}"/>
+              </a:ext>
+            </a:extLst>
+          </p:cNvPr>
+          <p:cNvSpPr>
+            <a:spLocks noGrp="1"/>
+          </p:cNvSpPr>
+          <p:nvPr/>
+        </p:nvSpPr>
+        <p:spPr>
+          <a:xfrm>
+            <a:off x="457200" y="868680"/>
+            <a:ext cx="11247120" cy="0"/>
+          </a:xfrm>
+          <a:prstGeom prst="line">
+            <a:avLst/>
+          </a:prstGeom>
+          <a:noFill/>
+          <a:ln w="12700">
+            <a:solidFill>
+              <a:srgbClr val="E2E8F0"/>
+            </a:solidFill>
+            <a:prstDash val="solid"/>
+          </a:ln>
+        </p:spPr>
+      </p:sp>
+      <p:sp>
+        <p:nvSpPr>
+          <p:cNvPr id="8" name="Text 4">
+            <a:extLst>
+              <a:ext uri="{FF2B5EF4-FFF2-40B4-BE49-F238E27FC236}">
+                <a16:creationId xmlns:a16="http://schemas.microsoft.com/office/drawing/2014/main" id="{14FC51D3-657E-4EAF-997E-6D6EBC36EF94}"/>
+              </a:ext>
+            </a:extLst>
+          </p:cNvPr>
+          <p:cNvSpPr>
+            <a:spLocks noGrp="1"/>
+          </p:cNvSpPr>
+          <p:nvPr/>
+        </p:nvSpPr>
+        <p:spPr>
+          <a:xfrm>
+            <a:off x="2011680" y="182880"/>
+            <a:ext cx="8138160" cy="502920"/>
+          </a:xfrm>
+          <a:prstGeom prst="rect">
+            <a:avLst/>
+          </a:prstGeom>
+          <a:noFill/>
+        </p:spPr>
+        <p:txBody>
+          <a:bodyPr wrap="square" lIns="0" tIns="0" rIns="0" bIns="0" anchor="ctr"/>
+          <a:lstStyle/>
+          <a:p>
+            <a:pPr marL="0" indent="0" algn="ctr">
+              <a:buNone/>
+            </a:pPr>
+            <a:r>
+              <a:rPr lang="en-US" sz="2200" b="1">
+                <a:solidFill>
+                  <a:srgbClr val="1976D2"/>
+                </a:solidFill>
+                <a:latin typeface="Calibri"/>
+                <a:ea typeface="Calibri"/>
+                <a:cs typeface="Calibri"/>
+              </a:rPr>
+              <a:t>Bukti 4a | POST, GET, dan Request ID</a:t>
+            </a:r>
+            <a:endParaRPr sz="2200"/>
+          </a:p>
+        </p:txBody>
+      </p:sp>
+      <p:sp>
+        <p:nvSpPr>
+          <p:cNvPr id="9" name="Text 5">
+            <a:extLst>
+              <a:ext uri="{FF2B5EF4-FFF2-40B4-BE49-F238E27FC236}">
+                <a16:creationId xmlns:a16="http://schemas.microsoft.com/office/drawing/2014/main" id="{7E594147-411E-4AC6-83CD-7B64DE78AA3C}"/>
+              </a:ext>
+            </a:extLst>
+          </p:cNvPr>
+          <p:cNvSpPr>
+            <a:spLocks noGrp="1"/>
+          </p:cNvSpPr>
+          <p:nvPr/>
+        </p:nvSpPr>
+        <p:spPr>
+          <a:xfrm>
+            <a:off x="457200" y="960120"/>
+            <a:ext cx="11247120" cy="320040"/>
+          </a:xfrm>
+          <a:prstGeom prst="rect">
+            <a:avLst/>
+          </a:prstGeom>
+          <a:noFill/>
+        </p:spPr>
+        <p:txBody>
+          <a:bodyPr wrap="square" lIns="0" tIns="0" rIns="0" bIns="0" anchor="ctr"/>
+          <a:lstStyle/>
+          <a:p>
+            <a:pPr marL="0" indent="0" algn="ctr">
+              <a:buNone/>
+            </a:pPr>
+            <a:r>
+              <a:rPr lang="en-US" sz="1200" i="1">
+                <a:solidFill>
+                  <a:srgbClr val="64748B"/>
+                </a:solidFill>
+                <a:latin typeface="Calibri"/>
+                <a:ea typeface="Calibri"/>
+                <a:cs typeface="Calibri"/>
+              </a:rPr>
+              <a:t>Respons nyata Route Handler pada jalur empat lapisan</a:t>
+            </a:r>
+            <a:endParaRPr sz="1200"/>
+          </a:p>
+        </p:txBody>
+      </p:sp>
+      <p:pic>
+        <p:nvPicPr>
+          <p:cNvPr id="10" name="Picture 9" descr="16_post_request_id.png"/>
+          <p:cNvPicPr>
+            <a:picLocks noChangeAspect="1"/>
+          </p:cNvPicPr>
+          <p:nvPr/>
+        </p:nvPicPr>
+        <p:blipFill>
+          <a:blip r:embed="rId4"/>
+          <a:stretch>
+            <a:fillRect/>
+          </a:stretch>
+        </p:blipFill>
+        <p:spPr>
+          <a:xfrm>
+            <a:off x="1525442" y="1463040"/>
+            <a:ext cx="9156356" cy="4343400"/>
+          </a:xfrm>
+          <a:prstGeom prst="rect">
+            <a:avLst/>
+          </a:prstGeom>
+        </p:spPr>
+      </p:pic>
+      <p:sp>
+        <p:nvSpPr>
+          <p:cNvPr id="11" name="TextBox 10"/>
+          <p:cNvSpPr txBox="1"/>
+          <p:nvPr/>
+        </p:nvSpPr>
+        <p:spPr>
+          <a:xfrm>
+            <a:off x="685800" y="5797296"/>
+            <a:ext cx="10881360" cy="566928"/>
+          </a:xfrm>
+          <a:prstGeom prst="rect">
+            <a:avLst/>
+          </a:prstGeom>
+          <a:noFill/>
+        </p:spPr>
+        <p:txBody>
+          <a:bodyPr wrap="square">
+            <a:spAutoFit/>
+          </a:bodyPr>
+          <a:lstStyle/>
+          <a:p>
+            <a:pPr>
+              <a:defRPr sz="1400">
+                <a:solidFill>
+                  <a:srgbClr val="0F336F"/>
+                </a:solidFill>
+                <a:latin typeface="Arial"/>
+              </a:defRPr>
+            </a:pPr>
+            <a:r>
+              <a:t>Perintah: POST lalu GET /api/notes. Fungsi: buktikan simpan dan baca.</a:t>
+            </a:r>
+            <a:br/>
+            <a:r>
+              <a:t>Cara kerja: Next proxy ke Lab 06/DB; hasil: 201 + X-Request-ID, lalu GET 200.</a:t>
+            </a:r>
+          </a:p>
+        </p:txBody>
+      </p:sp>
+    </p:spTree>
+  </p:cSld>
+  <p:clrMapOvr>
+    <a:masterClrMapping/>
+  </p:clrMapOvr>
+</p:sld>
+</file>
+
+<file path=ppt/slides/slide17.xml><?xml version="1.0" encoding="utf-8"?>
+<p:sld xmlns:a="http://schemas.openxmlformats.org/drawingml/2006/main" xmlns:p="http://schemas.openxmlformats.org/presentationml/2006/main" xmlns:r="http://schemas.openxmlformats.org/officeDocument/2006/relationships">
+  <p:cSld>
+    <p:spTree>
+      <p:nvGrpSpPr>
+        <p:cNvPr id="1" name=""/>
+        <p:cNvGrpSpPr/>
+        <p:nvPr/>
+      </p:nvGrpSpPr>
+      <p:grpSpPr/>
+      <p:sp>
+        <p:nvSpPr>
+          <p:cNvPr id="2" name="Text 0">
+            <a:extLst>
+              <a:ext uri="{FF2B5EF4-FFF2-40B4-BE49-F238E27FC236}">
+                <a16:creationId xmlns:a16="http://schemas.microsoft.com/office/drawing/2014/main" id="{0B86DC9D-6623-4169-8C9C-3145D037D6C7}"/>
+              </a:ext>
+            </a:extLst>
+          </p:cNvPr>
+          <p:cNvSpPr>
+            <a:spLocks noGrp="1"/>
+          </p:cNvSpPr>
+          <p:nvPr/>
+        </p:nvSpPr>
+        <p:spPr>
+          <a:xfrm>
+            <a:off x="457200" y="6492240"/>
+            <a:ext cx="7315200" cy="274320"/>
+          </a:xfrm>
+          <a:prstGeom prst="rect">
+            <a:avLst/>
+          </a:prstGeom>
+          <a:noFill/>
+        </p:spPr>
+        <p:txBody>
+          <a:bodyPr wrap="square" lIns="0" tIns="0" rIns="0" bIns="0" anchor="ctr"/>
+          <a:lstStyle/>
+          <a:p>
+            <a:pPr marL="0" indent="0" algn="l">
+              <a:buNone/>
+            </a:pPr>
+            <a:r>
+              <a:rPr sz="900">
+                <a:solidFill>
+                  <a:srgbClr val="64748B"/>
+                </a:solidFill>
+                <a:latin typeface="Calibri"/>
+                <a:ea typeface="Calibri"/>
+                <a:cs typeface="Calibri"/>
+              </a:rPr>
+              <a:t>BINUS UNIVERSITY  |  Cloud Services  |  Praktikum 8</a:t>
+            </a:r>
+            <a:endParaRPr sz="900"/>
+          </a:p>
+        </p:txBody>
+      </p:sp>
+      <p:sp>
+        <p:nvSpPr>
+          <p:cNvPr id="3" name="Text 1">
+            <a:extLst>
+              <a:ext uri="{FF2B5EF4-FFF2-40B4-BE49-F238E27FC236}">
+                <a16:creationId xmlns:a16="http://schemas.microsoft.com/office/drawing/2014/main" id="{B7DEE372-5732-46B2-A5A3-CCDCD1213C21}"/>
+              </a:ext>
+            </a:extLst>
+          </p:cNvPr>
+          <p:cNvSpPr>
+            <a:spLocks noGrp="1"/>
+          </p:cNvSpPr>
+          <p:nvPr/>
+        </p:nvSpPr>
+        <p:spPr>
+          <a:xfrm>
+            <a:off x="11247120" y="6492240"/>
+            <a:ext cx="457200" cy="274320"/>
+          </a:xfrm>
+          <a:prstGeom prst="rect">
+            <a:avLst/>
+          </a:prstGeom>
+          <a:noFill/>
+        </p:spPr>
+        <p:txBody>
+          <a:bodyPr wrap="square" lIns="0" tIns="0" rIns="0" bIns="0" anchor="ctr"/>
+          <a:lstStyle/>
+          <a:p>
+            <a:pPr marL="0" indent="0" algn="r">
+              <a:buNone/>
+            </a:pPr>
+            <a:r>
+              <a:rPr lang="en-US" sz="900" b="1">
+                <a:solidFill>
+                  <a:srgbClr val="64748B"/>
+                </a:solidFill>
+                <a:latin typeface="Calibri"/>
+                <a:ea typeface="Calibri"/>
+                <a:cs typeface="Calibri"/>
+              </a:rPr>
+              <a:t>15</a:t>
+            </a:r>
+            <a:endParaRPr sz="900"/>
+          </a:p>
+        </p:txBody>
+      </p:sp>
+      <p:sp>
+        <p:nvSpPr>
+          <p:cNvPr id="4" name="Shape 2">
+            <a:extLst>
+              <a:ext uri="{FF2B5EF4-FFF2-40B4-BE49-F238E27FC236}">
+                <a16:creationId xmlns:a16="http://schemas.microsoft.com/office/drawing/2014/main" id="{6444FE1B-E38D-44B3-AEA5-6826CCE7CA16}"/>
+              </a:ext>
+            </a:extLst>
+          </p:cNvPr>
+          <p:cNvSpPr>
+            <a:spLocks noGrp="1"/>
+          </p:cNvSpPr>
+          <p:nvPr/>
+        </p:nvSpPr>
+        <p:spPr>
+          <a:xfrm>
+            <a:off x="457200" y="6446520"/>
+            <a:ext cx="228600" cy="36576"/>
+          </a:xfrm>
+          <a:prstGeom prst="rect">
+            <a:avLst/>
+          </a:prstGeom>
+          <a:solidFill>
+            <a:srgbClr val="F37021"/>
+          </a:solidFill>
+          <a:ln w="12700">
+            <a:solidFill>
+              <a:srgbClr val="F37021"/>
+            </a:solidFill>
+            <a:prstDash val="solid"/>
+          </a:ln>
+        </p:spPr>
+      </p:sp>
+      <p:pic>
+        <p:nvPicPr>
+          <p:cNvPr id="5" name="Picture 4" descr="image.png"/>
+          <p:cNvPicPr>
+            <a:picLocks noChangeAspect="1"/>
+          </p:cNvPicPr>
+          <p:nvPr/>
+        </p:nvPicPr>
+        <p:blipFill>
+          <a:blip r:embed="rId2"/>
+          <a:stretch>
+            <a:fillRect/>
+          </a:stretch>
+        </p:blipFill>
+        <p:spPr>
+          <a:xfrm>
+            <a:off x="274320" y="164592"/>
+            <a:ext cx="914400" cy="603504"/>
+          </a:xfrm>
+          <a:prstGeom prst="rect">
+            <a:avLst/>
+          </a:prstGeom>
+        </p:spPr>
+      </p:pic>
+      <p:pic>
+        <p:nvPicPr>
+          <p:cNvPr id="6" name="Picture 5" descr="image.png"/>
+          <p:cNvPicPr>
+            <a:picLocks noChangeAspect="1"/>
+          </p:cNvPicPr>
+          <p:nvPr/>
+        </p:nvPicPr>
+        <p:blipFill>
+          <a:blip r:embed="rId3"/>
+          <a:stretch>
+            <a:fillRect/>
+          </a:stretch>
+        </p:blipFill>
+        <p:spPr>
+          <a:xfrm>
+            <a:off x="10881360" y="182880"/>
+            <a:ext cx="1005840" cy="512064"/>
+          </a:xfrm>
+          <a:prstGeom prst="rect">
+            <a:avLst/>
+          </a:prstGeom>
+        </p:spPr>
+      </p:pic>
+      <p:sp>
+        <p:nvSpPr>
+          <p:cNvPr id="7" name="Shape 3">
+            <a:extLst>
+              <a:ext uri="{FF2B5EF4-FFF2-40B4-BE49-F238E27FC236}">
+                <a16:creationId xmlns:a16="http://schemas.microsoft.com/office/drawing/2014/main" id="{36B0E2A9-8B0F-4E12-8FC4-67BFE3E2DE48}"/>
+              </a:ext>
+            </a:extLst>
+          </p:cNvPr>
+          <p:cNvSpPr>
+            <a:spLocks noGrp="1"/>
+          </p:cNvSpPr>
+          <p:nvPr/>
+        </p:nvSpPr>
+        <p:spPr>
+          <a:xfrm>
+            <a:off x="457200" y="868680"/>
+            <a:ext cx="11247120" cy="0"/>
+          </a:xfrm>
+          <a:prstGeom prst="line">
+            <a:avLst/>
+          </a:prstGeom>
+          <a:noFill/>
+          <a:ln w="12700">
+            <a:solidFill>
+              <a:srgbClr val="E2E8F0"/>
+            </a:solidFill>
+            <a:prstDash val="solid"/>
+          </a:ln>
+        </p:spPr>
+      </p:sp>
+      <p:sp>
+        <p:nvSpPr>
+          <p:cNvPr id="8" name="Text 4">
+            <a:extLst>
+              <a:ext uri="{FF2B5EF4-FFF2-40B4-BE49-F238E27FC236}">
+                <a16:creationId xmlns:a16="http://schemas.microsoft.com/office/drawing/2014/main" id="{14FC51D3-657E-4EAF-997E-6D6EBC36EF94}"/>
+              </a:ext>
+            </a:extLst>
+          </p:cNvPr>
+          <p:cNvSpPr>
+            <a:spLocks noGrp="1"/>
+          </p:cNvSpPr>
+          <p:nvPr/>
+        </p:nvSpPr>
+        <p:spPr>
+          <a:xfrm>
+            <a:off x="2011680" y="182880"/>
+            <a:ext cx="8138160" cy="502920"/>
+          </a:xfrm>
+          <a:prstGeom prst="rect">
+            <a:avLst/>
+          </a:prstGeom>
+          <a:noFill/>
+        </p:spPr>
+        <p:txBody>
+          <a:bodyPr wrap="square" lIns="0" tIns="0" rIns="0" bIns="0" anchor="ctr"/>
+          <a:lstStyle/>
+          <a:p>
+            <a:pPr marL="0" indent="0" algn="ctr">
+              <a:buNone/>
+            </a:pPr>
+            <a:r>
+              <a:rPr lang="en-US" sz="2200" b="1">
+                <a:solidFill>
+                  <a:srgbClr val="1976D2"/>
+                </a:solidFill>
+                <a:latin typeface="Calibri"/>
+                <a:ea typeface="Calibri"/>
+                <a:cs typeface="Calibri"/>
+              </a:rPr>
+              <a:t>Bukti 5a | Validasi 400</a:t>
+            </a:r>
+            <a:endParaRPr sz="2200"/>
+          </a:p>
+        </p:txBody>
+      </p:sp>
+      <p:sp>
+        <p:nvSpPr>
+          <p:cNvPr id="9" name="Text 5">
+            <a:extLst>
+              <a:ext uri="{FF2B5EF4-FFF2-40B4-BE49-F238E27FC236}">
+                <a16:creationId xmlns:a16="http://schemas.microsoft.com/office/drawing/2014/main" id="{7E594147-411E-4AC6-83CD-7B64DE78AA3C}"/>
+              </a:ext>
+            </a:extLst>
+          </p:cNvPr>
+          <p:cNvSpPr>
+            <a:spLocks noGrp="1"/>
+          </p:cNvSpPr>
+          <p:nvPr/>
+        </p:nvSpPr>
+        <p:spPr>
+          <a:xfrm>
+            <a:off x="457200" y="960120"/>
+            <a:ext cx="11247120" cy="320040"/>
+          </a:xfrm>
+          <a:prstGeom prst="rect">
+            <a:avLst/>
+          </a:prstGeom>
+          <a:noFill/>
+        </p:spPr>
+        <p:txBody>
+          <a:bodyPr wrap="square" lIns="0" tIns="0" rIns="0" bIns="0" anchor="ctr"/>
+          <a:lstStyle/>
+          <a:p>
+            <a:pPr marL="0" indent="0" algn="ctr">
+              <a:buNone/>
+            </a:pPr>
+            <a:r>
+              <a:rPr lang="en-US" sz="1200" i="1">
+                <a:solidFill>
+                  <a:srgbClr val="64748B"/>
+                </a:solidFill>
+                <a:latin typeface="Calibri"/>
+                <a:ea typeface="Calibri"/>
+                <a:cs typeface="Calibri"/>
+              </a:rPr>
+              <a:t>Dua input salah ditolak sebelum mencapai API Lab 06</a:t>
+            </a:r>
+            <a:endParaRPr sz="1200"/>
+          </a:p>
+        </p:txBody>
+      </p:sp>
+      <p:pic>
+        <p:nvPicPr>
+          <p:cNvPr id="10" name="Picture 9" descr="17_validasi_aktual.png"/>
+          <p:cNvPicPr>
+            <a:picLocks noChangeAspect="1"/>
+          </p:cNvPicPr>
+          <p:nvPr/>
+        </p:nvPicPr>
+        <p:blipFill>
+          <a:blip r:embed="rId4"/>
+          <a:stretch>
+            <a:fillRect/>
+          </a:stretch>
+        </p:blipFill>
+        <p:spPr>
+          <a:xfrm>
+            <a:off x="1726550" y="1463040"/>
+            <a:ext cx="8754139" cy="4343400"/>
+          </a:xfrm>
+          <a:prstGeom prst="rect">
+            <a:avLst/>
+          </a:prstGeom>
+        </p:spPr>
+      </p:pic>
+      <p:sp>
+        <p:nvSpPr>
+          <p:cNvPr id="11" name="TextBox 10"/>
+          <p:cNvSpPr txBox="1"/>
+          <p:nvPr/>
+        </p:nvSpPr>
+        <p:spPr>
+          <a:xfrm>
+            <a:off x="685800" y="5797296"/>
+            <a:ext cx="10881360" cy="566928"/>
+          </a:xfrm>
+          <a:prstGeom prst="rect">
+            <a:avLst/>
+          </a:prstGeom>
+          <a:noFill/>
+        </p:spPr>
+        <p:txBody>
+          <a:bodyPr wrap="square">
+            <a:spAutoFit/>
+          </a:bodyPr>
+          <a:lstStyle/>
+          <a:p>
+            <a:pPr>
+              <a:defRPr sz="1400">
+                <a:solidFill>
+                  <a:srgbClr val="0F336F"/>
+                </a:solidFill>
+                <a:latin typeface="Arial"/>
+              </a:defRPr>
+            </a:pPr>
+            <a:r>
+              <a:t>Perintah: POST tanpa title dan POST JSON rusak. Fungsi: uji validasi server.</a:t>
+            </a:r>
+            <a:br/>
+            <a:r>
+              <a:t>Cara kerja: Route Handler menolak sebelum proxy; hasil: keduanya HTTP 400.</a:t>
+            </a:r>
+          </a:p>
+        </p:txBody>
+      </p:sp>
+    </p:spTree>
+  </p:cSld>
+  <p:clrMapOvr>
+    <a:masterClrMapping/>
+  </p:clrMapOvr>
+</p:sld>
+</file>
+
+<file path=ppt/slides/slide18.xml><?xml version="1.0" encoding="utf-8"?>
+<p:sld xmlns:a="http://schemas.openxmlformats.org/drawingml/2006/main" xmlns:p="http://schemas.openxmlformats.org/presentationml/2006/main" xmlns:r="http://schemas.openxmlformats.org/officeDocument/2006/relationships">
+  <p:cSld>
+    <p:spTree>
+      <p:nvGrpSpPr>
+        <p:cNvPr id="1" name=""/>
+        <p:cNvGrpSpPr/>
+        <p:nvPr/>
+      </p:nvGrpSpPr>
+      <p:grpSpPr/>
+      <p:sp>
+        <p:nvSpPr>
+          <p:cNvPr id="2" name="Text 0">
+            <a:extLst>
+              <a:ext uri="{FF2B5EF4-FFF2-40B4-BE49-F238E27FC236}">
+                <a16:creationId xmlns:a16="http://schemas.microsoft.com/office/drawing/2014/main" id="{0B86DC9D-6623-4169-8C9C-3145D037D6C7}"/>
+              </a:ext>
+            </a:extLst>
+          </p:cNvPr>
+          <p:cNvSpPr>
+            <a:spLocks noGrp="1"/>
+          </p:cNvSpPr>
+          <p:nvPr/>
+        </p:nvSpPr>
+        <p:spPr>
+          <a:xfrm>
+            <a:off x="457200" y="6492240"/>
+            <a:ext cx="7315200" cy="274320"/>
+          </a:xfrm>
+          <a:prstGeom prst="rect">
+            <a:avLst/>
+          </a:prstGeom>
+          <a:noFill/>
+        </p:spPr>
+        <p:txBody>
+          <a:bodyPr wrap="square" lIns="0" tIns="0" rIns="0" bIns="0" anchor="ctr"/>
+          <a:lstStyle/>
+          <a:p>
+            <a:pPr marL="0" indent="0" algn="l">
+              <a:buNone/>
+            </a:pPr>
+            <a:r>
+              <a:rPr sz="900">
+                <a:solidFill>
+                  <a:srgbClr val="64748B"/>
+                </a:solidFill>
+                <a:latin typeface="Calibri"/>
+                <a:ea typeface="Calibri"/>
+                <a:cs typeface="Calibri"/>
+              </a:rPr>
+              <a:t>BINUS UNIVERSITY  |  Cloud Services  |  Praktikum 8</a:t>
+            </a:r>
+            <a:endParaRPr sz="900"/>
+          </a:p>
+        </p:txBody>
+      </p:sp>
+      <p:sp>
+        <p:nvSpPr>
+          <p:cNvPr id="3" name="Text 1">
+            <a:extLst>
+              <a:ext uri="{FF2B5EF4-FFF2-40B4-BE49-F238E27FC236}">
+                <a16:creationId xmlns:a16="http://schemas.microsoft.com/office/drawing/2014/main" id="{B7DEE372-5732-46B2-A5A3-CCDCD1213C21}"/>
+              </a:ext>
+            </a:extLst>
+          </p:cNvPr>
+          <p:cNvSpPr>
+            <a:spLocks noGrp="1"/>
+          </p:cNvSpPr>
+          <p:nvPr/>
+        </p:nvSpPr>
+        <p:spPr>
+          <a:xfrm>
+            <a:off x="11247120" y="6492240"/>
+            <a:ext cx="457200" cy="274320"/>
+          </a:xfrm>
+          <a:prstGeom prst="rect">
+            <a:avLst/>
+          </a:prstGeom>
+          <a:noFill/>
+        </p:spPr>
+        <p:txBody>
+          <a:bodyPr wrap="square" lIns="0" tIns="0" rIns="0" bIns="0" anchor="ctr"/>
+          <a:lstStyle/>
+          <a:p>
+            <a:pPr marL="0" indent="0" algn="r">
+              <a:buNone/>
+            </a:pPr>
+            <a:r>
+              <a:rPr lang="en-US" sz="900" b="1">
+                <a:solidFill>
+                  <a:srgbClr val="64748B"/>
+                </a:solidFill>
+                <a:latin typeface="Calibri"/>
+                <a:ea typeface="Calibri"/>
+                <a:cs typeface="Calibri"/>
+              </a:rPr>
+              <a:t>16</a:t>
+            </a:r>
+            <a:endParaRPr sz="900"/>
+          </a:p>
+        </p:txBody>
+      </p:sp>
+      <p:sp>
+        <p:nvSpPr>
+          <p:cNvPr id="4" name="Shape 2">
+            <a:extLst>
+              <a:ext uri="{FF2B5EF4-FFF2-40B4-BE49-F238E27FC236}">
+                <a16:creationId xmlns:a16="http://schemas.microsoft.com/office/drawing/2014/main" id="{6444FE1B-E38D-44B3-AEA5-6826CCE7CA16}"/>
+              </a:ext>
+            </a:extLst>
+          </p:cNvPr>
+          <p:cNvSpPr>
+            <a:spLocks noGrp="1"/>
+          </p:cNvSpPr>
+          <p:nvPr/>
+        </p:nvSpPr>
+        <p:spPr>
+          <a:xfrm>
+            <a:off x="457200" y="6446520"/>
+            <a:ext cx="228600" cy="36576"/>
+          </a:xfrm>
+          <a:prstGeom prst="rect">
+            <a:avLst/>
+          </a:prstGeom>
+          <a:solidFill>
+            <a:srgbClr val="F37021"/>
+          </a:solidFill>
+          <a:ln w="12700">
+            <a:solidFill>
+              <a:srgbClr val="F37021"/>
+            </a:solidFill>
+            <a:prstDash val="solid"/>
+          </a:ln>
+        </p:spPr>
+      </p:sp>
+      <p:pic>
+        <p:nvPicPr>
+          <p:cNvPr id="5" name="Picture 4" descr="image.png"/>
+          <p:cNvPicPr>
+            <a:picLocks noChangeAspect="1"/>
+          </p:cNvPicPr>
+          <p:nvPr/>
+        </p:nvPicPr>
+        <p:blipFill>
+          <a:blip r:embed="rId2"/>
+          <a:stretch>
+            <a:fillRect/>
+          </a:stretch>
+        </p:blipFill>
+        <p:spPr>
+          <a:xfrm>
+            <a:off x="274320" y="164592"/>
+            <a:ext cx="914400" cy="603504"/>
+          </a:xfrm>
+          <a:prstGeom prst="rect">
+            <a:avLst/>
+          </a:prstGeom>
+        </p:spPr>
+      </p:pic>
+      <p:pic>
+        <p:nvPicPr>
+          <p:cNvPr id="6" name="Picture 5" descr="image.png"/>
+          <p:cNvPicPr>
+            <a:picLocks noChangeAspect="1"/>
+          </p:cNvPicPr>
+          <p:nvPr/>
+        </p:nvPicPr>
+        <p:blipFill>
+          <a:blip r:embed="rId3"/>
+          <a:stretch>
+            <a:fillRect/>
+          </a:stretch>
+        </p:blipFill>
+        <p:spPr>
+          <a:xfrm>
+            <a:off x="10881360" y="182880"/>
+            <a:ext cx="1005840" cy="512064"/>
+          </a:xfrm>
+          <a:prstGeom prst="rect">
+            <a:avLst/>
+          </a:prstGeom>
+        </p:spPr>
+      </p:pic>
+      <p:sp>
+        <p:nvSpPr>
+          <p:cNvPr id="7" name="Shape 3">
+            <a:extLst>
+              <a:ext uri="{FF2B5EF4-FFF2-40B4-BE49-F238E27FC236}">
+                <a16:creationId xmlns:a16="http://schemas.microsoft.com/office/drawing/2014/main" id="{36B0E2A9-8B0F-4E12-8FC4-67BFE3E2DE48}"/>
+              </a:ext>
+            </a:extLst>
+          </p:cNvPr>
+          <p:cNvSpPr>
+            <a:spLocks noGrp="1"/>
+          </p:cNvSpPr>
+          <p:nvPr/>
+        </p:nvSpPr>
+        <p:spPr>
+          <a:xfrm>
+            <a:off x="457200" y="868680"/>
+            <a:ext cx="11247120" cy="0"/>
+          </a:xfrm>
+          <a:prstGeom prst="line">
+            <a:avLst/>
+          </a:prstGeom>
+          <a:noFill/>
+          <a:ln w="12700">
+            <a:solidFill>
+              <a:srgbClr val="E2E8F0"/>
+            </a:solidFill>
+            <a:prstDash val="solid"/>
+          </a:ln>
+        </p:spPr>
+      </p:sp>
+      <p:sp>
+        <p:nvSpPr>
+          <p:cNvPr id="8" name="Text 4">
+            <a:extLst>
+              <a:ext uri="{FF2B5EF4-FFF2-40B4-BE49-F238E27FC236}">
+                <a16:creationId xmlns:a16="http://schemas.microsoft.com/office/drawing/2014/main" id="{14FC51D3-657E-4EAF-997E-6D6EBC36EF94}"/>
+              </a:ext>
+            </a:extLst>
+          </p:cNvPr>
+          <p:cNvSpPr>
+            <a:spLocks noGrp="1"/>
+          </p:cNvSpPr>
+          <p:nvPr/>
+        </p:nvSpPr>
+        <p:spPr>
+          <a:xfrm>
+            <a:off x="2011680" y="182880"/>
+            <a:ext cx="8138160" cy="502920"/>
+          </a:xfrm>
+          <a:prstGeom prst="rect">
+            <a:avLst/>
+          </a:prstGeom>
+          <a:noFill/>
+        </p:spPr>
+        <p:txBody>
+          <a:bodyPr wrap="square" lIns="0" tIns="0" rIns="0" bIns="0" anchor="ctr"/>
+          <a:lstStyle/>
+          <a:p>
+            <a:pPr marL="0" indent="0" algn="ctr">
+              <a:buNone/>
+            </a:pPr>
+            <a:r>
+              <a:rPr lang="en-US" sz="2200" b="1">
+                <a:solidFill>
+                  <a:srgbClr val="1976D2"/>
+                </a:solidFill>
+                <a:latin typeface="Calibri"/>
+                <a:ea typeface="Calibri"/>
+                <a:cs typeface="Calibri"/>
+              </a:rPr>
+              <a:t>Bukti 5b | Sembilan cek lulus</a:t>
+            </a:r>
+            <a:endParaRPr sz="2200"/>
+          </a:p>
+        </p:txBody>
+      </p:sp>
+      <p:sp>
+        <p:nvSpPr>
+          <p:cNvPr id="9" name="Text 5">
+            <a:extLst>
+              <a:ext uri="{FF2B5EF4-FFF2-40B4-BE49-F238E27FC236}">
+                <a16:creationId xmlns:a16="http://schemas.microsoft.com/office/drawing/2014/main" id="{7E594147-411E-4AC6-83CD-7B64DE78AA3C}"/>
+              </a:ext>
+            </a:extLst>
+          </p:cNvPr>
+          <p:cNvSpPr>
+            <a:spLocks noGrp="1"/>
+          </p:cNvSpPr>
+          <p:nvPr/>
+        </p:nvSpPr>
+        <p:spPr>
+          <a:xfrm>
+            <a:off x="457200" y="960120"/>
+            <a:ext cx="11247120" cy="320040"/>
+          </a:xfrm>
+          <a:prstGeom prst="rect">
+            <a:avLst/>
+          </a:prstGeom>
+          <a:noFill/>
+        </p:spPr>
+        <p:txBody>
+          <a:bodyPr wrap="square" lIns="0" tIns="0" rIns="0" bIns="0" anchor="ctr"/>
+          <a:lstStyle/>
+          <a:p>
+            <a:pPr marL="0" indent="0" algn="ctr">
+              <a:buNone/>
+            </a:pPr>
+            <a:r>
+              <a:rPr lang="en-US" sz="1200" i="1">
+                <a:solidFill>
+                  <a:srgbClr val="64748B"/>
+                </a:solidFill>
+                <a:latin typeface="Calibri"/>
+                <a:ea typeface="Calibri"/>
+                <a:cs typeface="Calibri"/>
+              </a:rPr>
+              <a:t>Checker berjalan ketika API Lab 06 sehat</a:t>
+            </a:r>
+            <a:endParaRPr sz="1200"/>
+          </a:p>
+        </p:txBody>
+      </p:sp>
+      <p:pic>
+        <p:nvPicPr>
+          <p:cNvPr id="10" name="Picture 9" descr="08_challenge_output.png"/>
+          <p:cNvPicPr>
+            <a:picLocks noChangeAspect="1"/>
+          </p:cNvPicPr>
+          <p:nvPr/>
+        </p:nvPicPr>
+        <p:blipFill>
+          <a:blip r:embed="rId4"/>
+          <a:stretch>
+            <a:fillRect/>
+          </a:stretch>
+        </p:blipFill>
+        <p:spPr>
+          <a:xfrm>
+            <a:off x="640080" y="1466614"/>
+            <a:ext cx="10927080" cy="4336252"/>
+          </a:xfrm>
+          <a:prstGeom prst="rect">
+            <a:avLst/>
+          </a:prstGeom>
+        </p:spPr>
+      </p:pic>
+      <p:sp>
+        <p:nvSpPr>
+          <p:cNvPr id="11" name="TextBox 10"/>
+          <p:cNvSpPr txBox="1"/>
+          <p:nvPr/>
+        </p:nvSpPr>
+        <p:spPr>
+          <a:xfrm>
+            <a:off x="685800" y="5797296"/>
+            <a:ext cx="10881360" cy="566928"/>
+          </a:xfrm>
+          <a:prstGeom prst="rect">
+            <a:avLst/>
+          </a:prstGeom>
+          <a:noFill/>
+        </p:spPr>
+        <p:txBody>
+          <a:bodyPr wrap="square">
+            <a:spAutoFit/>
+          </a:bodyPr>
+          <a:lstStyle/>
+          <a:p>
+            <a:pPr>
+              <a:defRPr sz="1400">
+                <a:solidFill>
+                  <a:srgbClr val="0F336F"/>
+                </a:solidFill>
+                <a:latin typeface="Arial"/>
+              </a:defRPr>
+            </a:pPr>
+            <a:r>
+              <a:t>Perintah: npm run check:local. Fungsi: verifikasi kontrak aplikasi.</a:t>
+            </a:r>
+            <a:br/>
+            <a:r>
+              <a:t>Cara kerja: skrip menguji GET/POST dan validasi; hasil: 9 PASS, 0 FAIL.</a:t>
+            </a:r>
+          </a:p>
+        </p:txBody>
+      </p:sp>
+    </p:spTree>
+  </p:cSld>
+  <p:clrMapOvr>
+    <a:masterClrMapping/>
+  </p:clrMapOvr>
+</p:sld>
+</file>
+
+<file path=ppt/slides/slide19.xml><?xml version="1.0" encoding="utf-8"?>
+<p:sld xmlns:a="http://schemas.openxmlformats.org/drawingml/2006/main" xmlns:p="http://schemas.openxmlformats.org/presentationml/2006/main" xmlns:r="http://schemas.openxmlformats.org/officeDocument/2006/relationships">
+  <p:cSld>
+    <p:spTree>
+      <p:nvGrpSpPr>
+        <p:cNvPr id="1" name=""/>
+        <p:cNvGrpSpPr/>
+        <p:nvPr/>
+      </p:nvGrpSpPr>
+      <p:grpSpPr/>
+      <p:sp>
+        <p:nvSpPr>
+          <p:cNvPr id="2" name="Text 0">
+            <a:extLst>
+              <a:ext uri="{FF2B5EF4-FFF2-40B4-BE49-F238E27FC236}">
+                <a16:creationId xmlns:a16="http://schemas.microsoft.com/office/drawing/2014/main" id="{0B86DC9D-6623-4169-8C9C-3145D037D6C7}"/>
+              </a:ext>
+            </a:extLst>
+          </p:cNvPr>
+          <p:cNvSpPr>
+            <a:spLocks noGrp="1"/>
+          </p:cNvSpPr>
+          <p:nvPr/>
+        </p:nvSpPr>
+        <p:spPr>
+          <a:xfrm>
+            <a:off x="457200" y="6492240"/>
+            <a:ext cx="7315200" cy="274320"/>
+          </a:xfrm>
+          <a:prstGeom prst="rect">
+            <a:avLst/>
+          </a:prstGeom>
+          <a:noFill/>
+        </p:spPr>
+        <p:txBody>
+          <a:bodyPr wrap="square" lIns="0" tIns="0" rIns="0" bIns="0" anchor="ctr"/>
+          <a:lstStyle/>
+          <a:p>
+            <a:pPr marL="0" indent="0" algn="l">
+              <a:buNone/>
+            </a:pPr>
+            <a:r>
+              <a:rPr sz="900">
+                <a:solidFill>
+                  <a:srgbClr val="64748B"/>
+                </a:solidFill>
+                <a:latin typeface="Calibri"/>
+                <a:ea typeface="Calibri"/>
+                <a:cs typeface="Calibri"/>
+              </a:rPr>
+              <a:t>BINUS UNIVERSITY  |  Cloud Services  |  Praktikum 8</a:t>
+            </a:r>
+            <a:endParaRPr sz="900"/>
+          </a:p>
+        </p:txBody>
+      </p:sp>
+      <p:sp>
+        <p:nvSpPr>
+          <p:cNvPr id="3" name="Text 1">
+            <a:extLst>
+              <a:ext uri="{FF2B5EF4-FFF2-40B4-BE49-F238E27FC236}">
+                <a16:creationId xmlns:a16="http://schemas.microsoft.com/office/drawing/2014/main" id="{B7DEE372-5732-46B2-A5A3-CCDCD1213C21}"/>
+              </a:ext>
+            </a:extLst>
+          </p:cNvPr>
+          <p:cNvSpPr>
+            <a:spLocks noGrp="1"/>
+          </p:cNvSpPr>
+          <p:nvPr/>
+        </p:nvSpPr>
+        <p:spPr>
+          <a:xfrm>
+            <a:off x="11247120" y="6492240"/>
+            <a:ext cx="457200" cy="274320"/>
+          </a:xfrm>
+          <a:prstGeom prst="rect">
+            <a:avLst/>
+          </a:prstGeom>
+          <a:noFill/>
+        </p:spPr>
+        <p:txBody>
+          <a:bodyPr wrap="square" lIns="0" tIns="0" rIns="0" bIns="0" anchor="ctr"/>
+          <a:lstStyle/>
+          <a:p>
+            <a:pPr marL="0" indent="0" algn="r">
+              <a:buNone/>
+            </a:pPr>
+            <a:r>
+              <a:rPr lang="en-US" sz="900" b="1">
+                <a:solidFill>
+                  <a:srgbClr val="64748B"/>
+                </a:solidFill>
+                <a:latin typeface="Calibri"/>
+                <a:ea typeface="Calibri"/>
+                <a:cs typeface="Calibri"/>
+              </a:rPr>
+              <a:t>19</a:t>
+            </a:r>
+            <a:endParaRPr sz="900"/>
+          </a:p>
+        </p:txBody>
+      </p:sp>
+      <p:sp>
+        <p:nvSpPr>
+          <p:cNvPr id="4" name="Shape 2">
+            <a:extLst>
+              <a:ext uri="{FF2B5EF4-FFF2-40B4-BE49-F238E27FC236}">
+                <a16:creationId xmlns:a16="http://schemas.microsoft.com/office/drawing/2014/main" id="{6444FE1B-E38D-44B3-AEA5-6826CCE7CA16}"/>
+              </a:ext>
+            </a:extLst>
+          </p:cNvPr>
+          <p:cNvSpPr>
+            <a:spLocks noGrp="1"/>
+          </p:cNvSpPr>
+          <p:nvPr/>
+        </p:nvSpPr>
+        <p:spPr>
+          <a:xfrm>
+            <a:off x="457200" y="6446520"/>
+            <a:ext cx="228600" cy="36576"/>
+          </a:xfrm>
+          <a:prstGeom prst="rect">
+            <a:avLst/>
+          </a:prstGeom>
+          <a:solidFill>
+            <a:srgbClr val="F37021"/>
+          </a:solidFill>
+          <a:ln w="12700">
+            <a:solidFill>
+              <a:srgbClr val="F37021"/>
+            </a:solidFill>
+            <a:prstDash val="solid"/>
+          </a:ln>
+        </p:spPr>
+      </p:sp>
+      <p:pic>
+        <p:nvPicPr>
+          <p:cNvPr id="5" name="Picture 4" descr="image.png"/>
+          <p:cNvPicPr>
+            <a:picLocks noChangeAspect="1"/>
+          </p:cNvPicPr>
+          <p:nvPr/>
+        </p:nvPicPr>
+        <p:blipFill>
+          <a:blip r:embed="rId2"/>
+          <a:stretch>
+            <a:fillRect/>
+          </a:stretch>
+        </p:blipFill>
+        <p:spPr>
+          <a:xfrm>
+            <a:off x="274320" y="164592"/>
+            <a:ext cx="914400" cy="603504"/>
+          </a:xfrm>
+          <a:prstGeom prst="rect">
+            <a:avLst/>
+          </a:prstGeom>
+        </p:spPr>
+      </p:pic>
+      <p:pic>
+        <p:nvPicPr>
+          <p:cNvPr id="6" name="Picture 5" descr="image.png"/>
+          <p:cNvPicPr>
+            <a:picLocks noChangeAspect="1"/>
+          </p:cNvPicPr>
+          <p:nvPr/>
+        </p:nvPicPr>
+        <p:blipFill>
+          <a:blip r:embed="rId3"/>
+          <a:stretch>
+            <a:fillRect/>
+          </a:stretch>
+        </p:blipFill>
+        <p:spPr>
+          <a:xfrm>
+            <a:off x="10881360" y="182880"/>
+            <a:ext cx="1005840" cy="512064"/>
+          </a:xfrm>
+          <a:prstGeom prst="rect">
+            <a:avLst/>
+          </a:prstGeom>
+        </p:spPr>
+      </p:pic>
+      <p:sp>
+        <p:nvSpPr>
+          <p:cNvPr id="7" name="Shape 3">
+            <a:extLst>
+              <a:ext uri="{FF2B5EF4-FFF2-40B4-BE49-F238E27FC236}">
+                <a16:creationId xmlns:a16="http://schemas.microsoft.com/office/drawing/2014/main" id="{36B0E2A9-8B0F-4E12-8FC4-67BFE3E2DE48}"/>
+              </a:ext>
+            </a:extLst>
+          </p:cNvPr>
+          <p:cNvSpPr>
+            <a:spLocks noGrp="1"/>
+          </p:cNvSpPr>
+          <p:nvPr/>
+        </p:nvSpPr>
+        <p:spPr>
+          <a:xfrm>
+            <a:off x="457200" y="868680"/>
+            <a:ext cx="11247120" cy="0"/>
+          </a:xfrm>
+          <a:prstGeom prst="line">
+            <a:avLst/>
+          </a:prstGeom>
+          <a:noFill/>
+          <a:ln w="12700">
+            <a:solidFill>
+              <a:srgbClr val="E2E8F0"/>
+            </a:solidFill>
+            <a:prstDash val="solid"/>
+          </a:ln>
+        </p:spPr>
+      </p:sp>
+      <p:sp>
+        <p:nvSpPr>
+          <p:cNvPr id="8" name="Text 4">
+            <a:extLst>
+              <a:ext uri="{FF2B5EF4-FFF2-40B4-BE49-F238E27FC236}">
+                <a16:creationId xmlns:a16="http://schemas.microsoft.com/office/drawing/2014/main" id="{14FC51D3-657E-4EAF-997E-6D6EBC36EF94}"/>
+              </a:ext>
+            </a:extLst>
+          </p:cNvPr>
+          <p:cNvSpPr>
+            <a:spLocks noGrp="1"/>
+          </p:cNvSpPr>
+          <p:nvPr/>
+        </p:nvSpPr>
+        <p:spPr>
+          <a:xfrm>
+            <a:off x="2011680" y="182880"/>
+            <a:ext cx="8138160" cy="502920"/>
+          </a:xfrm>
+          <a:prstGeom prst="rect">
+            <a:avLst/>
+          </a:prstGeom>
+          <a:noFill/>
+        </p:spPr>
+        <p:txBody>
+          <a:bodyPr wrap="square" lIns="0" tIns="0" rIns="0" bIns="0" anchor="ctr"/>
+          <a:lstStyle/>
+          <a:p>
+            <a:pPr marL="0" indent="0" algn="ctr">
+              <a:buNone/>
+            </a:pPr>
+            <a:r>
+              <a:rPr lang="en-US" sz="2200" b="1">
+                <a:solidFill>
+                  <a:srgbClr val="1976D2"/>
+                </a:solidFill>
+                <a:latin typeface="Calibri"/>
+                <a:ea typeface="Calibri"/>
+                <a:cs typeface="Calibri"/>
+              </a:rPr>
+              <a:t>Bukti 6 | Git mengabaikan file lokal</a:t>
+            </a:r>
+            <a:endParaRPr sz="2200"/>
+          </a:p>
+        </p:txBody>
+      </p:sp>
+      <p:sp>
+        <p:nvSpPr>
+          <p:cNvPr id="9" name="Text 5">
+            <a:extLst>
+              <a:ext uri="{FF2B5EF4-FFF2-40B4-BE49-F238E27FC236}">
+                <a16:creationId xmlns:a16="http://schemas.microsoft.com/office/drawing/2014/main" id="{7E594147-411E-4AC6-83CD-7B64DE78AA3C}"/>
+              </a:ext>
+            </a:extLst>
+          </p:cNvPr>
+          <p:cNvSpPr>
+            <a:spLocks noGrp="1"/>
+          </p:cNvSpPr>
+          <p:nvPr/>
+        </p:nvSpPr>
+        <p:spPr>
+          <a:xfrm>
+            <a:off x="457200" y="960120"/>
+            <a:ext cx="11247120" cy="320040"/>
+          </a:xfrm>
+          <a:prstGeom prst="rect">
+            <a:avLst/>
+          </a:prstGeom>
+          <a:noFill/>
+        </p:spPr>
+        <p:txBody>
+          <a:bodyPr wrap="square" lIns="0" tIns="0" rIns="0" bIns="0" anchor="ctr"/>
+          <a:lstStyle/>
+          <a:p>
+            <a:pPr marL="0" indent="0" algn="ctr">
+              <a:buNone/>
+            </a:pPr>
+            <a:r>
+              <a:rPr lang="en-US" sz="1200" i="1">
+                <a:solidFill>
+                  <a:srgbClr val="64748B"/>
+                </a:solidFill>
+                <a:latin typeface="Calibri"/>
+                <a:ea typeface="Calibri"/>
+                <a:cs typeface="Calibri"/>
+              </a:rPr>
+              <a:t>Periksa isi commit sebelum push repo milik mahasiswa</a:t>
+            </a:r>
+            <a:endParaRPr sz="1200"/>
+          </a:p>
+        </p:txBody>
+      </p:sp>
+      <p:pic>
+        <p:nvPicPr>
+          <p:cNvPr id="10" name="Picture 9" descr="20_git_ringkas_ppt.png"/>
+          <p:cNvPicPr>
+            <a:picLocks noChangeAspect="1"/>
+          </p:cNvPicPr>
+          <p:nvPr/>
+        </p:nvPicPr>
+        <p:blipFill>
+          <a:blip r:embed="rId4"/>
+          <a:stretch>
+            <a:fillRect/>
+          </a:stretch>
+        </p:blipFill>
+        <p:spPr>
+          <a:xfrm>
+            <a:off x="640080" y="1757524"/>
+            <a:ext cx="10927080" cy="3754432"/>
+          </a:xfrm>
+          <a:prstGeom prst="rect">
+            <a:avLst/>
+          </a:prstGeom>
+        </p:spPr>
+      </p:pic>
+      <p:sp>
+        <p:nvSpPr>
+          <p:cNvPr id="11" name="TextBox 10"/>
+          <p:cNvSpPr txBox="1"/>
+          <p:nvPr/>
+        </p:nvSpPr>
+        <p:spPr>
+          <a:xfrm>
+            <a:off x="685800" y="5797296"/>
+            <a:ext cx="10881360" cy="566928"/>
+          </a:xfrm>
+          <a:prstGeom prst="rect">
+            <a:avLst/>
+          </a:prstGeom>
+          <a:noFill/>
+        </p:spPr>
+        <p:txBody>
+          <a:bodyPr wrap="square">
+            <a:spAutoFit/>
+          </a:bodyPr>
+          <a:lstStyle/>
+          <a:p>
+            <a:pPr>
+              <a:defRPr sz="1400">
+                <a:solidFill>
+                  <a:srgbClr val="0F336F"/>
+                </a:solidFill>
+                <a:latin typeface="Arial"/>
+              </a:defRPr>
+            </a:pPr>
+            <a:r>
+              <a:t>Perintah: git check-ignore -v + git diff --cached --check. Fungsi: periksa commit.</a:t>
+            </a:r>
+            <a:br/>
+            <a:r>
+              <a:t>Cara kerja: .gitignore menyaring file lokal; hasil: env, node_modules, .next diabaikan.</a:t>
+            </a:r>
+          </a:p>
+        </p:txBody>
+      </p:sp>
+    </p:spTree>
   </p:cSld>
   <p:clrMapOvr>
     <a:masterClrMapping/>
@@ -7094,7 +10227,7 @@
                 <a:ea typeface="Calibri"/>
                 <a:cs typeface="Calibri"/>
               </a:rPr>
-              <a:t>4</a:t>
+              <a:t>5</a:t>
             </a:r>
             <a:endParaRPr sz="900"/>
           </a:p>
@@ -8269,7 +11402,7 @@
                 <a:ea typeface="Calibri"/>
                 <a:cs typeface="Calibri"/>
               </a:rPr>
-              <a:t>5</a:t>
+              <a:t>7</a:t>
             </a:r>
             <a:endParaRPr sz="900"/>
           </a:p>
@@ -9141,7 +12274,7 @@
                 <a:ea typeface="Calibri"/>
                 <a:cs typeface="Calibri"/>
               </a:rPr>
-              <a:t>6</a:t>
+              <a:t>8</a:t>
             </a:r>
             <a:endParaRPr sz="900"/>
           </a:p>
@@ -10316,7 +13449,7 @@
                 <a:ea typeface="Calibri"/>
                 <a:cs typeface="Calibri"/>
               </a:rPr>
-              <a:t>7</a:t>
+              <a:t>9</a:t>
             </a:r>
             <a:endParaRPr sz="900"/>
           </a:p>
@@ -11491,7 +14624,7 @@
                 <a:ea typeface="Calibri"/>
                 <a:cs typeface="Calibri"/>
               </a:rPr>
-              <a:t>8</a:t>
+              <a:t>11</a:t>
             </a:r>
             <a:endParaRPr sz="900"/>
           </a:p>
@@ -12366,7 +15499,7 @@
                 <a:ea typeface="Calibri"/>
                 <a:cs typeface="Calibri"/>
               </a:rPr>
-              <a:t>9</a:t>
+              <a:t>12</a:t>
             </a:r>
             <a:endParaRPr sz="900"/>
           </a:p>

</xml_diff>

<commit_message>
Align Lab 08 with group project and publish revised theory/practical slides
</commit_message>
<xml_diff>
--- a/slides/LAB08_Cloud_Notes_Nextjs_Bukti_Live.pptx
+++ b/slides/LAB08_Cloud_Notes_Nextjs_Bukti_Live.pptx
@@ -2,31 +2,31 @@
 <file path=ppt/presentation.xml><?xml version="1.0" encoding="utf-8"?>
 <p:presentation xmlns:p="http://schemas.openxmlformats.org/presentationml/2006/main">
   <p:sldMasterIdLst>
-    <p:sldMasterId xmlns:r="http://schemas.openxmlformats.org/officeDocument/2006/relationships" id="2147483648" r:id="R98e5ddcd472d4423"/>
+    <p:sldMasterId xmlns:r="http://schemas.openxmlformats.org/officeDocument/2006/relationships" id="2147483648" r:id="R6e7be2ea59924af6"/>
   </p:sldMasterIdLst>
   <p:notesMasterIdLst>
-    <p:notesMasterId xmlns:r="http://schemas.openxmlformats.org/officeDocument/2006/relationships" r:id="R1546c82ba3e94d71"/>
+    <p:notesMasterId xmlns:r="http://schemas.openxmlformats.org/officeDocument/2006/relationships" r:id="Rc52ac088ebc84768"/>
   </p:notesMasterIdLst>
   <p:sldIdLst>
-    <p:sldId xmlns:r="http://schemas.openxmlformats.org/officeDocument/2006/relationships" id="256" r:id="Rf6cda5519e614121"/>
-    <p:sldId xmlns:r="http://schemas.openxmlformats.org/officeDocument/2006/relationships" id="257" r:id="R7f1e63c74e2046b3"/>
-    <p:sldId xmlns:r="http://schemas.openxmlformats.org/officeDocument/2006/relationships" id="258" r:id="R71ff617a8d334451"/>
-    <p:sldId xmlns:r="http://schemas.openxmlformats.org/officeDocument/2006/relationships" id="259" r:id="R6fd2998db4af424c"/>
-    <p:sldId xmlns:r="http://schemas.openxmlformats.org/officeDocument/2006/relationships" id="260" r:id="R2f14d20f6316452a"/>
-    <p:sldId xmlns:r="http://schemas.openxmlformats.org/officeDocument/2006/relationships" id="261" r:id="R1d751a7ff9f447b9"/>
-    <p:sldId xmlns:r="http://schemas.openxmlformats.org/officeDocument/2006/relationships" id="262" r:id="Rd360b0fc89b34e6b"/>
-    <p:sldId xmlns:r="http://schemas.openxmlformats.org/officeDocument/2006/relationships" id="263" r:id="R0975ef2f4d174a69"/>
-    <p:sldId xmlns:r="http://schemas.openxmlformats.org/officeDocument/2006/relationships" id="264" r:id="Rd671be2f639d46cb"/>
-    <p:sldId xmlns:r="http://schemas.openxmlformats.org/officeDocument/2006/relationships" id="265" r:id="Rb7cdbc9a34d9457f"/>
-    <p:sldId xmlns:r="http://schemas.openxmlformats.org/officeDocument/2006/relationships" id="266" r:id="Rebe7ed8e510c423b"/>
-    <p:sldId xmlns:r="http://schemas.openxmlformats.org/officeDocument/2006/relationships" id="267" r:id="R99b3503e37a543e2"/>
-    <p:sldId xmlns:r="http://schemas.openxmlformats.org/officeDocument/2006/relationships" id="268" r:id="R82b233d5fff44d63"/>
-    <p:sldId xmlns:r="http://schemas.openxmlformats.org/officeDocument/2006/relationships" id="269" r:id="Re7cd5c1eb7a94438"/>
-    <p:sldId xmlns:r="http://schemas.openxmlformats.org/officeDocument/2006/relationships" id="270" r:id="R96a78c2794634741"/>
-    <p:sldId xmlns:r="http://schemas.openxmlformats.org/officeDocument/2006/relationships" id="271" r:id="R8eaa4f1817114c3b"/>
-    <p:sldId xmlns:r="http://schemas.openxmlformats.org/officeDocument/2006/relationships" id="272" r:id="Rb379b4ec3a30463e"/>
-    <p:sldId xmlns:r="http://schemas.openxmlformats.org/officeDocument/2006/relationships" id="273" r:id="R6b1d27364829408e"/>
-    <p:sldId xmlns:r="http://schemas.openxmlformats.org/officeDocument/2006/relationships" id="274" r:id="Rf07279f27b01490d"/>
+    <p:sldId xmlns:r="http://schemas.openxmlformats.org/officeDocument/2006/relationships" id="256" r:id="R98602ecb86c543b8"/>
+    <p:sldId xmlns:r="http://schemas.openxmlformats.org/officeDocument/2006/relationships" id="257" r:id="R546ce563cfec4224"/>
+    <p:sldId xmlns:r="http://schemas.openxmlformats.org/officeDocument/2006/relationships" id="258" r:id="R73707c76d1c3457d"/>
+    <p:sldId xmlns:r="http://schemas.openxmlformats.org/officeDocument/2006/relationships" id="259" r:id="R190e93c712a04cdd"/>
+    <p:sldId xmlns:r="http://schemas.openxmlformats.org/officeDocument/2006/relationships" id="260" r:id="Re5125d7df2cc40c7"/>
+    <p:sldId xmlns:r="http://schemas.openxmlformats.org/officeDocument/2006/relationships" id="261" r:id="Rbe949fda1c724fb2"/>
+    <p:sldId xmlns:r="http://schemas.openxmlformats.org/officeDocument/2006/relationships" id="262" r:id="R4d2ee66d24334136"/>
+    <p:sldId xmlns:r="http://schemas.openxmlformats.org/officeDocument/2006/relationships" id="263" r:id="R8965af6211624142"/>
+    <p:sldId xmlns:r="http://schemas.openxmlformats.org/officeDocument/2006/relationships" id="264" r:id="R3c3eb33768334926"/>
+    <p:sldId xmlns:r="http://schemas.openxmlformats.org/officeDocument/2006/relationships" id="265" r:id="Rc61e3033f8a94c84"/>
+    <p:sldId xmlns:r="http://schemas.openxmlformats.org/officeDocument/2006/relationships" id="266" r:id="R14086b4ee117426e"/>
+    <p:sldId xmlns:r="http://schemas.openxmlformats.org/officeDocument/2006/relationships" id="267" r:id="R859066b79b954e44"/>
+    <p:sldId xmlns:r="http://schemas.openxmlformats.org/officeDocument/2006/relationships" id="268" r:id="R2982779ab1b84b59"/>
+    <p:sldId xmlns:r="http://schemas.openxmlformats.org/officeDocument/2006/relationships" id="269" r:id="R172495b6f3934495"/>
+    <p:sldId xmlns:r="http://schemas.openxmlformats.org/officeDocument/2006/relationships" id="270" r:id="R92758199cf714a2c"/>
+    <p:sldId xmlns:r="http://schemas.openxmlformats.org/officeDocument/2006/relationships" id="271" r:id="Rf7058e2b701b42bc"/>
+    <p:sldId xmlns:r="http://schemas.openxmlformats.org/officeDocument/2006/relationships" id="272" r:id="Re43b822b4ddf42a5"/>
+    <p:sldId xmlns:r="http://schemas.openxmlformats.org/officeDocument/2006/relationships" id="273" r:id="R96d83d1940724a0e"/>
+    <p:sldId xmlns:r="http://schemas.openxmlformats.org/officeDocument/2006/relationships" id="274" r:id="R9a977624b6544f36"/>
   </p:sldIdLst>
   <p:sldSz cx="12192000" cy="6858000"/>
   <p:notesSz cx="6858000" cy="9144000"/>
@@ -1811,7 +1811,7 @@
   </p:cSld>
   <p:clrMap bg1="lt1" tx1="dk1" bg2="lt2" tx2="dk2" accent1="accent1" accent2="accent2" accent3="accent3" accent4="accent4" accent5="accent5" accent6="accent6" hlink="hlink" folHlink="folHlink"/>
   <p:sldLayoutIdLst>
-    <p:sldLayoutId xmlns:r="http://schemas.openxmlformats.org/officeDocument/2006/relationships" id="2147483649" r:id="R49dfaff3b6e84216"/>
+    <p:sldLayoutId xmlns:r="http://schemas.openxmlformats.org/officeDocument/2006/relationships" id="2147483649" r:id="Rff3c166415f7423a"/>
   </p:sldLayoutIdLst>
   <p:hf sldNum="0" hdr="0" ftr="0" dt="0"/>
   <p:txStyles>
@@ -2364,7 +2364,7 @@
     <p:bg>
       <p:bgPr>
         <a:blipFill xmlns:a="http://schemas.openxmlformats.org/drawingml/2006/main" rotWithShape="1">
-          <a:blip xmlns:r="http://schemas.openxmlformats.org/officeDocument/2006/relationships" r:embed="Rbef72ec11fb2425d">
+          <a:blip xmlns:r="http://schemas.openxmlformats.org/officeDocument/2006/relationships" r:embed="Rd334941427d24376">
             <a:lum/>
           </a:blip>
           <a:srcRect l="0" t="0" r="0" b="0"/>
@@ -2392,7 +2392,7 @@
           <p:nvPr/>
         </p:nvPicPr>
         <p:blipFill>
-          <a:blip xmlns:r="http://schemas.openxmlformats.org/officeDocument/2006/relationships" xmlns:a="http://schemas.openxmlformats.org/drawingml/2006/main" r:embed="R34b0ecc98b9b49f3"/>
+          <a:blip xmlns:r="http://schemas.openxmlformats.org/officeDocument/2006/relationships" xmlns:a="http://schemas.openxmlformats.org/drawingml/2006/main" r:embed="R5106e05c53984dd5"/>
           <a:stretch xmlns:a="http://schemas.openxmlformats.org/drawingml/2006/main">
             <a:fillRect l="0" t="0" r="0" b="0"/>
           </a:stretch>
@@ -2416,7 +2416,7 @@
           <p:nvPr/>
         </p:nvPicPr>
         <p:blipFill>
-          <a:blip xmlns:r="http://schemas.openxmlformats.org/officeDocument/2006/relationships" xmlns:a="http://schemas.openxmlformats.org/drawingml/2006/main" r:embed="R422404e30c0d46a1"/>
+          <a:blip xmlns:r="http://schemas.openxmlformats.org/officeDocument/2006/relationships" xmlns:a="http://schemas.openxmlformats.org/drawingml/2006/main" r:embed="R5c66ace3870b44af"/>
           <a:stretch xmlns:a="http://schemas.openxmlformats.org/drawingml/2006/main">
             <a:fillRect l="0" t="0" r="0" b="0"/>
           </a:stretch>
@@ -2942,7 +2942,7 @@
           <p:nvPr/>
         </p:nvPicPr>
         <p:blipFill>
-          <a:blip xmlns:r="http://schemas.openxmlformats.org/officeDocument/2006/relationships" xmlns:a="http://schemas.openxmlformats.org/drawingml/2006/main" r:embed="R49826c0433184adf"/>
+          <a:blip xmlns:r="http://schemas.openxmlformats.org/officeDocument/2006/relationships" xmlns:a="http://schemas.openxmlformats.org/drawingml/2006/main" r:embed="R38a43a3f54b54ce8"/>
           <a:stretch xmlns:a="http://schemas.openxmlformats.org/drawingml/2006/main">
             <a:fillRect l="0" t="0" r="0" b="0"/>
           </a:stretch>
@@ -2966,7 +2966,7 @@
           <p:nvPr/>
         </p:nvPicPr>
         <p:blipFill>
-          <a:blip xmlns:r="http://schemas.openxmlformats.org/officeDocument/2006/relationships" xmlns:a="http://schemas.openxmlformats.org/drawingml/2006/main" r:embed="R1e12f6bddb1742bd"/>
+          <a:blip xmlns:r="http://schemas.openxmlformats.org/officeDocument/2006/relationships" xmlns:a="http://schemas.openxmlformats.org/drawingml/2006/main" r:embed="Rf287e5f54db24eb4"/>
           <a:stretch xmlns:a="http://schemas.openxmlformats.org/drawingml/2006/main">
             <a:fillRect l="0" t="0" r="0" b="0"/>
           </a:stretch>
@@ -3113,7 +3113,7 @@
           <p:nvPr/>
         </p:nvPicPr>
         <p:blipFill>
-          <a:blip xmlns:r="http://schemas.openxmlformats.org/officeDocument/2006/relationships" xmlns:a="http://schemas.openxmlformats.org/drawingml/2006/main" r:embed="Rdfbb3cfe1244413f"/>
+          <a:blip xmlns:r="http://schemas.openxmlformats.org/officeDocument/2006/relationships" xmlns:a="http://schemas.openxmlformats.org/drawingml/2006/main" r:embed="R247657a59bc34774"/>
           <a:stretch xmlns:a="http://schemas.openxmlformats.org/drawingml/2006/main">
             <a:fillRect l="0" t="0" r="0" b="0"/>
           </a:stretch>
@@ -3342,7 +3342,7 @@
           <p:nvPr/>
         </p:nvPicPr>
         <p:blipFill>
-          <a:blip xmlns:r="http://schemas.openxmlformats.org/officeDocument/2006/relationships" xmlns:a="http://schemas.openxmlformats.org/drawingml/2006/main" r:embed="Rd1fd29ef9b834415"/>
+          <a:blip xmlns:r="http://schemas.openxmlformats.org/officeDocument/2006/relationships" xmlns:a="http://schemas.openxmlformats.org/drawingml/2006/main" r:embed="R470f6decc32b4ede"/>
           <a:stretch xmlns:a="http://schemas.openxmlformats.org/drawingml/2006/main">
             <a:fillRect l="0" t="0" r="0" b="0"/>
           </a:stretch>
@@ -3366,7 +3366,7 @@
           <p:nvPr/>
         </p:nvPicPr>
         <p:blipFill>
-          <a:blip xmlns:r="http://schemas.openxmlformats.org/officeDocument/2006/relationships" xmlns:a="http://schemas.openxmlformats.org/drawingml/2006/main" r:embed="R7c4a2d6718994028"/>
+          <a:blip xmlns:r="http://schemas.openxmlformats.org/officeDocument/2006/relationships" xmlns:a="http://schemas.openxmlformats.org/drawingml/2006/main" r:embed="R12fe09fa0e9c4e32"/>
           <a:stretch xmlns:a="http://schemas.openxmlformats.org/drawingml/2006/main">
             <a:fillRect l="0" t="0" r="0" b="0"/>
           </a:stretch>
@@ -4212,7 +4212,7 @@
           <p:nvPr/>
         </p:nvPicPr>
         <p:blipFill>
-          <a:blip xmlns:r="http://schemas.openxmlformats.org/officeDocument/2006/relationships" xmlns:a="http://schemas.openxmlformats.org/drawingml/2006/main" r:embed="R901f316049154e19"/>
+          <a:blip xmlns:r="http://schemas.openxmlformats.org/officeDocument/2006/relationships" xmlns:a="http://schemas.openxmlformats.org/drawingml/2006/main" r:embed="R35ef7ba4e73d453a"/>
           <a:stretch xmlns:a="http://schemas.openxmlformats.org/drawingml/2006/main">
             <a:fillRect l="0" t="0" r="0" b="0"/>
           </a:stretch>
@@ -4236,7 +4236,7 @@
           <p:nvPr/>
         </p:nvPicPr>
         <p:blipFill>
-          <a:blip xmlns:r="http://schemas.openxmlformats.org/officeDocument/2006/relationships" xmlns:a="http://schemas.openxmlformats.org/drawingml/2006/main" r:embed="Rfc02a249bd584fcd"/>
+          <a:blip xmlns:r="http://schemas.openxmlformats.org/officeDocument/2006/relationships" xmlns:a="http://schemas.openxmlformats.org/drawingml/2006/main" r:embed="Re20bc8dd08c241ae"/>
           <a:stretch xmlns:a="http://schemas.openxmlformats.org/drawingml/2006/main">
             <a:fillRect l="0" t="0" r="0" b="0"/>
           </a:stretch>
@@ -4462,7 +4462,7 @@
           <p:nvPr/>
         </p:nvPicPr>
         <p:blipFill>
-          <a:blip xmlns:r="http://schemas.openxmlformats.org/officeDocument/2006/relationships" xmlns:a="http://schemas.openxmlformats.org/drawingml/2006/main" r:embed="R44e2457956114e80"/>
+          <a:blip xmlns:r="http://schemas.openxmlformats.org/officeDocument/2006/relationships" xmlns:a="http://schemas.openxmlformats.org/drawingml/2006/main" r:embed="R2736791a0f5a425e"/>
           <a:stretch xmlns:a="http://schemas.openxmlformats.org/drawingml/2006/main">
             <a:fillRect l="0" t="0" r="0" b="0"/>
           </a:stretch>
@@ -4539,7 +4539,7 @@
           <p:nvPr/>
         </p:nvPicPr>
         <p:blipFill>
-          <a:blip xmlns:r="http://schemas.openxmlformats.org/officeDocument/2006/relationships" xmlns:a="http://schemas.openxmlformats.org/drawingml/2006/main" r:embed="Rbcb574eb67684712"/>
+          <a:blip xmlns:r="http://schemas.openxmlformats.org/officeDocument/2006/relationships" xmlns:a="http://schemas.openxmlformats.org/drawingml/2006/main" r:embed="R2f19fa29ab904a46"/>
           <a:stretch xmlns:a="http://schemas.openxmlformats.org/drawingml/2006/main">
             <a:fillRect l="0" t="0" r="0" b="0"/>
           </a:stretch>
@@ -4616,7 +4616,7 @@
           <p:nvPr/>
         </p:nvPicPr>
         <p:blipFill>
-          <a:blip xmlns:r="http://schemas.openxmlformats.org/officeDocument/2006/relationships" xmlns:a="http://schemas.openxmlformats.org/drawingml/2006/main" r:embed="R1e292df40c344ff9"/>
+          <a:blip xmlns:r="http://schemas.openxmlformats.org/officeDocument/2006/relationships" xmlns:a="http://schemas.openxmlformats.org/drawingml/2006/main" r:embed="Rc8ba9022585d4fb3"/>
           <a:stretch xmlns:a="http://schemas.openxmlformats.org/drawingml/2006/main">
             <a:fillRect l="0" t="0" r="0" b="0"/>
           </a:stretch>
@@ -4693,7 +4693,7 @@
           <p:nvPr/>
         </p:nvPicPr>
         <p:blipFill>
-          <a:blip xmlns:r="http://schemas.openxmlformats.org/officeDocument/2006/relationships" xmlns:a="http://schemas.openxmlformats.org/drawingml/2006/main" r:embed="R805c940da95e47ee"/>
+          <a:blip xmlns:r="http://schemas.openxmlformats.org/officeDocument/2006/relationships" xmlns:a="http://schemas.openxmlformats.org/drawingml/2006/main" r:embed="Reb332f8e30ec4ccc"/>
           <a:stretch xmlns:a="http://schemas.openxmlformats.org/drawingml/2006/main">
             <a:fillRect l="0" t="0" r="0" b="0"/>
           </a:stretch>
@@ -4770,7 +4770,7 @@
           <p:nvPr/>
         </p:nvPicPr>
         <p:blipFill>
-          <a:blip xmlns:r="http://schemas.openxmlformats.org/officeDocument/2006/relationships" xmlns:a="http://schemas.openxmlformats.org/drawingml/2006/main" r:embed="R0d4aec285b95450b"/>
+          <a:blip xmlns:r="http://schemas.openxmlformats.org/officeDocument/2006/relationships" xmlns:a="http://schemas.openxmlformats.org/drawingml/2006/main" r:embed="R8298d8fc1ad24bd4"/>
           <a:stretch xmlns:a="http://schemas.openxmlformats.org/drawingml/2006/main">
             <a:fillRect l="0" t="0" r="0" b="0"/>
           </a:stretch>
@@ -4847,7 +4847,7 @@
           <p:nvPr/>
         </p:nvPicPr>
         <p:blipFill>
-          <a:blip xmlns:r="http://schemas.openxmlformats.org/officeDocument/2006/relationships" xmlns:a="http://schemas.openxmlformats.org/drawingml/2006/main" r:embed="R5b0a7950431c44ea"/>
+          <a:blip xmlns:r="http://schemas.openxmlformats.org/officeDocument/2006/relationships" xmlns:a="http://schemas.openxmlformats.org/drawingml/2006/main" r:embed="R323b4017b222410a"/>
           <a:stretch xmlns:a="http://schemas.openxmlformats.org/drawingml/2006/main">
             <a:fillRect l="0" t="0" r="0" b="0"/>
           </a:stretch>
@@ -4924,7 +4924,7 @@
           <p:nvPr/>
         </p:nvPicPr>
         <p:blipFill>
-          <a:blip xmlns:r="http://schemas.openxmlformats.org/officeDocument/2006/relationships" xmlns:a="http://schemas.openxmlformats.org/drawingml/2006/main" r:embed="Rfbeefe07e1d948b9"/>
+          <a:blip xmlns:r="http://schemas.openxmlformats.org/officeDocument/2006/relationships" xmlns:a="http://schemas.openxmlformats.org/drawingml/2006/main" r:embed="R4674103d888e4c95"/>
           <a:stretch xmlns:a="http://schemas.openxmlformats.org/drawingml/2006/main">
             <a:fillRect l="0" t="0" r="0" b="0"/>
           </a:stretch>
@@ -5204,7 +5204,7 @@
           <p:nvPr/>
         </p:nvPicPr>
         <p:blipFill>
-          <a:blip xmlns:r="http://schemas.openxmlformats.org/officeDocument/2006/relationships" xmlns:a="http://schemas.openxmlformats.org/drawingml/2006/main" r:embed="R154968f9b39945c1"/>
+          <a:blip xmlns:r="http://schemas.openxmlformats.org/officeDocument/2006/relationships" xmlns:a="http://schemas.openxmlformats.org/drawingml/2006/main" r:embed="R24da77f142da46fc"/>
           <a:stretch xmlns:a="http://schemas.openxmlformats.org/drawingml/2006/main">
             <a:fillRect l="0" t="0" r="0" b="0"/>
           </a:stretch>
@@ -5375,7 +5375,7 @@
           <p:nvPr/>
         </p:nvPicPr>
         <p:blipFill>
-          <a:blip xmlns:r="http://schemas.openxmlformats.org/officeDocument/2006/relationships" xmlns:a="http://schemas.openxmlformats.org/drawingml/2006/main" r:embed="Rd496af11b6fe4bc4"/>
+          <a:blip xmlns:r="http://schemas.openxmlformats.org/officeDocument/2006/relationships" xmlns:a="http://schemas.openxmlformats.org/drawingml/2006/main" r:embed="R06126efe62044d16"/>
           <a:stretch xmlns:a="http://schemas.openxmlformats.org/drawingml/2006/main">
             <a:fillRect l="0" t="0" r="0" b="0"/>
           </a:stretch>
@@ -5399,7 +5399,7 @@
           <p:nvPr/>
         </p:nvPicPr>
         <p:blipFill>
-          <a:blip xmlns:r="http://schemas.openxmlformats.org/officeDocument/2006/relationships" xmlns:a="http://schemas.openxmlformats.org/drawingml/2006/main" r:embed="R796b4ad6e8b640b1"/>
+          <a:blip xmlns:r="http://schemas.openxmlformats.org/officeDocument/2006/relationships" xmlns:a="http://schemas.openxmlformats.org/drawingml/2006/main" r:embed="Rfd028033c39f4298"/>
           <a:stretch xmlns:a="http://schemas.openxmlformats.org/drawingml/2006/main">
             <a:fillRect l="0" t="0" r="0" b="0"/>
           </a:stretch>
@@ -5546,7 +5546,7 @@
           <p:nvPr/>
         </p:nvPicPr>
         <p:blipFill>
-          <a:blip xmlns:r="http://schemas.openxmlformats.org/officeDocument/2006/relationships" xmlns:a="http://schemas.openxmlformats.org/drawingml/2006/main" r:embed="R618755da4e824644"/>
+          <a:blip xmlns:r="http://schemas.openxmlformats.org/officeDocument/2006/relationships" xmlns:a="http://schemas.openxmlformats.org/drawingml/2006/main" r:embed="Rdebad471c3e04766"/>
           <a:stretch xmlns:a="http://schemas.openxmlformats.org/drawingml/2006/main">
             <a:fillRect l="0" t="0" r="0" b="0"/>
           </a:stretch>
@@ -5775,7 +5775,7 @@
           <p:nvPr/>
         </p:nvPicPr>
         <p:blipFill>
-          <a:blip xmlns:r="http://schemas.openxmlformats.org/officeDocument/2006/relationships" xmlns:a="http://schemas.openxmlformats.org/drawingml/2006/main" r:embed="R526670ecbcc24d43"/>
+          <a:blip xmlns:r="http://schemas.openxmlformats.org/officeDocument/2006/relationships" xmlns:a="http://schemas.openxmlformats.org/drawingml/2006/main" r:embed="R07ffb13d81ec4ea5"/>
           <a:stretch xmlns:a="http://schemas.openxmlformats.org/drawingml/2006/main">
             <a:fillRect l="0" t="0" r="0" b="0"/>
           </a:stretch>
@@ -5799,7 +5799,7 @@
           <p:nvPr/>
         </p:nvPicPr>
         <p:blipFill>
-          <a:blip xmlns:r="http://schemas.openxmlformats.org/officeDocument/2006/relationships" xmlns:a="http://schemas.openxmlformats.org/drawingml/2006/main" r:embed="R0cc41c0ea2d64b76"/>
+          <a:blip xmlns:r="http://schemas.openxmlformats.org/officeDocument/2006/relationships" xmlns:a="http://schemas.openxmlformats.org/drawingml/2006/main" r:embed="R1b407f06ca0b4f61"/>
           <a:stretch xmlns:a="http://schemas.openxmlformats.org/drawingml/2006/main">
             <a:fillRect l="0" t="0" r="0" b="0"/>
           </a:stretch>
@@ -6639,7 +6639,7 @@
           <p:nvPr/>
         </p:nvPicPr>
         <p:blipFill>
-          <a:blip xmlns:r="http://schemas.openxmlformats.org/officeDocument/2006/relationships" xmlns:a="http://schemas.openxmlformats.org/drawingml/2006/main" r:embed="Raaf2c814c69b49f6"/>
+          <a:blip xmlns:r="http://schemas.openxmlformats.org/officeDocument/2006/relationships" xmlns:a="http://schemas.openxmlformats.org/drawingml/2006/main" r:embed="Rc155ed204f7f4dd4"/>
           <a:stretch xmlns:a="http://schemas.openxmlformats.org/drawingml/2006/main">
             <a:fillRect l="0" t="0" r="0" b="0"/>
           </a:stretch>
@@ -6663,7 +6663,7 @@
           <p:nvPr/>
         </p:nvPicPr>
         <p:blipFill>
-          <a:blip xmlns:r="http://schemas.openxmlformats.org/officeDocument/2006/relationships" xmlns:a="http://schemas.openxmlformats.org/drawingml/2006/main" r:embed="R8f2af0ce72d24cb2"/>
+          <a:blip xmlns:r="http://schemas.openxmlformats.org/officeDocument/2006/relationships" xmlns:a="http://schemas.openxmlformats.org/drawingml/2006/main" r:embed="R484ce9d140884485"/>
           <a:stretch xmlns:a="http://schemas.openxmlformats.org/drawingml/2006/main">
             <a:fillRect l="0" t="0" r="0" b="0"/>
           </a:stretch>
@@ -6810,7 +6810,7 @@
           <p:nvPr/>
         </p:nvPicPr>
         <p:blipFill>
-          <a:blip xmlns:r="http://schemas.openxmlformats.org/officeDocument/2006/relationships" xmlns:a="http://schemas.openxmlformats.org/drawingml/2006/main" r:embed="Rb010e930d6cc4b77"/>
+          <a:blip xmlns:r="http://schemas.openxmlformats.org/officeDocument/2006/relationships" xmlns:a="http://schemas.openxmlformats.org/drawingml/2006/main" r:embed="R1935f7bbce8b4bc8"/>
           <a:stretch xmlns:a="http://schemas.openxmlformats.org/drawingml/2006/main">
             <a:fillRect l="0" t="0" r="0" b="0"/>
           </a:stretch>
@@ -7032,7 +7032,7 @@
           <p:nvPr/>
         </p:nvPicPr>
         <p:blipFill>
-          <a:blip xmlns:r="http://schemas.openxmlformats.org/officeDocument/2006/relationships" xmlns:a="http://schemas.openxmlformats.org/drawingml/2006/main" r:embed="R8275741996c54ff8"/>
+          <a:blip xmlns:r="http://schemas.openxmlformats.org/officeDocument/2006/relationships" xmlns:a="http://schemas.openxmlformats.org/drawingml/2006/main" r:embed="R09a90ec18c64404b"/>
           <a:stretch xmlns:a="http://schemas.openxmlformats.org/drawingml/2006/main">
             <a:fillRect l="0" t="0" r="0" b="0"/>
           </a:stretch>
@@ -7056,7 +7056,7 @@
           <p:nvPr/>
         </p:nvPicPr>
         <p:blipFill>
-          <a:blip xmlns:r="http://schemas.openxmlformats.org/officeDocument/2006/relationships" xmlns:a="http://schemas.openxmlformats.org/drawingml/2006/main" r:embed="R72a756ece95b484d"/>
+          <a:blip xmlns:r="http://schemas.openxmlformats.org/officeDocument/2006/relationships" xmlns:a="http://schemas.openxmlformats.org/drawingml/2006/main" r:embed="R9c66614a135342b2"/>
           <a:stretch xmlns:a="http://schemas.openxmlformats.org/drawingml/2006/main">
             <a:fillRect l="0" t="0" r="0" b="0"/>
           </a:stretch>
@@ -7203,7 +7203,7 @@
           <p:nvPr/>
         </p:nvPicPr>
         <p:blipFill>
-          <a:blip xmlns:r="http://schemas.openxmlformats.org/officeDocument/2006/relationships" xmlns:a="http://schemas.openxmlformats.org/drawingml/2006/main" r:embed="R649fae8cd3ef476c"/>
+          <a:blip xmlns:r="http://schemas.openxmlformats.org/officeDocument/2006/relationships" xmlns:a="http://schemas.openxmlformats.org/drawingml/2006/main" r:embed="R15eae68ef9da4a51"/>
           <a:stretch xmlns:a="http://schemas.openxmlformats.org/drawingml/2006/main">
             <a:fillRect l="0" t="0" r="0" b="0"/>
           </a:stretch>
@@ -7432,7 +7432,7 @@
           <p:nvPr/>
         </p:nvPicPr>
         <p:blipFill>
-          <a:blip xmlns:r="http://schemas.openxmlformats.org/officeDocument/2006/relationships" xmlns:a="http://schemas.openxmlformats.org/drawingml/2006/main" r:embed="Ra84cc472d7b94757"/>
+          <a:blip xmlns:r="http://schemas.openxmlformats.org/officeDocument/2006/relationships" xmlns:a="http://schemas.openxmlformats.org/drawingml/2006/main" r:embed="R61897bf3fb494e38"/>
           <a:stretch xmlns:a="http://schemas.openxmlformats.org/drawingml/2006/main">
             <a:fillRect l="0" t="0" r="0" b="0"/>
           </a:stretch>
@@ -7456,7 +7456,7 @@
           <p:nvPr/>
         </p:nvPicPr>
         <p:blipFill>
-          <a:blip xmlns:r="http://schemas.openxmlformats.org/officeDocument/2006/relationships" xmlns:a="http://schemas.openxmlformats.org/drawingml/2006/main" r:embed="R3f5af150fc69464e"/>
+          <a:blip xmlns:r="http://schemas.openxmlformats.org/officeDocument/2006/relationships" xmlns:a="http://schemas.openxmlformats.org/drawingml/2006/main" r:embed="R698f7b9f6c9a4790"/>
           <a:stretch xmlns:a="http://schemas.openxmlformats.org/drawingml/2006/main">
             <a:fillRect l="0" t="0" r="0" b="0"/>
           </a:stretch>
@@ -7682,7 +7682,7 @@
           <p:nvPr/>
         </p:nvPicPr>
         <p:blipFill>
-          <a:blip xmlns:r="http://schemas.openxmlformats.org/officeDocument/2006/relationships" xmlns:a="http://schemas.openxmlformats.org/drawingml/2006/main" r:embed="Rcb3614886a9c49b9"/>
+          <a:blip xmlns:r="http://schemas.openxmlformats.org/officeDocument/2006/relationships" xmlns:a="http://schemas.openxmlformats.org/drawingml/2006/main" r:embed="R50d69842e9d442d4"/>
           <a:stretch xmlns:a="http://schemas.openxmlformats.org/drawingml/2006/main">
             <a:fillRect l="0" t="0" r="0" b="0"/>
           </a:stretch>
@@ -7759,7 +7759,7 @@
           <p:nvPr/>
         </p:nvPicPr>
         <p:blipFill>
-          <a:blip xmlns:r="http://schemas.openxmlformats.org/officeDocument/2006/relationships" xmlns:a="http://schemas.openxmlformats.org/drawingml/2006/main" r:embed="R01ca607bae8d4531"/>
+          <a:blip xmlns:r="http://schemas.openxmlformats.org/officeDocument/2006/relationships" xmlns:a="http://schemas.openxmlformats.org/drawingml/2006/main" r:embed="Re71b7aacbada47c7"/>
           <a:stretch xmlns:a="http://schemas.openxmlformats.org/drawingml/2006/main">
             <a:fillRect l="0" t="0" r="0" b="0"/>
           </a:stretch>
@@ -7836,7 +7836,7 @@
           <p:nvPr/>
         </p:nvPicPr>
         <p:blipFill>
-          <a:blip xmlns:r="http://schemas.openxmlformats.org/officeDocument/2006/relationships" xmlns:a="http://schemas.openxmlformats.org/drawingml/2006/main" r:embed="R84d6a237d19c4d51"/>
+          <a:blip xmlns:r="http://schemas.openxmlformats.org/officeDocument/2006/relationships" xmlns:a="http://schemas.openxmlformats.org/drawingml/2006/main" r:embed="R1646825fefcb4f80"/>
           <a:stretch xmlns:a="http://schemas.openxmlformats.org/drawingml/2006/main">
             <a:fillRect l="0" t="0" r="0" b="0"/>
           </a:stretch>
@@ -7913,7 +7913,7 @@
           <p:nvPr/>
         </p:nvPicPr>
         <p:blipFill>
-          <a:blip xmlns:r="http://schemas.openxmlformats.org/officeDocument/2006/relationships" xmlns:a="http://schemas.openxmlformats.org/drawingml/2006/main" r:embed="Reabf4d61b5e34459"/>
+          <a:blip xmlns:r="http://schemas.openxmlformats.org/officeDocument/2006/relationships" xmlns:a="http://schemas.openxmlformats.org/drawingml/2006/main" r:embed="R5095369124884cfa"/>
           <a:stretch xmlns:a="http://schemas.openxmlformats.org/drawingml/2006/main">
             <a:fillRect l="0" t="0" r="0" b="0"/>
           </a:stretch>
@@ -7990,7 +7990,7 @@
           <p:nvPr/>
         </p:nvPicPr>
         <p:blipFill>
-          <a:blip xmlns:r="http://schemas.openxmlformats.org/officeDocument/2006/relationships" xmlns:a="http://schemas.openxmlformats.org/drawingml/2006/main" r:embed="Rdccfd03e2ca44060"/>
+          <a:blip xmlns:r="http://schemas.openxmlformats.org/officeDocument/2006/relationships" xmlns:a="http://schemas.openxmlformats.org/drawingml/2006/main" r:embed="R3873125fb2f34467"/>
           <a:stretch xmlns:a="http://schemas.openxmlformats.org/drawingml/2006/main">
             <a:fillRect l="0" t="0" r="0" b="0"/>
           </a:stretch>
@@ -8067,7 +8067,7 @@
           <p:nvPr/>
         </p:nvPicPr>
         <p:blipFill>
-          <a:blip xmlns:r="http://schemas.openxmlformats.org/officeDocument/2006/relationships" xmlns:a="http://schemas.openxmlformats.org/drawingml/2006/main" r:embed="R0931c4987fc94c2e"/>
+          <a:blip xmlns:r="http://schemas.openxmlformats.org/officeDocument/2006/relationships" xmlns:a="http://schemas.openxmlformats.org/drawingml/2006/main" r:embed="R51ecd6c2cf3d4c23"/>
           <a:stretch xmlns:a="http://schemas.openxmlformats.org/drawingml/2006/main">
             <a:fillRect l="0" t="0" r="0" b="0"/>
           </a:stretch>
@@ -8144,7 +8144,7 @@
           <p:nvPr/>
         </p:nvPicPr>
         <p:blipFill>
-          <a:blip xmlns:r="http://schemas.openxmlformats.org/officeDocument/2006/relationships" xmlns:a="http://schemas.openxmlformats.org/drawingml/2006/main" r:embed="Rf5a94493eb8548f1"/>
+          <a:blip xmlns:r="http://schemas.openxmlformats.org/officeDocument/2006/relationships" xmlns:a="http://schemas.openxmlformats.org/drawingml/2006/main" r:embed="R26dcac8cb2214f45"/>
           <a:stretch xmlns:a="http://schemas.openxmlformats.org/drawingml/2006/main">
             <a:fillRect l="0" t="0" r="0" b="0"/>
           </a:stretch>
@@ -8424,7 +8424,7 @@
           <p:nvPr/>
         </p:nvPicPr>
         <p:blipFill>
-          <a:blip xmlns:r="http://schemas.openxmlformats.org/officeDocument/2006/relationships" xmlns:a="http://schemas.openxmlformats.org/drawingml/2006/main" r:embed="R82002edba13143c8"/>
+          <a:blip xmlns:r="http://schemas.openxmlformats.org/officeDocument/2006/relationships" xmlns:a="http://schemas.openxmlformats.org/drawingml/2006/main" r:embed="R813d479d83594322"/>
           <a:stretch xmlns:a="http://schemas.openxmlformats.org/drawingml/2006/main">
             <a:fillRect l="0" t="0" r="0" b="0"/>
           </a:stretch>
@@ -8602,7 +8602,7 @@
           <p:nvPr/>
         </p:nvPicPr>
         <p:blipFill>
-          <a:blip xmlns:r="http://schemas.openxmlformats.org/officeDocument/2006/relationships" xmlns:a="http://schemas.openxmlformats.org/drawingml/2006/main" r:embed="Ra16f19ab9b344fc2"/>
+          <a:blip xmlns:r="http://schemas.openxmlformats.org/officeDocument/2006/relationships" xmlns:a="http://schemas.openxmlformats.org/drawingml/2006/main" r:embed="R6a5b0c6713a64f9c"/>
           <a:stretch xmlns:a="http://schemas.openxmlformats.org/drawingml/2006/main">
             <a:fillRect l="0" t="0" r="0" b="0"/>
           </a:stretch>
@@ -8626,7 +8626,7 @@
           <p:nvPr/>
         </p:nvPicPr>
         <p:blipFill>
-          <a:blip xmlns:r="http://schemas.openxmlformats.org/officeDocument/2006/relationships" xmlns:a="http://schemas.openxmlformats.org/drawingml/2006/main" r:embed="R943132b1bbcf4a82"/>
+          <a:blip xmlns:r="http://schemas.openxmlformats.org/officeDocument/2006/relationships" xmlns:a="http://schemas.openxmlformats.org/drawingml/2006/main" r:embed="R4968a7c577cc4511"/>
           <a:stretch xmlns:a="http://schemas.openxmlformats.org/drawingml/2006/main">
             <a:fillRect l="0" t="0" r="0" b="0"/>
           </a:stretch>
@@ -9465,7 +9465,7 @@
           <p:nvPr/>
         </p:nvPicPr>
         <p:blipFill>
-          <a:blip xmlns:r="http://schemas.openxmlformats.org/officeDocument/2006/relationships" xmlns:a="http://schemas.openxmlformats.org/drawingml/2006/main" r:embed="R682825586216407b"/>
+          <a:blip xmlns:r="http://schemas.openxmlformats.org/officeDocument/2006/relationships" xmlns:a="http://schemas.openxmlformats.org/drawingml/2006/main" r:embed="R50b21c9aa0674a8b"/>
           <a:stretch xmlns:a="http://schemas.openxmlformats.org/drawingml/2006/main">
             <a:fillRect l="0" t="0" r="0" b="0"/>
           </a:stretch>
@@ -9489,7 +9489,7 @@
           <p:nvPr/>
         </p:nvPicPr>
         <p:blipFill>
-          <a:blip xmlns:r="http://schemas.openxmlformats.org/officeDocument/2006/relationships" xmlns:a="http://schemas.openxmlformats.org/drawingml/2006/main" r:embed="R1918962a47254aad"/>
+          <a:blip xmlns:r="http://schemas.openxmlformats.org/officeDocument/2006/relationships" xmlns:a="http://schemas.openxmlformats.org/drawingml/2006/main" r:embed="Ra2de8a0ef3ef44c1"/>
           <a:stretch xmlns:a="http://schemas.openxmlformats.org/drawingml/2006/main">
             <a:fillRect l="0" t="0" r="0" b="0"/>
           </a:stretch>
@@ -9636,7 +9636,7 @@
           <p:nvPr/>
         </p:nvPicPr>
         <p:blipFill>
-          <a:blip xmlns:r="http://schemas.openxmlformats.org/officeDocument/2006/relationships" xmlns:a="http://schemas.openxmlformats.org/drawingml/2006/main" r:embed="R1ffd4adf80674b28"/>
+          <a:blip xmlns:r="http://schemas.openxmlformats.org/officeDocument/2006/relationships" xmlns:a="http://schemas.openxmlformats.org/drawingml/2006/main" r:embed="R80a9f35cee704027"/>
           <a:stretch xmlns:a="http://schemas.openxmlformats.org/drawingml/2006/main">
             <a:fillRect l="0" t="0" r="0" b="0"/>
           </a:stretch>
@@ -9865,7 +9865,7 @@
           <p:nvPr/>
         </p:nvPicPr>
         <p:blipFill>
-          <a:blip xmlns:r="http://schemas.openxmlformats.org/officeDocument/2006/relationships" xmlns:a="http://schemas.openxmlformats.org/drawingml/2006/main" r:embed="R5ace2e95008b4ceb"/>
+          <a:blip xmlns:r="http://schemas.openxmlformats.org/officeDocument/2006/relationships" xmlns:a="http://schemas.openxmlformats.org/drawingml/2006/main" r:embed="R22193168426a4f2e"/>
           <a:stretch xmlns:a="http://schemas.openxmlformats.org/drawingml/2006/main">
             <a:fillRect l="0" t="0" r="0" b="0"/>
           </a:stretch>
@@ -9889,7 +9889,7 @@
           <p:nvPr/>
         </p:nvPicPr>
         <p:blipFill>
-          <a:blip xmlns:r="http://schemas.openxmlformats.org/officeDocument/2006/relationships" xmlns:a="http://schemas.openxmlformats.org/drawingml/2006/main" r:embed="R0756cd0aaa3740af"/>
+          <a:blip xmlns:r="http://schemas.openxmlformats.org/officeDocument/2006/relationships" xmlns:a="http://schemas.openxmlformats.org/drawingml/2006/main" r:embed="R2547d33392ff4abb"/>
           <a:stretch xmlns:a="http://schemas.openxmlformats.org/drawingml/2006/main">
             <a:fillRect l="0" t="0" r="0" b="0"/>
           </a:stretch>
@@ -10144,7 +10144,7 @@
           <p:nvPr/>
         </p:nvPicPr>
         <p:blipFill>
-          <a:blip xmlns:r="http://schemas.openxmlformats.org/officeDocument/2006/relationships" xmlns:a="http://schemas.openxmlformats.org/drawingml/2006/main" r:embed="R83147767613f43a5"/>
+          <a:blip xmlns:r="http://schemas.openxmlformats.org/officeDocument/2006/relationships" xmlns:a="http://schemas.openxmlformats.org/drawingml/2006/main" r:embed="R6342f405d3f4425f"/>
           <a:stretch xmlns:a="http://schemas.openxmlformats.org/drawingml/2006/main">
             <a:fillRect l="0" t="0" r="0" b="0"/>
           </a:stretch>
@@ -10214,7 +10214,7 @@
           <p:nvPr/>
         </p:nvPicPr>
         <p:blipFill>
-          <a:blip xmlns:r="http://schemas.openxmlformats.org/officeDocument/2006/relationships" xmlns:a="http://schemas.openxmlformats.org/drawingml/2006/main" r:embed="R12435fd2ea774bc4"/>
+          <a:blip xmlns:r="http://schemas.openxmlformats.org/officeDocument/2006/relationships" xmlns:a="http://schemas.openxmlformats.org/drawingml/2006/main" r:embed="R085a7d5fd4b542ec"/>
           <a:stretch xmlns:a="http://schemas.openxmlformats.org/drawingml/2006/main">
             <a:fillRect l="0" t="0" r="0" b="0"/>
           </a:stretch>
@@ -10284,7 +10284,7 @@
           <p:nvPr/>
         </p:nvPicPr>
         <p:blipFill>
-          <a:blip xmlns:r="http://schemas.openxmlformats.org/officeDocument/2006/relationships" xmlns:a="http://schemas.openxmlformats.org/drawingml/2006/main" r:embed="R665fdbf4f3ca48ab"/>
+          <a:blip xmlns:r="http://schemas.openxmlformats.org/officeDocument/2006/relationships" xmlns:a="http://schemas.openxmlformats.org/drawingml/2006/main" r:embed="Rdf099ab65f5c497c"/>
           <a:stretch xmlns:a="http://schemas.openxmlformats.org/drawingml/2006/main">
             <a:fillRect l="0" t="0" r="0" b="0"/>
           </a:stretch>
@@ -10354,7 +10354,7 @@
           <p:nvPr/>
         </p:nvPicPr>
         <p:blipFill>
-          <a:blip xmlns:r="http://schemas.openxmlformats.org/officeDocument/2006/relationships" xmlns:a="http://schemas.openxmlformats.org/drawingml/2006/main" r:embed="R1fb6733f9f044c1c"/>
+          <a:blip xmlns:r="http://schemas.openxmlformats.org/officeDocument/2006/relationships" xmlns:a="http://schemas.openxmlformats.org/drawingml/2006/main" r:embed="R72250a3c828d4bab"/>
           <a:stretch xmlns:a="http://schemas.openxmlformats.org/drawingml/2006/main">
             <a:fillRect l="0" t="0" r="0" b="0"/>
           </a:stretch>
@@ -10424,7 +10424,7 @@
           <p:nvPr/>
         </p:nvPicPr>
         <p:blipFill>
-          <a:blip xmlns:r="http://schemas.openxmlformats.org/officeDocument/2006/relationships" xmlns:a="http://schemas.openxmlformats.org/drawingml/2006/main" r:embed="R3ce94d8f1a224b20"/>
+          <a:blip xmlns:r="http://schemas.openxmlformats.org/officeDocument/2006/relationships" xmlns:a="http://schemas.openxmlformats.org/drawingml/2006/main" r:embed="Rccc7566f06094cf1"/>
           <a:stretch xmlns:a="http://schemas.openxmlformats.org/drawingml/2006/main">
             <a:fillRect l="0" t="0" r="0" b="0"/>
           </a:stretch>
@@ -10494,7 +10494,7 @@
           <p:nvPr/>
         </p:nvPicPr>
         <p:blipFill>
-          <a:blip xmlns:r="http://schemas.openxmlformats.org/officeDocument/2006/relationships" xmlns:a="http://schemas.openxmlformats.org/drawingml/2006/main" r:embed="R682ce87a81ec4244"/>
+          <a:blip xmlns:r="http://schemas.openxmlformats.org/officeDocument/2006/relationships" xmlns:a="http://schemas.openxmlformats.org/drawingml/2006/main" r:embed="Rfd95801a65cc45d6"/>
           <a:stretch xmlns:a="http://schemas.openxmlformats.org/drawingml/2006/main">
             <a:fillRect l="0" t="0" r="0" b="0"/>
           </a:stretch>
@@ -10564,7 +10564,7 @@
           <p:nvPr/>
         </p:nvPicPr>
         <p:blipFill>
-          <a:blip xmlns:r="http://schemas.openxmlformats.org/officeDocument/2006/relationships" xmlns:a="http://schemas.openxmlformats.org/drawingml/2006/main" r:embed="Rd4a14f3298254e34"/>
+          <a:blip xmlns:r="http://schemas.openxmlformats.org/officeDocument/2006/relationships" xmlns:a="http://schemas.openxmlformats.org/drawingml/2006/main" r:embed="R72207e06399440d3"/>
           <a:stretch xmlns:a="http://schemas.openxmlformats.org/drawingml/2006/main">
             <a:fillRect l="0" t="0" r="0" b="0"/>
           </a:stretch>
@@ -10698,7 +10698,7 @@
                 <a:ea typeface="Calibri"/>
                 <a:cs typeface="Calibri"/>
               </a:rPr>
-              <a:t>BUKTI YANG DIKUMPULKAN</a:t>
+              <a:t>PROYEK KELOMPOK</a:t>
             </a:r>
           </a:p>
           <a:p xmlns:a="http://schemas.openxmlformats.org/drawingml/2006/main">
@@ -10727,7 +10727,7 @@
                 <a:ea typeface="Calibri"/>
                 <a:cs typeface="Calibri"/>
               </a:rPr>
-              <a:t>Hasil mesin sendiri</a:t>
+              <a:t>Tim 3 orang</a:t>
             </a:r>
             <a:endParaRPr sz="1100"/>
           </a:p>
@@ -10776,7 +10776,7 @@
                 <a:ea typeface="Calibri"/>
                 <a:cs typeface="Calibri"/>
               </a:rPr>
-              <a:t>1. UI Cloud Notes dan catatan baru</a:t>
+              <a:t>Next.js menghubungkan UI dan API proyek</a:t>
             </a:r>
           </a:p>
           <a:p xmlns:a="http://schemas.openxmlformats.org/drawingml/2006/main">
@@ -10795,7 +10795,7 @@
                 <a:ea typeface="Calibri"/>
                 <a:cs typeface="Calibri"/>
               </a:rPr>
-              <a:t>2. Bukti /health, /ready, HTTP 400</a:t>
+              <a:t>Uji catatan baru serta status gagal</a:t>
             </a:r>
           </a:p>
           <a:p xmlns:a="http://schemas.openxmlformats.org/drawingml/2006/main">
@@ -10814,7 +10814,7 @@
                 <a:ea typeface="Calibri"/>
                 <a:cs typeface="Calibri"/>
               </a:rPr>
-              <a:t>3. 9 PASS dan build Next.js</a:t>
+              <a:t>Simpan bukti bila berguna</a:t>
             </a:r>
           </a:p>
           <a:p xmlns:a="http://schemas.openxmlformats.org/drawingml/2006/main">
@@ -10833,7 +10833,7 @@
                 <a:ea typeface="Calibri"/>
                 <a:cs typeface="Calibri"/>
               </a:rPr>
-              <a:t>4. Commit tanpa .env.local</a:t>
+              <a:t>Minggu 7 dan 14; tanpa nilai Lab 08</a:t>
             </a:r>
             <a:endParaRPr sz="1700"/>
           </a:p>
@@ -11081,7 +11081,7 @@
           <p:nvPr/>
         </p:nvPicPr>
         <p:blipFill>
-          <a:blip xmlns:r="http://schemas.openxmlformats.org/officeDocument/2006/relationships" xmlns:a="http://schemas.openxmlformats.org/drawingml/2006/main" r:embed="Rf174d7fedfd34fb7"/>
+          <a:blip xmlns:r="http://schemas.openxmlformats.org/officeDocument/2006/relationships" xmlns:a="http://schemas.openxmlformats.org/drawingml/2006/main" r:embed="R0a80aaa4338b4d56"/>
           <a:stretch xmlns:a="http://schemas.openxmlformats.org/drawingml/2006/main">
             <a:fillRect l="0" t="0" r="0" b="0"/>
           </a:stretch>
@@ -11105,7 +11105,7 @@
           <p:nvPr/>
         </p:nvPicPr>
         <p:blipFill>
-          <a:blip xmlns:r="http://schemas.openxmlformats.org/officeDocument/2006/relationships" xmlns:a="http://schemas.openxmlformats.org/drawingml/2006/main" r:embed="R75cc9338e32d4487"/>
+          <a:blip xmlns:r="http://schemas.openxmlformats.org/officeDocument/2006/relationships" xmlns:a="http://schemas.openxmlformats.org/drawingml/2006/main" r:embed="R17d5867824484fe0"/>
           <a:stretch xmlns:a="http://schemas.openxmlformats.org/drawingml/2006/main">
             <a:fillRect l="0" t="0" r="0" b="0"/>
           </a:stretch>
@@ -11939,7 +11939,7 @@
           <p:nvPr/>
         </p:nvPicPr>
         <p:blipFill>
-          <a:blip xmlns:r="http://schemas.openxmlformats.org/officeDocument/2006/relationships" xmlns:a="http://schemas.openxmlformats.org/drawingml/2006/main" r:embed="R7dbe4d3f106d4c1b"/>
+          <a:blip xmlns:r="http://schemas.openxmlformats.org/officeDocument/2006/relationships" xmlns:a="http://schemas.openxmlformats.org/drawingml/2006/main" r:embed="R763ab537f44344af"/>
           <a:stretch xmlns:a="http://schemas.openxmlformats.org/drawingml/2006/main">
             <a:fillRect l="0" t="0" r="0" b="0"/>
           </a:stretch>
@@ -11963,7 +11963,7 @@
           <p:nvPr/>
         </p:nvPicPr>
         <p:blipFill>
-          <a:blip xmlns:r="http://schemas.openxmlformats.org/officeDocument/2006/relationships" xmlns:a="http://schemas.openxmlformats.org/drawingml/2006/main" r:embed="Rfb9d000435ed4a50"/>
+          <a:blip xmlns:r="http://schemas.openxmlformats.org/officeDocument/2006/relationships" xmlns:a="http://schemas.openxmlformats.org/drawingml/2006/main" r:embed="R65e3f1eebad74f97"/>
           <a:stretch xmlns:a="http://schemas.openxmlformats.org/drawingml/2006/main">
             <a:fillRect l="0" t="0" r="0" b="0"/>
           </a:stretch>
@@ -12110,7 +12110,7 @@
           <p:nvPr/>
         </p:nvPicPr>
         <p:blipFill>
-          <a:blip xmlns:r="http://schemas.openxmlformats.org/officeDocument/2006/relationships" xmlns:a="http://schemas.openxmlformats.org/drawingml/2006/main" r:embed="R239ed9b7bb824f9c"/>
+          <a:blip xmlns:r="http://schemas.openxmlformats.org/officeDocument/2006/relationships" xmlns:a="http://schemas.openxmlformats.org/drawingml/2006/main" r:embed="R31fa8914647a4347"/>
           <a:stretch xmlns:a="http://schemas.openxmlformats.org/drawingml/2006/main">
             <a:fillRect l="0" t="0" r="0" b="0"/>
           </a:stretch>
@@ -12339,7 +12339,7 @@
           <p:nvPr/>
         </p:nvPicPr>
         <p:blipFill>
-          <a:blip xmlns:r="http://schemas.openxmlformats.org/officeDocument/2006/relationships" xmlns:a="http://schemas.openxmlformats.org/drawingml/2006/main" r:embed="R80928b2cde564cdd"/>
+          <a:blip xmlns:r="http://schemas.openxmlformats.org/officeDocument/2006/relationships" xmlns:a="http://schemas.openxmlformats.org/drawingml/2006/main" r:embed="Re396fae101544fc1"/>
           <a:stretch xmlns:a="http://schemas.openxmlformats.org/drawingml/2006/main">
             <a:fillRect l="0" t="0" r="0" b="0"/>
           </a:stretch>
@@ -12363,7 +12363,7 @@
           <p:nvPr/>
         </p:nvPicPr>
         <p:blipFill>
-          <a:blip xmlns:r="http://schemas.openxmlformats.org/officeDocument/2006/relationships" xmlns:a="http://schemas.openxmlformats.org/drawingml/2006/main" r:embed="R681750ee67834334"/>
+          <a:blip xmlns:r="http://schemas.openxmlformats.org/officeDocument/2006/relationships" xmlns:a="http://schemas.openxmlformats.org/drawingml/2006/main" r:embed="Rd35be0e9976a4515"/>
           <a:stretch xmlns:a="http://schemas.openxmlformats.org/drawingml/2006/main">
             <a:fillRect l="0" t="0" r="0" b="0"/>
           </a:stretch>
@@ -12589,7 +12589,7 @@
           <p:nvPr/>
         </p:nvPicPr>
         <p:blipFill>
-          <a:blip xmlns:r="http://schemas.openxmlformats.org/officeDocument/2006/relationships" xmlns:a="http://schemas.openxmlformats.org/drawingml/2006/main" r:embed="Rb3031082bc37476f"/>
+          <a:blip xmlns:r="http://schemas.openxmlformats.org/officeDocument/2006/relationships" xmlns:a="http://schemas.openxmlformats.org/drawingml/2006/main" r:embed="R9c40b3e2126f4757"/>
           <a:stretch xmlns:a="http://schemas.openxmlformats.org/drawingml/2006/main">
             <a:fillRect l="0" t="0" r="0" b="0"/>
           </a:stretch>
@@ -12666,7 +12666,7 @@
           <p:nvPr/>
         </p:nvPicPr>
         <p:blipFill>
-          <a:blip xmlns:r="http://schemas.openxmlformats.org/officeDocument/2006/relationships" xmlns:a="http://schemas.openxmlformats.org/drawingml/2006/main" r:embed="R64e41a0a5ed442b7"/>
+          <a:blip xmlns:r="http://schemas.openxmlformats.org/officeDocument/2006/relationships" xmlns:a="http://schemas.openxmlformats.org/drawingml/2006/main" r:embed="Rdf5894bf762f408c"/>
           <a:stretch xmlns:a="http://schemas.openxmlformats.org/drawingml/2006/main">
             <a:fillRect l="0" t="0" r="0" b="0"/>
           </a:stretch>
@@ -12743,7 +12743,7 @@
           <p:nvPr/>
         </p:nvPicPr>
         <p:blipFill>
-          <a:blip xmlns:r="http://schemas.openxmlformats.org/officeDocument/2006/relationships" xmlns:a="http://schemas.openxmlformats.org/drawingml/2006/main" r:embed="R4b6b8cdba6f44f63"/>
+          <a:blip xmlns:r="http://schemas.openxmlformats.org/officeDocument/2006/relationships" xmlns:a="http://schemas.openxmlformats.org/drawingml/2006/main" r:embed="Raba09443ce094e62"/>
           <a:stretch xmlns:a="http://schemas.openxmlformats.org/drawingml/2006/main">
             <a:fillRect l="0" t="0" r="0" b="0"/>
           </a:stretch>
@@ -12820,7 +12820,7 @@
           <p:nvPr/>
         </p:nvPicPr>
         <p:blipFill>
-          <a:blip xmlns:r="http://schemas.openxmlformats.org/officeDocument/2006/relationships" xmlns:a="http://schemas.openxmlformats.org/drawingml/2006/main" r:embed="R28823a229a6f4a13"/>
+          <a:blip xmlns:r="http://schemas.openxmlformats.org/officeDocument/2006/relationships" xmlns:a="http://schemas.openxmlformats.org/drawingml/2006/main" r:embed="Rb773582266cb462d"/>
           <a:stretch xmlns:a="http://schemas.openxmlformats.org/drawingml/2006/main">
             <a:fillRect l="0" t="0" r="0" b="0"/>
           </a:stretch>
@@ -12897,7 +12897,7 @@
           <p:nvPr/>
         </p:nvPicPr>
         <p:blipFill>
-          <a:blip xmlns:r="http://schemas.openxmlformats.org/officeDocument/2006/relationships" xmlns:a="http://schemas.openxmlformats.org/drawingml/2006/main" r:embed="R1f849d476760412e"/>
+          <a:blip xmlns:r="http://schemas.openxmlformats.org/officeDocument/2006/relationships" xmlns:a="http://schemas.openxmlformats.org/drawingml/2006/main" r:embed="R483509940dc748ac"/>
           <a:stretch xmlns:a="http://schemas.openxmlformats.org/drawingml/2006/main">
             <a:fillRect l="0" t="0" r="0" b="0"/>
           </a:stretch>
@@ -12974,7 +12974,7 @@
           <p:nvPr/>
         </p:nvPicPr>
         <p:blipFill>
-          <a:blip xmlns:r="http://schemas.openxmlformats.org/officeDocument/2006/relationships" xmlns:a="http://schemas.openxmlformats.org/drawingml/2006/main" r:embed="R9d6fc9e247c2407b"/>
+          <a:blip xmlns:r="http://schemas.openxmlformats.org/officeDocument/2006/relationships" xmlns:a="http://schemas.openxmlformats.org/drawingml/2006/main" r:embed="R6f2a6f346ff1458f"/>
           <a:stretch xmlns:a="http://schemas.openxmlformats.org/drawingml/2006/main">
             <a:fillRect l="0" t="0" r="0" b="0"/>
           </a:stretch>
@@ -13051,7 +13051,7 @@
           <p:nvPr/>
         </p:nvPicPr>
         <p:blipFill>
-          <a:blip xmlns:r="http://schemas.openxmlformats.org/officeDocument/2006/relationships" xmlns:a="http://schemas.openxmlformats.org/drawingml/2006/main" r:embed="R7021ca66dee242b6"/>
+          <a:blip xmlns:r="http://schemas.openxmlformats.org/officeDocument/2006/relationships" xmlns:a="http://schemas.openxmlformats.org/drawingml/2006/main" r:embed="R8ae294c481f04477"/>
           <a:stretch xmlns:a="http://schemas.openxmlformats.org/drawingml/2006/main">
             <a:fillRect l="0" t="0" r="0" b="0"/>
           </a:stretch>
@@ -13331,7 +13331,7 @@
           <p:nvPr/>
         </p:nvPicPr>
         <p:blipFill>
-          <a:blip xmlns:r="http://schemas.openxmlformats.org/officeDocument/2006/relationships" xmlns:a="http://schemas.openxmlformats.org/drawingml/2006/main" r:embed="Ra3e718af2d8c4c2b"/>
+          <a:blip xmlns:r="http://schemas.openxmlformats.org/officeDocument/2006/relationships" xmlns:a="http://schemas.openxmlformats.org/drawingml/2006/main" r:embed="R951ccb060eb04518"/>
           <a:stretch xmlns:a="http://schemas.openxmlformats.org/drawingml/2006/main">
             <a:fillRect l="0" t="0" r="0" b="0"/>
           </a:stretch>
@@ -13502,7 +13502,7 @@
           <p:nvPr/>
         </p:nvPicPr>
         <p:blipFill>
-          <a:blip xmlns:r="http://schemas.openxmlformats.org/officeDocument/2006/relationships" xmlns:a="http://schemas.openxmlformats.org/drawingml/2006/main" r:embed="R8d02ca7f5f4c4a8d"/>
+          <a:blip xmlns:r="http://schemas.openxmlformats.org/officeDocument/2006/relationships" xmlns:a="http://schemas.openxmlformats.org/drawingml/2006/main" r:embed="R14a7c46f8cf54860"/>
           <a:stretch xmlns:a="http://schemas.openxmlformats.org/drawingml/2006/main">
             <a:fillRect l="0" t="0" r="0" b="0"/>
           </a:stretch>
@@ -13526,7 +13526,7 @@
           <p:nvPr/>
         </p:nvPicPr>
         <p:blipFill>
-          <a:blip xmlns:r="http://schemas.openxmlformats.org/officeDocument/2006/relationships" xmlns:a="http://schemas.openxmlformats.org/drawingml/2006/main" r:embed="R183e1f5261bf48e2"/>
+          <a:blip xmlns:r="http://schemas.openxmlformats.org/officeDocument/2006/relationships" xmlns:a="http://schemas.openxmlformats.org/drawingml/2006/main" r:embed="R2834027c333c4da8"/>
           <a:stretch xmlns:a="http://schemas.openxmlformats.org/drawingml/2006/main">
             <a:fillRect l="0" t="0" r="0" b="0"/>
           </a:stretch>
@@ -13673,7 +13673,7 @@
           <p:nvPr/>
         </p:nvPicPr>
         <p:blipFill>
-          <a:blip xmlns:r="http://schemas.openxmlformats.org/officeDocument/2006/relationships" xmlns:a="http://schemas.openxmlformats.org/drawingml/2006/main" r:embed="R3664be2e0fe14e84"/>
+          <a:blip xmlns:r="http://schemas.openxmlformats.org/officeDocument/2006/relationships" xmlns:a="http://schemas.openxmlformats.org/drawingml/2006/main" r:embed="Rfda2f222ac524793"/>
           <a:stretch xmlns:a="http://schemas.openxmlformats.org/drawingml/2006/main">
             <a:fillRect l="0" t="0" r="0" b="0"/>
           </a:stretch>
@@ -13902,7 +13902,7 @@
           <p:nvPr/>
         </p:nvPicPr>
         <p:blipFill>
-          <a:blip xmlns:r="http://schemas.openxmlformats.org/officeDocument/2006/relationships" xmlns:a="http://schemas.openxmlformats.org/drawingml/2006/main" r:embed="Rcc34783981a2410c"/>
+          <a:blip xmlns:r="http://schemas.openxmlformats.org/officeDocument/2006/relationships" xmlns:a="http://schemas.openxmlformats.org/drawingml/2006/main" r:embed="R664e867c6c1e41f3"/>
           <a:stretch xmlns:a="http://schemas.openxmlformats.org/drawingml/2006/main">
             <a:fillRect l="0" t="0" r="0" b="0"/>
           </a:stretch>
@@ -13926,7 +13926,7 @@
           <p:nvPr/>
         </p:nvPicPr>
         <p:blipFill>
-          <a:blip xmlns:r="http://schemas.openxmlformats.org/officeDocument/2006/relationships" xmlns:a="http://schemas.openxmlformats.org/drawingml/2006/main" r:embed="Rd5ddd035c1434535"/>
+          <a:blip xmlns:r="http://schemas.openxmlformats.org/officeDocument/2006/relationships" xmlns:a="http://schemas.openxmlformats.org/drawingml/2006/main" r:embed="R204700106148406f"/>
           <a:stretch xmlns:a="http://schemas.openxmlformats.org/drawingml/2006/main">
             <a:fillRect l="0" t="0" r="0" b="0"/>
           </a:stretch>
@@ -14769,7 +14769,7 @@
           <p:nvPr/>
         </p:nvPicPr>
         <p:blipFill>
-          <a:blip xmlns:r="http://schemas.openxmlformats.org/officeDocument/2006/relationships" xmlns:a="http://schemas.openxmlformats.org/drawingml/2006/main" r:embed="Rb44db6e29cb644ed"/>
+          <a:blip xmlns:r="http://schemas.openxmlformats.org/officeDocument/2006/relationships" xmlns:a="http://schemas.openxmlformats.org/drawingml/2006/main" r:embed="R117e449046b14e83"/>
           <a:stretch xmlns:a="http://schemas.openxmlformats.org/drawingml/2006/main">
             <a:fillRect l="0" t="0" r="0" b="0"/>
           </a:stretch>
@@ -14793,7 +14793,7 @@
           <p:nvPr/>
         </p:nvPicPr>
         <p:blipFill>
-          <a:blip xmlns:r="http://schemas.openxmlformats.org/officeDocument/2006/relationships" xmlns:a="http://schemas.openxmlformats.org/drawingml/2006/main" r:embed="R04190d19551541b1"/>
+          <a:blip xmlns:r="http://schemas.openxmlformats.org/officeDocument/2006/relationships" xmlns:a="http://schemas.openxmlformats.org/drawingml/2006/main" r:embed="Rb3b999a5362e487a"/>
           <a:stretch xmlns:a="http://schemas.openxmlformats.org/drawingml/2006/main">
             <a:fillRect l="0" t="0" r="0" b="0"/>
           </a:stretch>
@@ -15019,7 +15019,7 @@
           <p:nvPr/>
         </p:nvPicPr>
         <p:blipFill>
-          <a:blip xmlns:r="http://schemas.openxmlformats.org/officeDocument/2006/relationships" xmlns:a="http://schemas.openxmlformats.org/drawingml/2006/main" r:embed="R997c2495c9774e5e"/>
+          <a:blip xmlns:r="http://schemas.openxmlformats.org/officeDocument/2006/relationships" xmlns:a="http://schemas.openxmlformats.org/drawingml/2006/main" r:embed="R941812bb85714c6c"/>
           <a:stretch xmlns:a="http://schemas.openxmlformats.org/drawingml/2006/main">
             <a:fillRect l="0" t="0" r="0" b="0"/>
           </a:stretch>
@@ -15096,7 +15096,7 @@
           <p:nvPr/>
         </p:nvPicPr>
         <p:blipFill>
-          <a:blip xmlns:r="http://schemas.openxmlformats.org/officeDocument/2006/relationships" xmlns:a="http://schemas.openxmlformats.org/drawingml/2006/main" r:embed="Rad77ff29d5db4f8d"/>
+          <a:blip xmlns:r="http://schemas.openxmlformats.org/officeDocument/2006/relationships" xmlns:a="http://schemas.openxmlformats.org/drawingml/2006/main" r:embed="R68f0480f92734d9f"/>
           <a:stretch xmlns:a="http://schemas.openxmlformats.org/drawingml/2006/main">
             <a:fillRect l="0" t="0" r="0" b="0"/>
           </a:stretch>
@@ -15173,7 +15173,7 @@
           <p:nvPr/>
         </p:nvPicPr>
         <p:blipFill>
-          <a:blip xmlns:r="http://schemas.openxmlformats.org/officeDocument/2006/relationships" xmlns:a="http://schemas.openxmlformats.org/drawingml/2006/main" r:embed="R768afcb7c3d44fcd"/>
+          <a:blip xmlns:r="http://schemas.openxmlformats.org/officeDocument/2006/relationships" xmlns:a="http://schemas.openxmlformats.org/drawingml/2006/main" r:embed="R0a0474f7bfc44890"/>
           <a:stretch xmlns:a="http://schemas.openxmlformats.org/drawingml/2006/main">
             <a:fillRect l="0" t="0" r="0" b="0"/>
           </a:stretch>
@@ -15250,7 +15250,7 @@
           <p:nvPr/>
         </p:nvPicPr>
         <p:blipFill>
-          <a:blip xmlns:r="http://schemas.openxmlformats.org/officeDocument/2006/relationships" xmlns:a="http://schemas.openxmlformats.org/drawingml/2006/main" r:embed="R868f888120f5442e"/>
+          <a:blip xmlns:r="http://schemas.openxmlformats.org/officeDocument/2006/relationships" xmlns:a="http://schemas.openxmlformats.org/drawingml/2006/main" r:embed="R8a88a61af456447c"/>
           <a:stretch xmlns:a="http://schemas.openxmlformats.org/drawingml/2006/main">
             <a:fillRect l="0" t="0" r="0" b="0"/>
           </a:stretch>
@@ -15327,7 +15327,7 @@
           <p:nvPr/>
         </p:nvPicPr>
         <p:blipFill>
-          <a:blip xmlns:r="http://schemas.openxmlformats.org/officeDocument/2006/relationships" xmlns:a="http://schemas.openxmlformats.org/drawingml/2006/main" r:embed="Rd02517da0ff542ea"/>
+          <a:blip xmlns:r="http://schemas.openxmlformats.org/officeDocument/2006/relationships" xmlns:a="http://schemas.openxmlformats.org/drawingml/2006/main" r:embed="Rdc8a816f44a149ec"/>
           <a:stretch xmlns:a="http://schemas.openxmlformats.org/drawingml/2006/main">
             <a:fillRect l="0" t="0" r="0" b="0"/>
           </a:stretch>
@@ -15404,7 +15404,7 @@
           <p:nvPr/>
         </p:nvPicPr>
         <p:blipFill>
-          <a:blip xmlns:r="http://schemas.openxmlformats.org/officeDocument/2006/relationships" xmlns:a="http://schemas.openxmlformats.org/drawingml/2006/main" r:embed="Red2be71f9b4b460e"/>
+          <a:blip xmlns:r="http://schemas.openxmlformats.org/officeDocument/2006/relationships" xmlns:a="http://schemas.openxmlformats.org/drawingml/2006/main" r:embed="R82c37628f8654ab4"/>
           <a:stretch xmlns:a="http://schemas.openxmlformats.org/drawingml/2006/main">
             <a:fillRect l="0" t="0" r="0" b="0"/>
           </a:stretch>
@@ -15481,7 +15481,7 @@
           <p:nvPr/>
         </p:nvPicPr>
         <p:blipFill>
-          <a:blip xmlns:r="http://schemas.openxmlformats.org/officeDocument/2006/relationships" xmlns:a="http://schemas.openxmlformats.org/drawingml/2006/main" r:embed="Rcfe8436f8562406b"/>
+          <a:blip xmlns:r="http://schemas.openxmlformats.org/officeDocument/2006/relationships" xmlns:a="http://schemas.openxmlformats.org/drawingml/2006/main" r:embed="R4aeb28ed675b44c7"/>
           <a:stretch xmlns:a="http://schemas.openxmlformats.org/drawingml/2006/main">
             <a:fillRect l="0" t="0" r="0" b="0"/>
           </a:stretch>
@@ -15761,7 +15761,7 @@
           <p:nvPr/>
         </p:nvPicPr>
         <p:blipFill>
-          <a:blip xmlns:r="http://schemas.openxmlformats.org/officeDocument/2006/relationships" xmlns:a="http://schemas.openxmlformats.org/drawingml/2006/main" r:embed="R854b0ff5d7214b73"/>
+          <a:blip xmlns:r="http://schemas.openxmlformats.org/officeDocument/2006/relationships" xmlns:a="http://schemas.openxmlformats.org/drawingml/2006/main" r:embed="R3e6e502954b844ed"/>
           <a:stretch xmlns:a="http://schemas.openxmlformats.org/drawingml/2006/main">
             <a:fillRect l="0" t="0" r="0" b="0"/>
           </a:stretch>
@@ -15939,7 +15939,7 @@
           <p:nvPr/>
         </p:nvPicPr>
         <p:blipFill>
-          <a:blip xmlns:r="http://schemas.openxmlformats.org/officeDocument/2006/relationships" xmlns:a="http://schemas.openxmlformats.org/drawingml/2006/main" r:embed="R3e020d6746f94cb7"/>
+          <a:blip xmlns:r="http://schemas.openxmlformats.org/officeDocument/2006/relationships" xmlns:a="http://schemas.openxmlformats.org/drawingml/2006/main" r:embed="Rc778249b02c043c0"/>
           <a:stretch xmlns:a="http://schemas.openxmlformats.org/drawingml/2006/main">
             <a:fillRect l="0" t="0" r="0" b="0"/>
           </a:stretch>
@@ -15963,7 +15963,7 @@
           <p:nvPr/>
         </p:nvPicPr>
         <p:blipFill>
-          <a:blip xmlns:r="http://schemas.openxmlformats.org/officeDocument/2006/relationships" xmlns:a="http://schemas.openxmlformats.org/drawingml/2006/main" r:embed="R89070d16fa57467c"/>
+          <a:blip xmlns:r="http://schemas.openxmlformats.org/officeDocument/2006/relationships" xmlns:a="http://schemas.openxmlformats.org/drawingml/2006/main" r:embed="Rc35610e4aca54d39"/>
           <a:stretch xmlns:a="http://schemas.openxmlformats.org/drawingml/2006/main">
             <a:fillRect l="0" t="0" r="0" b="0"/>
           </a:stretch>
@@ -16189,7 +16189,7 @@
           <p:nvPr/>
         </p:nvPicPr>
         <p:blipFill>
-          <a:blip xmlns:r="http://schemas.openxmlformats.org/officeDocument/2006/relationships" xmlns:a="http://schemas.openxmlformats.org/drawingml/2006/main" r:embed="R48fe01f292144eca"/>
+          <a:blip xmlns:r="http://schemas.openxmlformats.org/officeDocument/2006/relationships" xmlns:a="http://schemas.openxmlformats.org/drawingml/2006/main" r:embed="R55e84dc5a5de4dae"/>
           <a:stretch xmlns:a="http://schemas.openxmlformats.org/drawingml/2006/main">
             <a:fillRect l="0" t="0" r="0" b="0"/>
           </a:stretch>
@@ -16266,7 +16266,7 @@
           <p:nvPr/>
         </p:nvPicPr>
         <p:blipFill>
-          <a:blip xmlns:r="http://schemas.openxmlformats.org/officeDocument/2006/relationships" xmlns:a="http://schemas.openxmlformats.org/drawingml/2006/main" r:embed="R5d35612f53874a25"/>
+          <a:blip xmlns:r="http://schemas.openxmlformats.org/officeDocument/2006/relationships" xmlns:a="http://schemas.openxmlformats.org/drawingml/2006/main" r:embed="R10352de5c8df4b64"/>
           <a:stretch xmlns:a="http://schemas.openxmlformats.org/drawingml/2006/main">
             <a:fillRect l="0" t="0" r="0" b="0"/>
           </a:stretch>
@@ -16343,7 +16343,7 @@
           <p:nvPr/>
         </p:nvPicPr>
         <p:blipFill>
-          <a:blip xmlns:r="http://schemas.openxmlformats.org/officeDocument/2006/relationships" xmlns:a="http://schemas.openxmlformats.org/drawingml/2006/main" r:embed="R527abaf07834417f"/>
+          <a:blip xmlns:r="http://schemas.openxmlformats.org/officeDocument/2006/relationships" xmlns:a="http://schemas.openxmlformats.org/drawingml/2006/main" r:embed="R05ad354c07c34fd2"/>
           <a:stretch xmlns:a="http://schemas.openxmlformats.org/drawingml/2006/main">
             <a:fillRect l="0" t="0" r="0" b="0"/>
           </a:stretch>
@@ -16420,7 +16420,7 @@
           <p:nvPr/>
         </p:nvPicPr>
         <p:blipFill>
-          <a:blip xmlns:r="http://schemas.openxmlformats.org/officeDocument/2006/relationships" xmlns:a="http://schemas.openxmlformats.org/drawingml/2006/main" r:embed="R4a184552757246a7"/>
+          <a:blip xmlns:r="http://schemas.openxmlformats.org/officeDocument/2006/relationships" xmlns:a="http://schemas.openxmlformats.org/drawingml/2006/main" r:embed="R220f31b8e5d3447a"/>
           <a:stretch xmlns:a="http://schemas.openxmlformats.org/drawingml/2006/main">
             <a:fillRect l="0" t="0" r="0" b="0"/>
           </a:stretch>
@@ -16497,7 +16497,7 @@
           <p:nvPr/>
         </p:nvPicPr>
         <p:blipFill>
-          <a:blip xmlns:r="http://schemas.openxmlformats.org/officeDocument/2006/relationships" xmlns:a="http://schemas.openxmlformats.org/drawingml/2006/main" r:embed="R6a2cef702d624ac6"/>
+          <a:blip xmlns:r="http://schemas.openxmlformats.org/officeDocument/2006/relationships" xmlns:a="http://schemas.openxmlformats.org/drawingml/2006/main" r:embed="R19d491c03abe4fc0"/>
           <a:stretch xmlns:a="http://schemas.openxmlformats.org/drawingml/2006/main">
             <a:fillRect l="0" t="0" r="0" b="0"/>
           </a:stretch>
@@ -16574,7 +16574,7 @@
           <p:nvPr/>
         </p:nvPicPr>
         <p:blipFill>
-          <a:blip xmlns:r="http://schemas.openxmlformats.org/officeDocument/2006/relationships" xmlns:a="http://schemas.openxmlformats.org/drawingml/2006/main" r:embed="Rf67b65600d9b4d6c"/>
+          <a:blip xmlns:r="http://schemas.openxmlformats.org/officeDocument/2006/relationships" xmlns:a="http://schemas.openxmlformats.org/drawingml/2006/main" r:embed="Rc6c2f617fc954e02"/>
           <a:stretch xmlns:a="http://schemas.openxmlformats.org/drawingml/2006/main">
             <a:fillRect l="0" t="0" r="0" b="0"/>
           </a:stretch>
@@ -16651,7 +16651,7 @@
           <p:nvPr/>
         </p:nvPicPr>
         <p:blipFill>
-          <a:blip xmlns:r="http://schemas.openxmlformats.org/officeDocument/2006/relationships" xmlns:a="http://schemas.openxmlformats.org/drawingml/2006/main" r:embed="R464ab4f7c13f4d9a"/>
+          <a:blip xmlns:r="http://schemas.openxmlformats.org/officeDocument/2006/relationships" xmlns:a="http://schemas.openxmlformats.org/drawingml/2006/main" r:embed="R86fecf72a0d247c8"/>
           <a:stretch xmlns:a="http://schemas.openxmlformats.org/drawingml/2006/main">
             <a:fillRect l="0" t="0" r="0" b="0"/>
           </a:stretch>
@@ -16931,7 +16931,7 @@
           <p:nvPr/>
         </p:nvPicPr>
         <p:blipFill>
-          <a:blip xmlns:r="http://schemas.openxmlformats.org/officeDocument/2006/relationships" xmlns:a="http://schemas.openxmlformats.org/drawingml/2006/main" r:embed="R1e50667e76da4e10"/>
+          <a:blip xmlns:r="http://schemas.openxmlformats.org/officeDocument/2006/relationships" xmlns:a="http://schemas.openxmlformats.org/drawingml/2006/main" r:embed="Rf19fffc45aa748d0"/>
           <a:stretch xmlns:a="http://schemas.openxmlformats.org/drawingml/2006/main">
             <a:fillRect l="0" t="0" r="0" b="0"/>
           </a:stretch>

</xml_diff>

<commit_message>
Simplify local Lab 08 teaching flow and correct examples
</commit_message>
<xml_diff>
--- a/slides/LAB08_Cloud_Notes_Nextjs_Bukti_Live.pptx
+++ b/slides/LAB08_Cloud_Notes_Nextjs_Bukti_Live.pptx
@@ -6129,23 +6129,23 @@
         <p:txBody>
           <a:bodyPr xmlns:a="http://schemas.openxmlformats.org/drawingml/2006/main" wrap="square" lIns="0" tIns="0" rIns="0" bIns="0" anchor="ctr"/>
           <a:lstStyle xmlns:a="http://schemas.openxmlformats.org/drawingml/2006/main"/>
-          <a:p xmlns:a="http://schemas.openxmlformats.org/drawingml/2006/main">
-            <a:pPr marL="0" indent="0" algn="ctr">
-              <a:buNone/>
-            </a:pPr>
-            <a:r>
-              <a:rPr sz="900">
-                <a:solidFill>
-                  <a:srgbClr val="94A3B8"/>
-                </a:solidFill>
-                <a:latin typeface="Consolas"/>
-                <a:ea typeface="Consolas"/>
-                <a:cs typeface="Consolas"/>
-              </a:rPr>
-              <a:t>PowerShell dan runner</a:t>
-            </a:r>
-            <a:endParaRPr sz="900"/>
-          </a:p>
+          <ns0:p xmlns:ns0="http://schemas.openxmlformats.org/drawingml/2006/main">
+            <ns0:pPr marL="0" indent="0" algn="ctr">
+              <ns0:buNone/>
+            </ns0:pPr>
+            <ns0:r>
+              <ns0:rPr sz="900">
+                <ns0:solidFill>
+                  <ns0:srgbClr val="94A3B8"/>
+                </ns0:solidFill>
+                <ns0:latin typeface="Consolas"/>
+                <ns0:ea typeface="Consolas"/>
+                <ns0:cs typeface="Consolas"/>
+              </ns0:rPr>
+              <ns0:t>Terminal 3: input salah, lalu build</ns0:t>
+            </ns0:r>
+            <ns0:endParaRPr sz="900"/>
+          </ns0:p>
         </p:txBody>
       </p:sp>
       <p:sp>
@@ -6175,40 +6175,249 @@
         <p:txBody>
           <a:bodyPr xmlns:a="http://schemas.openxmlformats.org/drawingml/2006/main" wrap="square" lIns="0" tIns="0" rIns="0" bIns="0" anchor="t"/>
           <a:lstStyle xmlns:a="http://schemas.openxmlformats.org/drawingml/2006/main"/>
-          <a:p xmlns:a="http://schemas.openxmlformats.org/drawingml/2006/main">
-            <a:pPr marL="0" indent="0">
-              <a:spcAft>
-                <a:spcPts val="200"/>
-              </a:spcAft>
-              <a:buNone/>
-            </a:pPr>
-            <a:r>
-              <a:rPr sz="1500">
-                <a:solidFill>
-                  <a:srgbClr val="FFFFFF"/>
-                </a:solidFill>
-                <a:latin typeface="Consolas"/>
-                <a:ea typeface="Consolas"/>
-                <a:cs typeface="Consolas"/>
-              </a:rPr>
-              <a:t>Invoke-WebRequest `
-  http://127.0.0.1:3000/api/notes `
-  -Method Post -ContentType application/json `
-  -Body '{"content":"tanpa judul"}'
-# PowerShell menampilkan error HTTP 400.
-npm run check:local
-npm run typecheck
-npm run build</a:t>
-            </a:r>
-            <a:endParaRPr sz="1500">
-              <a:solidFill>
-                <a:srgbClr val="FFFFFF"/>
-              </a:solidFill>
-              <a:latin typeface="Consolas"/>
-              <a:ea typeface="Consolas"/>
-              <a:cs typeface="Consolas"/>
-            </a:endParaRPr>
-          </a:p>
+          <ns0:p xmlns:ns0="http://schemas.openxmlformats.org/drawingml/2006/main">
+            <ns0:pPr marL="0" indent="0">
+              <ns0:spcAft>
+                <ns0:spcPts val="200"/>
+              </ns0:spcAft>
+              <ns0:buNone/>
+            </ns0:pPr>
+            <ns0:r>
+              <ns0:rPr sz="1500">
+                <ns0:solidFill>
+                  <ns0:srgbClr val="F8FAFC"/>
+                </ns0:solidFill>
+                <ns0:latin typeface="Consolas"/>
+                <ns0:ea typeface="Consolas"/>
+                <ns0:cs typeface="Consolas"/>
+              </ns0:rPr>
+              <ns0:t>'{"content":"tanpa judul"}' |</ns0:t>
+            </ns0:r>
+            <ns0:endParaRPr sz="1500">
+              <ns0:solidFill>
+                <ns0:srgbClr val="FFFFFF"/>
+              </ns0:solidFill>
+              <ns0:latin typeface="Consolas"/>
+              <ns0:ea typeface="Consolas"/>
+              <ns0:cs typeface="Consolas"/>
+            </ns0:endParaRPr>
+          </ns0:p>
+          <ns1:p xmlns:ns1="http://schemas.openxmlformats.org/drawingml/2006/main">
+            <ns1:pPr marL="0" indent="0">
+              <ns1:spcAft>
+                <ns1:spcPts val="200"/>
+              </ns1:spcAft>
+              <ns1:buNone/>
+            </ns1:pPr>
+            <ns1:r>
+              <ns1:rPr sz="1500">
+                <ns1:solidFill>
+                  <ns1:srgbClr val="F8FAFC"/>
+                </ns1:solidFill>
+                <ns1:latin typeface="Consolas"/>
+                <ns1:ea typeface="Consolas"/>
+                <ns1:cs typeface="Consolas"/>
+              </ns1:rPr>
+              <ns1:t>  curl.exe -i http://localhost:3000/api/notes `</ns1:t>
+            </ns1:r>
+            <ns1:endParaRPr sz="1500">
+              <ns1:solidFill>
+                <ns1:srgbClr val="FFFFFF"/>
+              </ns1:solidFill>
+              <ns1:latin typeface="Consolas"/>
+              <ns1:ea typeface="Consolas"/>
+              <ns1:cs typeface="Consolas"/>
+            </ns1:endParaRPr>
+          </ns1:p>
+          <ns2:p xmlns:ns2="http://schemas.openxmlformats.org/drawingml/2006/main">
+            <ns2:pPr marL="0" indent="0">
+              <ns2:spcAft>
+                <ns2:spcPts val="200"/>
+              </ns2:spcAft>
+              <ns2:buNone/>
+            </ns2:pPr>
+            <ns2:r>
+              <ns2:rPr sz="1500">
+                <ns2:solidFill>
+                  <ns2:srgbClr val="F8FAFC"/>
+                </ns2:solidFill>
+                <ns2:latin typeface="Consolas"/>
+                <ns2:ea typeface="Consolas"/>
+                <ns2:cs typeface="Consolas"/>
+              </ns2:rPr>
+              <ns2:t>  -H 'Content-Type: application/json' `</ns2:t>
+            </ns2:r>
+            <ns2:endParaRPr sz="1500">
+              <ns2:solidFill>
+                <ns2:srgbClr val="FFFFFF"/>
+              </ns2:solidFill>
+              <ns2:latin typeface="Consolas"/>
+              <ns2:ea typeface="Consolas"/>
+              <ns2:cs typeface="Consolas"/>
+            </ns2:endParaRPr>
+          </ns2:p>
+          <ns3:p xmlns:ns3="http://schemas.openxmlformats.org/drawingml/2006/main">
+            <ns3:pPr marL="0" indent="0">
+              <ns3:spcAft>
+                <ns3:spcPts val="200"/>
+              </ns3:spcAft>
+              <ns3:buNone/>
+            </ns3:pPr>
+            <ns3:r>
+              <ns3:rPr sz="1500">
+                <ns3:solidFill>
+                  <ns3:srgbClr val="F8FAFC"/>
+                </ns3:solidFill>
+                <ns3:latin typeface="Consolas"/>
+                <ns3:ea typeface="Consolas"/>
+                <ns3:cs typeface="Consolas"/>
+              </ns3:rPr>
+              <ns3:t>  --data-binary '@-'</ns3:t>
+            </ns3:r>
+            <ns3:endParaRPr sz="1500">
+              <ns3:solidFill>
+                <ns3:srgbClr val="FFFFFF"/>
+              </ns3:solidFill>
+              <ns3:latin typeface="Consolas"/>
+              <ns3:ea typeface="Consolas"/>
+              <ns3:cs typeface="Consolas"/>
+            </ns3:endParaRPr>
+          </ns3:p>
+          <ns4:p xmlns:ns4="http://schemas.openxmlformats.org/drawingml/2006/main">
+            <ns4:pPr marL="0" indent="0">
+              <ns4:spcAft>
+                <ns4:spcPts val="200"/>
+              </ns4:spcAft>
+              <ns4:buNone/>
+            </ns4:pPr>
+            <ns4:r>
+              <ns4:rPr sz="1500">
+                <ns4:solidFill>
+                  <ns4:srgbClr val="F8FAFC"/>
+                </ns4:solidFill>
+                <ns4:latin typeface="Consolas"/>
+                <ns4:ea typeface="Consolas"/>
+                <ns4:cs typeface="Consolas"/>
+              </ns4:rPr>
+              <ns4:t># Hasil: HTTP 400.</ns4:t>
+            </ns4:r>
+            <ns4:endParaRPr sz="1500">
+              <ns4:solidFill>
+                <ns4:srgbClr val="FFFFFF"/>
+              </ns4:solidFill>
+              <ns4:latin typeface="Consolas"/>
+              <ns4:ea typeface="Consolas"/>
+              <ns4:cs typeface="Consolas"/>
+            </ns4:endParaRPr>
+          </ns4:p>
+          <ns5:p xmlns:ns5="http://schemas.openxmlformats.org/drawingml/2006/main">
+            <ns5:pPr marL="0" indent="0">
+              <ns5:spcAft>
+                <ns5:spcPts val="200"/>
+              </ns5:spcAft>
+              <ns5:buNone/>
+            </ns5:pPr>
+            <ns5:r>
+              <ns5:rPr sz="1500">
+                <ns5:solidFill>
+                  <ns5:srgbClr val="F8FAFC"/>
+                </ns5:solidFill>
+                <ns5:latin typeface="Consolas"/>
+                <ns5:ea typeface="Consolas"/>
+                <ns5:cs typeface="Consolas"/>
+              </ns5:rPr>
+              <ns5:t># Terminal 2: Ctrl+C, lalu:</ns5:t>
+            </ns5:r>
+            <ns5:endParaRPr sz="1500">
+              <ns5:solidFill>
+                <ns5:srgbClr val="FFFFFF"/>
+              </ns5:solidFill>
+              <ns5:latin typeface="Consolas"/>
+              <ns5:ea typeface="Consolas"/>
+              <ns5:cs typeface="Consolas"/>
+            </ns5:endParaRPr>
+          </ns5:p>
+          <ns6:p xmlns:ns6="http://schemas.openxmlformats.org/drawingml/2006/main">
+            <ns6:pPr marL="0" indent="0">
+              <ns6:spcAft>
+                <ns6:spcPts val="200"/>
+              </ns6:spcAft>
+              <ns6:buNone/>
+            </ns6:pPr>
+            <ns6:r>
+              <ns6:rPr sz="1500">
+                <ns6:solidFill>
+                  <ns6:srgbClr val="F8FAFC"/>
+                </ns6:solidFill>
+                <ns6:latin typeface="Consolas"/>
+                <ns6:ea typeface="Consolas"/>
+                <ns6:cs typeface="Consolas"/>
+              </ns6:rPr>
+              <ns6:t>npm run typecheck</ns6:t>
+            </ns6:r>
+            <ns6:endParaRPr sz="1500">
+              <ns6:solidFill>
+                <ns6:srgbClr val="FFFFFF"/>
+              </ns6:solidFill>
+              <ns6:latin typeface="Consolas"/>
+              <ns6:ea typeface="Consolas"/>
+              <ns6:cs typeface="Consolas"/>
+            </ns6:endParaRPr>
+          </ns6:p>
+          <ns7:p xmlns:ns7="http://schemas.openxmlformats.org/drawingml/2006/main">
+            <ns7:pPr marL="0" indent="0">
+              <ns7:spcAft>
+                <ns7:spcPts val="200"/>
+              </ns7:spcAft>
+              <ns7:buNone/>
+            </ns7:pPr>
+            <ns7:r>
+              <ns7:rPr sz="1500">
+                <ns7:solidFill>
+                  <ns7:srgbClr val="F8FAFC"/>
+                </ns7:solidFill>
+                <ns7:latin typeface="Consolas"/>
+                <ns7:ea typeface="Consolas"/>
+                <ns7:cs typeface="Consolas"/>
+              </ns7:rPr>
+              <ns7:t>npm run build</ns7:t>
+            </ns7:r>
+            <ns7:endParaRPr sz="1500">
+              <ns7:solidFill>
+                <ns7:srgbClr val="FFFFFF"/>
+              </ns7:solidFill>
+              <ns7:latin typeface="Consolas"/>
+              <ns7:ea typeface="Consolas"/>
+              <ns7:cs typeface="Consolas"/>
+            </ns7:endParaRPr>
+          </ns7:p>
+          <ns8:p xmlns:ns8="http://schemas.openxmlformats.org/drawingml/2006/main">
+            <ns8:pPr marL="0" indent="0">
+              <ns8:spcAft>
+                <ns8:spcPts val="200"/>
+              </ns8:spcAft>
+              <ns8:buNone/>
+            </ns8:pPr>
+            <ns8:r>
+              <ns8:rPr sz="1500">
+                <ns8:solidFill>
+                  <ns8:srgbClr val="F8FAFC"/>
+                </ns8:solidFill>
+                <ns8:latin typeface="Consolas"/>
+                <ns8:ea typeface="Consolas"/>
+                <ns8:cs typeface="Consolas"/>
+              </ns8:rPr>
+              <ns8:t># Checker opsional: npm run check:local</ns8:t>
+            </ns8:r>
+            <ns8:endParaRPr sz="1500">
+              <ns8:solidFill>
+                <ns8:srgbClr val="FFFFFF"/>
+              </ns8:solidFill>
+              <ns8:latin typeface="Consolas"/>
+              <ns8:ea typeface="Consolas"/>
+              <ns8:cs typeface="Consolas"/>
+            </ns8:endParaRPr>
+          </ns8:p>
         </p:txBody>
       </p:sp>
       <p:sp>
@@ -8699,23 +8908,23 @@
         <p:txBody>
           <a:bodyPr xmlns:a="http://schemas.openxmlformats.org/drawingml/2006/main" wrap="square" lIns="0" tIns="0" rIns="0" bIns="0" anchor="ctr"/>
           <a:lstStyle xmlns:a="http://schemas.openxmlformats.org/drawingml/2006/main"/>
-          <a:p xmlns:a="http://schemas.openxmlformats.org/drawingml/2006/main">
-            <a:pPr marL="0" indent="0" algn="ctr">
-              <a:buNone/>
-            </a:pPr>
-            <a:r>
-              <a:rPr sz="2200" b="1">
-                <a:solidFill>
-                  <a:srgbClr val="1976D2"/>
-                </a:solidFill>
-                <a:latin typeface="Calibri"/>
-                <a:ea typeface="Calibri"/>
-                <a:cs typeface="Calibri"/>
-              </a:rPr>
-              <a:t>5 | Push source dan opsi deploy</a:t>
-            </a:r>
-            <a:endParaRPr sz="2200"/>
-          </a:p>
+          <ns0:p xmlns:ns0="http://schemas.openxmlformats.org/drawingml/2006/main">
+            <ns0:pPr marL="0" indent="0" algn="ctr">
+              <ns0:buNone/>
+            </ns0:pPr>
+            <ns0:r>
+              <ns0:rPr sz="2200" b="1">
+                <ns0:solidFill>
+                  <ns0:srgbClr val="1976D2"/>
+                </ns0:solidFill>
+                <ns0:latin typeface="Calibri"/>
+                <ns0:ea typeface="Calibri"/>
+                <ns0:cs typeface="Calibri"/>
+              </ns0:rPr>
+              <ns0:t>Tambahan | Git dan deployment Vercel</ns0:t>
+            </ns0:r>
+            <ns0:endParaRPr sz="2200"/>
+          </ns0:p>
         </p:txBody>
       </p:sp>
       <p:sp>
@@ -11224,23 +11433,23 @@
         <p:txBody>
           <a:bodyPr xmlns:a="http://schemas.openxmlformats.org/drawingml/2006/main" wrap="square" lIns="0" tIns="0" rIns="0" bIns="0" anchor="ctr"/>
           <a:lstStyle xmlns:a="http://schemas.openxmlformats.org/drawingml/2006/main"/>
-          <a:p xmlns:a="http://schemas.openxmlformats.org/drawingml/2006/main">
-            <a:pPr marL="0" indent="0" algn="ctr">
-              <a:buNone/>
-            </a:pPr>
-            <a:r>
-              <a:rPr sz="1200" i="1">
-                <a:solidFill>
-                  <a:srgbClr val="64748B"/>
-                </a:solidFill>
-                <a:latin typeface="Calibri"/>
-                <a:ea typeface="Calibri"/>
-                <a:cs typeface="Calibri"/>
-              </a:rPr>
-              <a:t>Dua terminal pada dua repo yang terpisah</a:t>
-            </a:r>
-            <a:endParaRPr sz="1200"/>
-          </a:p>
+          <ns0:p xmlns:ns0="http://schemas.openxmlformats.org/drawingml/2006/main">
+            <ns0:pPr marL="0" indent="0" algn="ctr">
+              <ns0:buNone/>
+            </ns0:pPr>
+            <ns0:r>
+              <ns0:rPr sz="1200" i="1">
+                <ns0:solidFill>
+                  <ns0:srgbClr val="64748B"/>
+                </ns0:solidFill>
+                <ns0:latin typeface="Calibri"/>
+                <ns0:ea typeface="Calibri"/>
+                <ns0:cs typeface="Calibri"/>
+              </ns0:rPr>
+              <ns0:t>Terminal 1: backend; terminal 2: Next; terminal 3: request</ns0:t>
+            </ns0:r>
+            <ns0:endParaRPr sz="1200"/>
+          </ns0:p>
         </p:txBody>
       </p:sp>
       <p:sp>
@@ -11481,35 +11690,168 @@
         <p:txBody>
           <a:bodyPr xmlns:a="http://schemas.openxmlformats.org/drawingml/2006/main" wrap="square" lIns="0" tIns="0" rIns="0" bIns="0" anchor="t"/>
           <a:lstStyle xmlns:a="http://schemas.openxmlformats.org/drawingml/2006/main"/>
-          <a:p xmlns:a="http://schemas.openxmlformats.org/drawingml/2006/main">
-            <a:pPr marL="0" indent="0">
-              <a:spcAft>
-                <a:spcPts val="200"/>
-              </a:spcAft>
-              <a:buNone/>
-            </a:pPr>
-            <a:r>
-              <a:rPr sz="1500">
-                <a:solidFill>
-                  <a:srgbClr val="FFFFFF"/>
-                </a:solidFill>
-                <a:latin typeface="Consolas"/>
-                <a:ea typeface="Consolas"/>
-                <a:cs typeface="Consolas"/>
-              </a:rPr>
-              <a:t>docker compose up --build -d
-docker compose ps
-# API tersedia di 127.0.0.1:8000.</a:t>
-            </a:r>
-            <a:endParaRPr sz="1500">
-              <a:solidFill>
-                <a:srgbClr val="FFFFFF"/>
-              </a:solidFill>
-              <a:latin typeface="Consolas"/>
-              <a:ea typeface="Consolas"/>
-              <a:cs typeface="Consolas"/>
-            </a:endParaRPr>
-          </a:p>
+          <ns0:p xmlns:ns0="http://schemas.openxmlformats.org/drawingml/2006/main">
+            <ns0:pPr marL="0" indent="0">
+              <ns0:spcAft>
+                <ns0:spcPts val="200"/>
+              </ns0:spcAft>
+              <ns0:buNone/>
+            </ns0:pPr>
+            <ns0:r>
+              <ns0:rPr sz="1500">
+                <ns0:solidFill>
+                  <ns0:srgbClr val="F8FAFC"/>
+                </ns0:solidFill>
+                <ns0:latin typeface="Consolas"/>
+                <ns0:ea typeface="Consolas"/>
+                <ns0:cs typeface="Consolas"/>
+              </ns0:rPr>
+              <ns0:t># Clone/cd Lab 06 sesuai modul.</ns0:t>
+            </ns0:r>
+            <ns0:endParaRPr sz="1500">
+              <ns0:solidFill>
+                <ns0:srgbClr val="FFFFFF"/>
+              </ns0:solidFill>
+              <ns0:latin typeface="Consolas"/>
+              <ns0:ea typeface="Consolas"/>
+              <ns0:cs typeface="Consolas"/>
+            </ns0:endParaRPr>
+          </ns0:p>
+          <ns1:p xmlns:ns1="http://schemas.openxmlformats.org/drawingml/2006/main">
+            <ns1:pPr marL="0" indent="0">
+              <ns1:spcAft>
+                <ns1:spcPts val="200"/>
+              </ns1:spcAft>
+              <ns1:buNone/>
+            </ns1:pPr>
+            <ns1:r>
+              <ns1:rPr sz="1500">
+                <ns1:solidFill>
+                  <ns1:srgbClr val="F8FAFC"/>
+                </ns1:solidFill>
+                <ns1:latin typeface="Consolas"/>
+                <ns1:ea typeface="Consolas"/>
+                <ns1:cs typeface="Consolas"/>
+              </ns1:rPr>
+              <ns1:t>Copy-Item .\.env.example .\.env</ns1:t>
+            </ns1:r>
+            <ns1:endParaRPr sz="1500">
+              <ns1:solidFill>
+                <ns1:srgbClr val="FFFFFF"/>
+              </ns1:solidFill>
+              <ns1:latin typeface="Consolas"/>
+              <ns1:ea typeface="Consolas"/>
+              <ns1:cs typeface="Consolas"/>
+            </ns1:endParaRPr>
+          </ns1:p>
+          <ns2:p xmlns:ns2="http://schemas.openxmlformats.org/drawingml/2006/main">
+            <ns2:pPr marL="0" indent="0">
+              <ns2:spcAft>
+                <ns2:spcPts val="200"/>
+              </ns2:spcAft>
+              <ns2:buNone/>
+            </ns2:pPr>
+            <ns2:r>
+              <ns2:rPr sz="1500">
+                <ns2:solidFill>
+                  <ns2:srgbClr val="F8FAFC"/>
+                </ns2:solidFill>
+                <ns2:latin typeface="Consolas"/>
+                <ns2:ea typeface="Consolas"/>
+                <ns2:cs typeface="Consolas"/>
+              </ns2:rPr>
+              <ns2:t>docker compose up --build -d --wait</ns2:t>
+            </ns2:r>
+            <ns2:endParaRPr sz="1500">
+              <ns2:solidFill>
+                <ns2:srgbClr val="FFFFFF"/>
+              </ns2:solidFill>
+              <ns2:latin typeface="Consolas"/>
+              <ns2:ea typeface="Consolas"/>
+              <ns2:cs typeface="Consolas"/>
+            </ns2:endParaRPr>
+          </ns2:p>
+          <ns3:p xmlns:ns3="http://schemas.openxmlformats.org/drawingml/2006/main">
+            <ns3:pPr marL="0" indent="0">
+              <ns3:spcAft>
+                <ns3:spcPts val="200"/>
+              </ns3:spcAft>
+              <ns3:buNone/>
+            </ns3:pPr>
+            <ns3:r>
+              <ns3:rPr sz="1500">
+                <ns3:solidFill>
+                  <ns3:srgbClr val="F8FAFC"/>
+                </ns3:solidFill>
+                <ns3:latin typeface="Consolas"/>
+                <ns3:ea typeface="Consolas"/>
+                <ns3:cs typeface="Consolas"/>
+              </ns3:rPr>
+              <ns3:t>docker compose ps</ns3:t>
+            </ns3:r>
+            <ns3:endParaRPr sz="1500">
+              <ns3:solidFill>
+                <ns3:srgbClr val="FFFFFF"/>
+              </ns3:solidFill>
+              <ns3:latin typeface="Consolas"/>
+              <ns3:ea typeface="Consolas"/>
+              <ns3:cs typeface="Consolas"/>
+            </ns3:endParaRPr>
+          </ns3:p>
+          <ns4:p xmlns:ns4="http://schemas.openxmlformats.org/drawingml/2006/main">
+            <ns4:pPr marL="0" indent="0">
+              <ns4:spcAft>
+                <ns4:spcPts val="200"/>
+              </ns4:spcAft>
+              <ns4:buNone/>
+            </ns4:pPr>
+            <ns4:r>
+              <ns4:rPr sz="1500">
+                <ns4:solidFill>
+                  <ns4:srgbClr val="F8FAFC"/>
+                </ns4:solidFill>
+                <ns4:latin typeface="Consolas"/>
+                <ns4:ea typeface="Consolas"/>
+                <ns4:cs typeface="Consolas"/>
+              </ns4:rPr>
+              <ns4:t>curl.exe -i http://127.0.0.1:18006/health</ns4:t>
+            </ns4:r>
+            <ns4:endParaRPr sz="1500">
+              <ns4:solidFill>
+                <ns4:srgbClr val="FFFFFF"/>
+              </ns4:solidFill>
+              <ns4:latin typeface="Consolas"/>
+              <ns4:ea typeface="Consolas"/>
+              <ns4:cs typeface="Consolas"/>
+            </ns4:endParaRPr>
+          </ns4:p>
+          <ns5:p xmlns:ns5="http://schemas.openxmlformats.org/drawingml/2006/main">
+            <ns5:pPr marL="0" indent="0">
+              <ns5:spcAft>
+                <ns5:spcPts val="200"/>
+              </ns5:spcAft>
+              <ns5:buNone/>
+            </ns5:pPr>
+            <ns5:r>
+              <ns5:rPr sz="1500">
+                <ns5:solidFill>
+                  <ns5:srgbClr val="F8FAFC"/>
+                </ns5:solidFill>
+                <ns5:latin typeface="Consolas"/>
+                <ns5:ea typeface="Consolas"/>
+                <ns5:cs typeface="Consolas"/>
+              </ns5:rPr>
+              <ns5:t># Clone lama: pertahankan .env dan volume.</ns5:t>
+            </ns5:r>
+            <ns5:endParaRPr sz="1500">
+              <ns5:solidFill>
+                <ns5:srgbClr val="FFFFFF"/>
+              </ns5:solidFill>
+              <ns5:latin typeface="Consolas"/>
+              <ns5:ea typeface="Consolas"/>
+              <ns5:cs typeface="Consolas"/>
+            </ns5:endParaRPr>
+          </ns5:p>
         </p:txBody>
       </p:sp>
       <p:sp>
@@ -11750,37 +12092,168 @@
         <p:txBody>
           <a:bodyPr xmlns:a="http://schemas.openxmlformats.org/drawingml/2006/main" wrap="square" lIns="0" tIns="0" rIns="0" bIns="0" anchor="t"/>
           <a:lstStyle xmlns:a="http://schemas.openxmlformats.org/drawingml/2006/main"/>
-          <a:p xmlns:a="http://schemas.openxmlformats.org/drawingml/2006/main">
-            <a:pPr marL="0" indent="0">
-              <a:spcAft>
-                <a:spcPts val="200"/>
-              </a:spcAft>
-              <a:buNone/>
-            </a:pPr>
-            <a:r>
-              <a:rPr sz="1600">
-                <a:solidFill>
-                  <a:srgbClr val="FFFFFF"/>
-                </a:solidFill>
-                <a:latin typeface="Aptos"/>
-                <a:ea typeface="Aptos"/>
-                <a:cs typeface="Aptos"/>
-              </a:rPr>
-              <a:t>node --version  # minimal 22.0.0
-npm ci          # versi dari lockfile
-Copy-Item .env.example .env.local
-npm run dev
-# Buka http://localhost:3000.</a:t>
-            </a:r>
-            <a:endParaRPr sz="1600">
-              <a:solidFill>
-                <a:srgbClr val="FFFFFF"/>
-              </a:solidFill>
-              <a:latin typeface="Aptos"/>
-              <a:ea typeface="Aptos"/>
-              <a:cs typeface="Aptos"/>
-            </a:endParaRPr>
-          </a:p>
+          <ns0:p xmlns:ns0="http://schemas.openxmlformats.org/drawingml/2006/main">
+            <ns0:pPr marL="0" indent="0">
+              <ns0:spcAft>
+                <ns0:spcPts val="200"/>
+              </ns0:spcAft>
+              <ns0:buNone/>
+            </ns0:pPr>
+            <ns0:r>
+              <ns0:rPr sz="1600">
+                <ns0:solidFill>
+                  <ns0:srgbClr val="FFFFFF"/>
+                </ns0:solidFill>
+                <ns0:latin typeface="Aptos"/>
+                <ns0:ea typeface="Aptos"/>
+                <ns0:cs typeface="Aptos"/>
+              </ns0:rPr>
+              <ns0:t># Clone/cd Lab 08 sesuai modul.</ns0:t>
+            </ns0:r>
+            <ns0:endParaRPr sz="1600">
+              <ns0:solidFill>
+                <ns0:srgbClr val="FFFFFF"/>
+              </ns0:solidFill>
+              <ns0:latin typeface="Aptos"/>
+              <ns0:ea typeface="Aptos"/>
+              <ns0:cs typeface="Aptos"/>
+            </ns0:endParaRPr>
+          </ns0:p>
+          <ns1:p xmlns:ns1="http://schemas.openxmlformats.org/drawingml/2006/main">
+            <ns1:pPr marL="0" indent="0">
+              <ns1:spcAft>
+                <ns1:spcPts val="200"/>
+              </ns1:spcAft>
+              <ns1:buNone/>
+            </ns1:pPr>
+            <ns1:r>
+              <ns1:rPr sz="1600">
+                <ns1:solidFill>
+                  <ns1:srgbClr val="FFFFFF"/>
+                </ns1:solidFill>
+                <ns1:latin typeface="Aptos"/>
+                <ns1:ea typeface="Aptos"/>
+                <ns1:cs typeface="Aptos"/>
+              </ns1:rPr>
+              <ns1:t>node --version  # minimal 22</ns1:t>
+            </ns1:r>
+            <ns1:endParaRPr sz="1600">
+              <ns1:solidFill>
+                <ns1:srgbClr val="FFFFFF"/>
+              </ns1:solidFill>
+              <ns1:latin typeface="Aptos"/>
+              <ns1:ea typeface="Aptos"/>
+              <ns1:cs typeface="Aptos"/>
+            </ns1:endParaRPr>
+          </ns1:p>
+          <ns2:p xmlns:ns2="http://schemas.openxmlformats.org/drawingml/2006/main">
+            <ns2:pPr marL="0" indent="0">
+              <ns2:spcAft>
+                <ns2:spcPts val="200"/>
+              </ns2:spcAft>
+              <ns2:buNone/>
+            </ns2:pPr>
+            <ns2:r>
+              <ns2:rPr sz="1600">
+                <ns2:solidFill>
+                  <ns2:srgbClr val="FFFFFF"/>
+                </ns2:solidFill>
+                <ns2:latin typeface="Aptos"/>
+                <ns2:ea typeface="Aptos"/>
+                <ns2:cs typeface="Aptos"/>
+              </ns2:rPr>
+              <ns2:t>npm ci</ns2:t>
+            </ns2:r>
+            <ns2:endParaRPr sz="1600">
+              <ns2:solidFill>
+                <ns2:srgbClr val="FFFFFF"/>
+              </ns2:solidFill>
+              <ns2:latin typeface="Aptos"/>
+              <ns2:ea typeface="Aptos"/>
+              <ns2:cs typeface="Aptos"/>
+            </ns2:endParaRPr>
+          </ns2:p>
+          <ns3:p xmlns:ns3="http://schemas.openxmlformats.org/drawingml/2006/main">
+            <ns3:pPr marL="0" indent="0">
+              <ns3:spcAft>
+                <ns3:spcPts val="200"/>
+              </ns3:spcAft>
+              <ns3:buNone/>
+            </ns3:pPr>
+            <ns3:r>
+              <ns3:rPr sz="1600">
+                <ns3:solidFill>
+                  <ns3:srgbClr val="FFFFFF"/>
+                </ns3:solidFill>
+                <ns3:latin typeface="Aptos"/>
+                <ns3:ea typeface="Aptos"/>
+                <ns3:cs typeface="Aptos"/>
+              </ns3:rPr>
+              <ns3:t>Copy-Item .\.env.example .\.env.local</ns3:t>
+            </ns3:r>
+            <ns3:endParaRPr sz="1600">
+              <ns3:solidFill>
+                <ns3:srgbClr val="FFFFFF"/>
+              </ns3:solidFill>
+              <ns3:latin typeface="Aptos"/>
+              <ns3:ea typeface="Aptos"/>
+              <ns3:cs typeface="Aptos"/>
+            </ns3:endParaRPr>
+          </ns3:p>
+          <ns4:p xmlns:ns4="http://schemas.openxmlformats.org/drawingml/2006/main">
+            <ns4:pPr marL="0" indent="0">
+              <ns4:spcAft>
+                <ns4:spcPts val="200"/>
+              </ns4:spcAft>
+              <ns4:buNone/>
+            </ns4:pPr>
+            <ns4:r>
+              <ns4:rPr sz="1600">
+                <ns4:solidFill>
+                  <ns4:srgbClr val="FFFFFF"/>
+                </ns4:solidFill>
+                <ns4:latin typeface="Aptos"/>
+                <ns4:ea typeface="Aptos"/>
+                <ns4:cs typeface="Aptos"/>
+              </ns4:rPr>
+              <ns4:t>npm run dev</ns4:t>
+            </ns4:r>
+            <ns4:endParaRPr sz="1600">
+              <ns4:solidFill>
+                <ns4:srgbClr val="FFFFFF"/>
+              </ns4:solidFill>
+              <ns4:latin typeface="Aptos"/>
+              <ns4:ea typeface="Aptos"/>
+              <ns4:cs typeface="Aptos"/>
+            </ns4:endParaRPr>
+          </ns4:p>
+          <ns5:p xmlns:ns5="http://schemas.openxmlformats.org/drawingml/2006/main">
+            <ns5:pPr marL="0" indent="0">
+              <ns5:spcAft>
+                <ns5:spcPts val="200"/>
+              </ns5:spcAft>
+              <ns5:buNone/>
+            </ns5:pPr>
+            <ns5:r>
+              <ns5:rPr sz="1600">
+                <ns5:solidFill>
+                  <ns5:srgbClr val="FFFFFF"/>
+                </ns5:solidFill>
+                <ns5:latin typeface="Aptos"/>
+                <ns5:ea typeface="Aptos"/>
+                <ns5:cs typeface="Aptos"/>
+              </ns5:rPr>
+              <ns5:t># Biarkan berjalan; buka localhost:3000.</ns5:t>
+            </ns5:r>
+            <ns5:endParaRPr sz="1600">
+              <ns5:solidFill>
+                <ns5:srgbClr val="FFFFFF"/>
+              </ns5:solidFill>
+              <ns5:latin typeface="Aptos"/>
+              <ns5:ea typeface="Aptos"/>
+              <ns5:cs typeface="Aptos"/>
+            </ns5:endParaRPr>
+          </ns5:p>
         </p:txBody>
       </p:sp>
     </p:spTree>

</xml_diff>